<commit_message>
Added visualisation to presentation
</commit_message>
<xml_diff>
--- a/project_presentation.pptx
+++ b/project_presentation.pptx
@@ -5,14 +5,21 @@
     <p:sldMasterId id="2147483660" r:id="rId1"/>
   </p:sldMasterIdLst>
   <p:notesMasterIdLst>
-    <p:notesMasterId r:id="rId7"/>
+    <p:notesMasterId r:id="rId14"/>
   </p:notesMasterIdLst>
   <p:sldIdLst>
     <p:sldId id="256" r:id="rId2"/>
     <p:sldId id="257" r:id="rId3"/>
-    <p:sldId id="258" r:id="rId4"/>
-    <p:sldId id="259" r:id="rId5"/>
-    <p:sldId id="260" r:id="rId6"/>
+    <p:sldId id="261" r:id="rId4"/>
+    <p:sldId id="262" r:id="rId5"/>
+    <p:sldId id="263" r:id="rId6"/>
+    <p:sldId id="264" r:id="rId7"/>
+    <p:sldId id="266" r:id="rId8"/>
+    <p:sldId id="265" r:id="rId9"/>
+    <p:sldId id="267" r:id="rId10"/>
+    <p:sldId id="268" r:id="rId11"/>
+    <p:sldId id="259" r:id="rId12"/>
+    <p:sldId id="260" r:id="rId13"/>
   </p:sldIdLst>
   <p:sldSz cx="12192000" cy="6858000"/>
   <p:notesSz cx="6858000" cy="9144000"/>
@@ -122,8 +129,7 @@
 <file path=ppt/revisionInfo.xml><?xml version="1.0" encoding="utf-8"?>
 <p1510:revInfo xmlns:a="http://schemas.openxmlformats.org/drawingml/2006/main" xmlns:r="http://schemas.openxmlformats.org/officeDocument/2006/relationships" xmlns:p1510="http://schemas.microsoft.com/office/powerpoint/2015/10/main">
   <p1510:revLst>
-    <p1510:client id="{00000000-0000-0000-0000-000000000000}" v="91" dt="2026-10-12T12:01:03.483"/>
-    <p1510:client id="{F8533C95-F66D-3292-5E5A-788ECDC35F2F}" v="533" dt="2026-10-12T11:57:55.904"/>
+    <p1510:client id="{1D93DDD2-C351-F292-A442-9645DC35FA3A}" v="667" dt="2026-10-18T10:11:01.524"/>
   </p1510:revLst>
 </p1510:revInfo>
 </file>
@@ -209,7 +215,7 @@
           </a:lstStyle>
           <a:p>
             <a:fld id="{6D8E7CD1-BB82-4A33-80CC-AC765A6873D5}" type="datetimeFigureOut">
-              <a:t>10/12/2026</a:t>
+              <a:t>10/18/2026</a:t>
             </a:fld>
             <a:endParaRPr lang="en-US"/>
           </a:p>
@@ -585,102 +591,6 @@
 </p:notes>
 </file>
 
-<file path=ppt/notesSlides/notesSlide2.xml><?xml version="1.0" encoding="utf-8"?>
-<p:notes xmlns:a="http://schemas.openxmlformats.org/drawingml/2006/main" xmlns:r="http://schemas.openxmlformats.org/officeDocument/2006/relationships" xmlns:p="http://schemas.openxmlformats.org/presentationml/2006/main">
-  <p:cSld>
-    <p:spTree>
-      <p:nvGrpSpPr>
-        <p:cNvPr id="1" name=""/>
-        <p:cNvGrpSpPr/>
-        <p:nvPr/>
-      </p:nvGrpSpPr>
-      <p:grpSpPr>
-        <a:xfrm>
-          <a:off x="0" y="0"/>
-          <a:ext cx="0" cy="0"/>
-          <a:chOff x="0" y="0"/>
-          <a:chExt cx="0" cy="0"/>
-        </a:xfrm>
-      </p:grpSpPr>
-      <p:sp>
-        <p:nvSpPr>
-          <p:cNvPr id="2" name="Slide Image Placeholder 1"/>
-          <p:cNvSpPr>
-            <a:spLocks noGrp="1" noRot="1" noChangeAspect="1"/>
-          </p:cNvSpPr>
-          <p:nvPr>
-            <p:ph type="sldImg"/>
-          </p:nvPr>
-        </p:nvSpPr>
-        <p:spPr/>
-      </p:sp>
-      <p:sp>
-        <p:nvSpPr>
-          <p:cNvPr id="3" name="Notes Placeholder 2"/>
-          <p:cNvSpPr>
-            <a:spLocks noGrp="1"/>
-          </p:cNvSpPr>
-          <p:nvPr>
-            <p:ph type="body" idx="1"/>
-          </p:nvPr>
-        </p:nvSpPr>
-        <p:spPr/>
-        <p:txBody>
-          <a:bodyPr/>
-          <a:lstStyle/>
-          <a:p>
-            <a:r>
-              <a:rPr lang="en-US" dirty="0">
-                <a:ea typeface="Calibri"/>
-                <a:cs typeface="Calibri"/>
-              </a:rPr>
-              <a:t>A visual aid here might be </a:t>
-            </a:r>
-            <a:r>
-              <a:rPr lang="en-US" dirty="0" err="1">
-                <a:ea typeface="Calibri"/>
-                <a:cs typeface="Calibri"/>
-              </a:rPr>
-              <a:t>valuble</a:t>
-            </a:r>
-          </a:p>
-        </p:txBody>
-      </p:sp>
-      <p:sp>
-        <p:nvSpPr>
-          <p:cNvPr id="4" name="Slide Number Placeholder 3"/>
-          <p:cNvSpPr>
-            <a:spLocks noGrp="1"/>
-          </p:cNvSpPr>
-          <p:nvPr>
-            <p:ph type="sldNum" sz="quarter" idx="5"/>
-          </p:nvPr>
-        </p:nvSpPr>
-        <p:spPr/>
-        <p:txBody>
-          <a:bodyPr/>
-          <a:lstStyle/>
-          <a:p>
-            <a:fld id="{434AD733-1E14-4C90-AFE1-2EFAD68261BF}" type="slidenum">
-              <a:t>3</a:t>
-            </a:fld>
-            <a:endParaRPr lang="en-US"/>
-          </a:p>
-        </p:txBody>
-      </p:sp>
-    </p:spTree>
-    <p:extLst>
-      <p:ext uri="{BB962C8B-B14F-4D97-AF65-F5344CB8AC3E}">
-        <p14:creationId xmlns:p14="http://schemas.microsoft.com/office/powerpoint/2010/main" val="1979594597"/>
-      </p:ext>
-    </p:extLst>
-  </p:cSld>
-  <p:clrMapOvr>
-    <a:masterClrMapping/>
-  </p:clrMapOvr>
-</p:notes>
-</file>
-
 <file path=ppt/slideLayouts/slideLayout1.xml><?xml version="1.0" encoding="utf-8"?>
 <p:sldLayout xmlns:a="http://schemas.openxmlformats.org/drawingml/2006/main" xmlns:r="http://schemas.openxmlformats.org/officeDocument/2006/relationships" xmlns:p="http://schemas.openxmlformats.org/presentationml/2006/main" type="title" preserve="1">
   <p:cSld name="Title Slide">
@@ -812,7 +722,7 @@
           <a:p>
             <a:fld id="{846CE7D5-CF57-46EF-B807-FDD0502418D4}" type="datetimeFigureOut">
               <a:rPr lang="en-US" smtClean="0"/>
-              <a:t>10/12/2026</a:t>
+              <a:t>10/18/2026</a:t>
             </a:fld>
             <a:endParaRPr lang="en-US"/>
           </a:p>
@@ -982,7 +892,7 @@
           <a:p>
             <a:fld id="{846CE7D5-CF57-46EF-B807-FDD0502418D4}" type="datetimeFigureOut">
               <a:rPr lang="en-US" smtClean="0"/>
-              <a:t>10/12/2026</a:t>
+              <a:t>10/18/2026</a:t>
             </a:fld>
             <a:endParaRPr lang="en-US"/>
           </a:p>
@@ -1162,7 +1072,7 @@
           <a:p>
             <a:fld id="{846CE7D5-CF57-46EF-B807-FDD0502418D4}" type="datetimeFigureOut">
               <a:rPr lang="en-US" smtClean="0"/>
-              <a:t>10/12/2026</a:t>
+              <a:t>10/18/2026</a:t>
             </a:fld>
             <a:endParaRPr lang="en-US"/>
           </a:p>
@@ -1332,7 +1242,7 @@
           <a:p>
             <a:fld id="{846CE7D5-CF57-46EF-B807-FDD0502418D4}" type="datetimeFigureOut">
               <a:rPr lang="en-US" smtClean="0"/>
-              <a:t>10/12/2026</a:t>
+              <a:t>10/18/2026</a:t>
             </a:fld>
             <a:endParaRPr lang="en-US"/>
           </a:p>
@@ -1578,7 +1488,7 @@
           <a:p>
             <a:fld id="{846CE7D5-CF57-46EF-B807-FDD0502418D4}" type="datetimeFigureOut">
               <a:rPr lang="en-US" smtClean="0"/>
-              <a:t>10/12/2026</a:t>
+              <a:t>10/18/2026</a:t>
             </a:fld>
             <a:endParaRPr lang="en-US"/>
           </a:p>
@@ -1810,7 +1720,7 @@
           <a:p>
             <a:fld id="{846CE7D5-CF57-46EF-B807-FDD0502418D4}" type="datetimeFigureOut">
               <a:rPr lang="en-US" smtClean="0"/>
-              <a:t>10/12/2026</a:t>
+              <a:t>10/18/2026</a:t>
             </a:fld>
             <a:endParaRPr lang="en-US"/>
           </a:p>
@@ -2177,7 +2087,7 @@
           <a:p>
             <a:fld id="{846CE7D5-CF57-46EF-B807-FDD0502418D4}" type="datetimeFigureOut">
               <a:rPr lang="en-US" smtClean="0"/>
-              <a:t>10/12/2026</a:t>
+              <a:t>10/18/2026</a:t>
             </a:fld>
             <a:endParaRPr lang="en-US"/>
           </a:p>
@@ -2295,7 +2205,7 @@
           <a:p>
             <a:fld id="{846CE7D5-CF57-46EF-B807-FDD0502418D4}" type="datetimeFigureOut">
               <a:rPr lang="en-US" smtClean="0"/>
-              <a:t>10/12/2026</a:t>
+              <a:t>10/18/2026</a:t>
             </a:fld>
             <a:endParaRPr lang="en-US"/>
           </a:p>
@@ -2390,7 +2300,7 @@
           <a:p>
             <a:fld id="{846CE7D5-CF57-46EF-B807-FDD0502418D4}" type="datetimeFigureOut">
               <a:rPr lang="en-US" smtClean="0"/>
-              <a:t>10/12/2026</a:t>
+              <a:t>10/18/2026</a:t>
             </a:fld>
             <a:endParaRPr lang="en-US"/>
           </a:p>
@@ -2667,7 +2577,7 @@
           <a:p>
             <a:fld id="{846CE7D5-CF57-46EF-B807-FDD0502418D4}" type="datetimeFigureOut">
               <a:rPr lang="en-US" smtClean="0"/>
-              <a:t>10/12/2026</a:t>
+              <a:t>10/18/2026</a:t>
             </a:fld>
             <a:endParaRPr lang="en-US"/>
           </a:p>
@@ -2920,7 +2830,7 @@
           <a:p>
             <a:fld id="{846CE7D5-CF57-46EF-B807-FDD0502418D4}" type="datetimeFigureOut">
               <a:rPr lang="en-US" smtClean="0"/>
-              <a:t>10/12/2026</a:t>
+              <a:t>10/18/2026</a:t>
             </a:fld>
             <a:endParaRPr lang="en-US"/>
           </a:p>
@@ -3133,7 +3043,7 @@
           <a:p>
             <a:fld id="{846CE7D5-CF57-46EF-B807-FDD0502418D4}" type="datetimeFigureOut">
               <a:rPr lang="en-US" smtClean="0"/>
-              <a:t>10/12/2026</a:t>
+              <a:t>10/18/2026</a:t>
             </a:fld>
             <a:endParaRPr lang="en-US"/>
           </a:p>
@@ -3602,6 +3512,629 @@
 </p:sld>
 </file>
 
+<file path=ppt/slides/slide10.xml><?xml version="1.0" encoding="utf-8"?>
+<p:sld xmlns:a="http://schemas.openxmlformats.org/drawingml/2006/main" xmlns:r="http://schemas.openxmlformats.org/officeDocument/2006/relationships" xmlns:p="http://schemas.openxmlformats.org/presentationml/2006/main">
+  <p:cSld>
+    <p:spTree>
+      <p:nvGrpSpPr>
+        <p:cNvPr id="1" name="">
+          <a:extLst>
+            <a:ext uri="{FF2B5EF4-FFF2-40B4-BE49-F238E27FC236}">
+              <a16:creationId xmlns:a16="http://schemas.microsoft.com/office/drawing/2014/main" id="{F8B55D21-7405-62ED-0465-A2FF9D3234AF}"/>
+            </a:ext>
+          </a:extLst>
+        </p:cNvPr>
+        <p:cNvGrpSpPr/>
+        <p:nvPr/>
+      </p:nvGrpSpPr>
+      <p:grpSpPr>
+        <a:xfrm>
+          <a:off x="0" y="0"/>
+          <a:ext cx="0" cy="0"/>
+          <a:chOff x="0" y="0"/>
+          <a:chExt cx="0" cy="0"/>
+        </a:xfrm>
+      </p:grpSpPr>
+      <p:cxnSp>
+        <p:nvCxnSpPr>
+          <p:cNvPr id="4" name="Straight Arrow Connector 3">
+            <a:extLst>
+              <a:ext uri="{FF2B5EF4-FFF2-40B4-BE49-F238E27FC236}">
+                <a16:creationId xmlns:a16="http://schemas.microsoft.com/office/drawing/2014/main" id="{7AEC4199-E680-CB68-5AFC-742C9B10B94B}"/>
+              </a:ext>
+            </a:extLst>
+          </p:cNvPr>
+          <p:cNvCxnSpPr/>
+          <p:nvPr/>
+        </p:nvCxnSpPr>
+        <p:spPr>
+          <a:xfrm>
+            <a:off x="982250" y="4442794"/>
+            <a:ext cx="9882952" cy="15119"/>
+          </a:xfrm>
+          <a:prstGeom prst="straightConnector1">
+            <a:avLst/>
+          </a:prstGeom>
+        </p:spPr>
+        <p:style>
+          <a:lnRef idx="2">
+            <a:schemeClr val="accent1"/>
+          </a:lnRef>
+          <a:fillRef idx="0">
+            <a:schemeClr val="accent1"/>
+          </a:fillRef>
+          <a:effectRef idx="1">
+            <a:schemeClr val="accent1"/>
+          </a:effectRef>
+          <a:fontRef idx="minor">
+            <a:schemeClr val="tx1"/>
+          </a:fontRef>
+        </p:style>
+      </p:cxnSp>
+      <p:sp>
+        <p:nvSpPr>
+          <p:cNvPr id="5" name="TextBox 4">
+            <a:extLst>
+              <a:ext uri="{FF2B5EF4-FFF2-40B4-BE49-F238E27FC236}">
+                <a16:creationId xmlns:a16="http://schemas.microsoft.com/office/drawing/2014/main" id="{76E4CD54-50BF-C48C-58AA-5C4195BF7652}"/>
+              </a:ext>
+            </a:extLst>
+          </p:cNvPr>
+          <p:cNvSpPr txBox="1"/>
+          <p:nvPr/>
+        </p:nvSpPr>
+        <p:spPr>
+          <a:xfrm>
+            <a:off x="149604" y="272008"/>
+            <a:ext cx="5575575" cy="923330"/>
+          </a:xfrm>
+          <a:prstGeom prst="rect">
+            <a:avLst/>
+          </a:prstGeom>
+          <a:noFill/>
+        </p:spPr>
+        <p:txBody>
+          <a:bodyPr rot="0" spcFirstLastPara="0" vertOverflow="overflow" horzOverflow="overflow" vert="horz" wrap="square" lIns="91440" tIns="45720" rIns="91440" bIns="45720" numCol="1" spcCol="0" rtlCol="0" fromWordArt="0" anchor="t" anchorCtr="0" forceAA="0" compatLnSpc="1">
+            <a:prstTxWarp prst="textNoShape">
+              <a:avLst/>
+            </a:prstTxWarp>
+            <a:spAutoFit/>
+          </a:bodyPr>
+          <a:lstStyle/>
+          <a:p>
+            <a:r>
+              <a:rPr lang="en-US"/>
+              <a:t>Messages are encoded using a number inside the final interval.</a:t>
+            </a:r>
+          </a:p>
+          <a:p>
+            <a:endParaRPr lang="en-US" dirty="0"/>
+          </a:p>
+        </p:txBody>
+      </p:sp>
+      <p:sp>
+        <p:nvSpPr>
+          <p:cNvPr id="8" name="TextBox 7">
+            <a:extLst>
+              <a:ext uri="{FF2B5EF4-FFF2-40B4-BE49-F238E27FC236}">
+                <a16:creationId xmlns:a16="http://schemas.microsoft.com/office/drawing/2014/main" id="{3B169FDA-1A00-186B-D944-D45CDBF0F564}"/>
+              </a:ext>
+            </a:extLst>
+          </p:cNvPr>
+          <p:cNvSpPr txBox="1"/>
+          <p:nvPr/>
+        </p:nvSpPr>
+        <p:spPr>
+          <a:xfrm>
+            <a:off x="979988" y="4502084"/>
+            <a:ext cx="5575575" cy="369332"/>
+          </a:xfrm>
+          <a:prstGeom prst="rect">
+            <a:avLst/>
+          </a:prstGeom>
+          <a:noFill/>
+        </p:spPr>
+        <p:txBody>
+          <a:bodyPr rot="0" spcFirstLastPara="0" vertOverflow="overflow" horzOverflow="overflow" vert="horz" wrap="square" lIns="91440" tIns="45720" rIns="91440" bIns="45720" numCol="1" spcCol="0" rtlCol="0" fromWordArt="0" anchor="t" anchorCtr="0" forceAA="0" compatLnSpc="1">
+            <a:prstTxWarp prst="textNoShape">
+              <a:avLst/>
+            </a:prstTxWarp>
+            <a:spAutoFit/>
+          </a:bodyPr>
+          <a:lstStyle/>
+          <a:p>
+            <a:r>
+              <a:rPr lang="en-US"/>
+              <a:t>Interval: [0.36, 0.504)</a:t>
+            </a:r>
+            <a:endParaRPr lang="en-US" dirty="0"/>
+          </a:p>
+        </p:txBody>
+      </p:sp>
+      <p:sp>
+        <p:nvSpPr>
+          <p:cNvPr id="13" name="Rectangle 12">
+            <a:extLst>
+              <a:ext uri="{FF2B5EF4-FFF2-40B4-BE49-F238E27FC236}">
+                <a16:creationId xmlns:a16="http://schemas.microsoft.com/office/drawing/2014/main" id="{E8C13B3D-32F6-B55C-AC64-F3BDF9E44A7C}"/>
+              </a:ext>
+            </a:extLst>
+          </p:cNvPr>
+          <p:cNvSpPr/>
+          <p:nvPr/>
+        </p:nvSpPr>
+        <p:spPr>
+          <a:xfrm>
+            <a:off x="981336" y="4064212"/>
+            <a:ext cx="9860830" cy="379284"/>
+          </a:xfrm>
+          <a:prstGeom prst="rect">
+            <a:avLst/>
+          </a:prstGeom>
+          <a:solidFill>
+            <a:srgbClr val="6E2F0D"/>
+          </a:solidFill>
+          <a:ln>
+            <a:solidFill>
+              <a:srgbClr val="6E2F0D"/>
+            </a:solidFill>
+          </a:ln>
+        </p:spPr>
+        <p:style>
+          <a:lnRef idx="2">
+            <a:schemeClr val="accent1">
+              <a:shade val="15000"/>
+            </a:schemeClr>
+          </a:lnRef>
+          <a:fillRef idx="1">
+            <a:schemeClr val="accent1"/>
+          </a:fillRef>
+          <a:effectRef idx="0">
+            <a:schemeClr val="accent1"/>
+          </a:effectRef>
+          <a:fontRef idx="minor">
+            <a:schemeClr val="lt1"/>
+          </a:fontRef>
+        </p:style>
+        <p:txBody>
+          <a:bodyPr rtlCol="0" anchor="ctr"/>
+          <a:lstStyle/>
+          <a:p>
+            <a:pPr algn="ctr"/>
+            <a:r>
+              <a:rPr lang="en-US"/>
+              <a:t>D: 60%</a:t>
+            </a:r>
+          </a:p>
+        </p:txBody>
+      </p:sp>
+      <p:sp>
+        <p:nvSpPr>
+          <p:cNvPr id="11" name="TextBox 10">
+            <a:extLst>
+              <a:ext uri="{FF2B5EF4-FFF2-40B4-BE49-F238E27FC236}">
+                <a16:creationId xmlns:a16="http://schemas.microsoft.com/office/drawing/2014/main" id="{F540400F-DBCE-6C13-8D92-F6ECF7DA8AD2}"/>
+              </a:ext>
+            </a:extLst>
+          </p:cNvPr>
+          <p:cNvSpPr txBox="1"/>
+          <p:nvPr/>
+        </p:nvSpPr>
+        <p:spPr>
+          <a:xfrm>
+            <a:off x="638453" y="4066517"/>
+            <a:ext cx="676570" cy="369332"/>
+          </a:xfrm>
+          <a:prstGeom prst="rect">
+            <a:avLst/>
+          </a:prstGeom>
+          <a:noFill/>
+        </p:spPr>
+        <p:txBody>
+          <a:bodyPr rot="0" spcFirstLastPara="0" vertOverflow="overflow" horzOverflow="overflow" vert="horz" wrap="square" lIns="91440" tIns="45720" rIns="91440" bIns="45720" numCol="1" spcCol="0" rtlCol="0" fromWordArt="0" anchor="t" anchorCtr="0" forceAA="0" compatLnSpc="1">
+            <a:prstTxWarp prst="textNoShape">
+              <a:avLst/>
+            </a:prstTxWarp>
+            <a:spAutoFit/>
+          </a:bodyPr>
+          <a:lstStyle/>
+          <a:p>
+            <a:pPr algn="l"/>
+            <a:r>
+              <a:rPr lang="en-US"/>
+              <a:t>0.36</a:t>
+            </a:r>
+          </a:p>
+        </p:txBody>
+      </p:sp>
+      <p:sp>
+        <p:nvSpPr>
+          <p:cNvPr id="15" name="TextBox 14">
+            <a:extLst>
+              <a:ext uri="{FF2B5EF4-FFF2-40B4-BE49-F238E27FC236}">
+                <a16:creationId xmlns:a16="http://schemas.microsoft.com/office/drawing/2014/main" id="{751D1D87-FD6A-84F6-ADB1-F15E095A8458}"/>
+              </a:ext>
+            </a:extLst>
+          </p:cNvPr>
+          <p:cNvSpPr txBox="1"/>
+          <p:nvPr/>
+        </p:nvSpPr>
+        <p:spPr>
+          <a:xfrm>
+            <a:off x="10456530" y="4066517"/>
+            <a:ext cx="744954" cy="369332"/>
+          </a:xfrm>
+          <a:prstGeom prst="rect">
+            <a:avLst/>
+          </a:prstGeom>
+          <a:noFill/>
+        </p:spPr>
+        <p:txBody>
+          <a:bodyPr rot="0" spcFirstLastPara="0" vertOverflow="overflow" horzOverflow="overflow" vert="horz" wrap="square" lIns="91440" tIns="45720" rIns="91440" bIns="45720" numCol="1" spcCol="0" rtlCol="0" fromWordArt="0" anchor="t" anchorCtr="0" forceAA="0" compatLnSpc="1">
+            <a:prstTxWarp prst="textNoShape">
+              <a:avLst/>
+            </a:prstTxWarp>
+            <a:spAutoFit/>
+          </a:bodyPr>
+          <a:lstStyle/>
+          <a:p>
+            <a:pPr algn="l"/>
+            <a:r>
+              <a:rPr lang="en-US"/>
+              <a:t>0.504</a:t>
+            </a:r>
+          </a:p>
+        </p:txBody>
+      </p:sp>
+      <p:sp>
+        <p:nvSpPr>
+          <p:cNvPr id="3" name="TextBox 2">
+            <a:extLst>
+              <a:ext uri="{FF2B5EF4-FFF2-40B4-BE49-F238E27FC236}">
+                <a16:creationId xmlns:a16="http://schemas.microsoft.com/office/drawing/2014/main" id="{5AC3CC75-9F34-365E-D39F-12FC34F5C768}"/>
+              </a:ext>
+            </a:extLst>
+          </p:cNvPr>
+          <p:cNvSpPr txBox="1"/>
+          <p:nvPr/>
+        </p:nvSpPr>
+        <p:spPr>
+          <a:xfrm>
+            <a:off x="4747846" y="2901462"/>
+            <a:ext cx="2354385" cy="523220"/>
+          </a:xfrm>
+          <a:prstGeom prst="rect">
+            <a:avLst/>
+          </a:prstGeom>
+          <a:noFill/>
+        </p:spPr>
+        <p:txBody>
+          <a:bodyPr rot="0" spcFirstLastPara="0" vertOverflow="overflow" horzOverflow="overflow" vert="horz" wrap="square" lIns="91440" tIns="45720" rIns="91440" bIns="45720" numCol="1" spcCol="0" rtlCol="0" fromWordArt="0" anchor="t" anchorCtr="0" forceAA="0" compatLnSpc="1">
+            <a:prstTxWarp prst="textNoShape">
+              <a:avLst/>
+            </a:prstTxWarp>
+            <a:spAutoFit/>
+          </a:bodyPr>
+          <a:lstStyle/>
+          <a:p>
+            <a:r>
+              <a:rPr lang="en-US" sz="2800">
+                <a:cs typeface="Arial"/>
+              </a:rPr>
+              <a:t>0.375  =</a:t>
+            </a:r>
+            <a:r>
+              <a:rPr lang="en-US" sz="2800" dirty="0">
+                <a:cs typeface="Arial"/>
+              </a:rPr>
+              <a:t> 0.011</a:t>
+            </a:r>
+          </a:p>
+        </p:txBody>
+      </p:sp>
+      <p:sp>
+        <p:nvSpPr>
+          <p:cNvPr id="6" name="TextBox 5">
+            <a:extLst>
+              <a:ext uri="{FF2B5EF4-FFF2-40B4-BE49-F238E27FC236}">
+                <a16:creationId xmlns:a16="http://schemas.microsoft.com/office/drawing/2014/main" id="{E2EEA992-8D2E-5076-412A-561F392E8042}"/>
+              </a:ext>
+            </a:extLst>
+          </p:cNvPr>
+          <p:cNvSpPr txBox="1"/>
+          <p:nvPr/>
+        </p:nvSpPr>
+        <p:spPr>
+          <a:xfrm>
+            <a:off x="5587999" y="3116384"/>
+            <a:ext cx="3350846" cy="307777"/>
+          </a:xfrm>
+          <a:prstGeom prst="rect">
+            <a:avLst/>
+          </a:prstGeom>
+          <a:noFill/>
+        </p:spPr>
+        <p:txBody>
+          <a:bodyPr rot="0" spcFirstLastPara="0" vertOverflow="overflow" horzOverflow="overflow" vert="horz" wrap="square" lIns="91440" tIns="45720" rIns="91440" bIns="45720" numCol="1" spcCol="0" rtlCol="0" fromWordArt="0" anchor="t" anchorCtr="0" forceAA="0" compatLnSpc="1">
+            <a:prstTxWarp prst="textNoShape">
+              <a:avLst/>
+            </a:prstTxWarp>
+            <a:spAutoFit/>
+          </a:bodyPr>
+          <a:lstStyle/>
+          <a:p>
+            <a:r>
+              <a:rPr lang="en-US" sz="1400">
+                <a:cs typeface="Arial"/>
+              </a:rPr>
+              <a:t>10                             2</a:t>
+            </a:r>
+            <a:endParaRPr lang="en-US" sz="1400"/>
+          </a:p>
+        </p:txBody>
+      </p:sp>
+      <p:sp>
+        <p:nvSpPr>
+          <p:cNvPr id="2" name="TextBox 1">
+            <a:extLst>
+              <a:ext uri="{FF2B5EF4-FFF2-40B4-BE49-F238E27FC236}">
+                <a16:creationId xmlns:a16="http://schemas.microsoft.com/office/drawing/2014/main" id="{4EB33929-793D-2F14-06A0-75B1F2C5A2E9}"/>
+              </a:ext>
+            </a:extLst>
+          </p:cNvPr>
+          <p:cNvSpPr txBox="1"/>
+          <p:nvPr/>
+        </p:nvSpPr>
+        <p:spPr>
+          <a:xfrm>
+            <a:off x="4442790" y="4873996"/>
+            <a:ext cx="2960574" cy="369332"/>
+          </a:xfrm>
+          <a:prstGeom prst="rect">
+            <a:avLst/>
+          </a:prstGeom>
+          <a:noFill/>
+        </p:spPr>
+        <p:txBody>
+          <a:bodyPr rot="0" spcFirstLastPara="0" vertOverflow="overflow" horzOverflow="overflow" vert="horz" wrap="square" lIns="91440" tIns="45720" rIns="91440" bIns="45720" numCol="1" spcCol="0" rtlCol="0" fromWordArt="0" anchor="t" anchorCtr="0" forceAA="0" compatLnSpc="1">
+            <a:prstTxWarp prst="textNoShape">
+              <a:avLst/>
+            </a:prstTxWarp>
+            <a:spAutoFit/>
+          </a:bodyPr>
+          <a:lstStyle/>
+          <a:p>
+            <a:r>
+              <a:rPr lang="en-US"/>
+              <a:t>DAD can be encoded as 011</a:t>
+            </a:r>
+          </a:p>
+        </p:txBody>
+      </p:sp>
+    </p:spTree>
+    <p:extLst>
+      <p:ext uri="{BB962C8B-B14F-4D97-AF65-F5344CB8AC3E}">
+        <p14:creationId xmlns:p14="http://schemas.microsoft.com/office/powerpoint/2010/main" val="3513804166"/>
+      </p:ext>
+    </p:extLst>
+  </p:cSld>
+  <p:clrMapOvr>
+    <a:masterClrMapping/>
+  </p:clrMapOvr>
+  <mc:AlternateContent xmlns:mc="http://schemas.openxmlformats.org/markup-compatibility/2006">
+    <mc:Choice xmlns:p159="http://schemas.microsoft.com/office/powerpoint/2015/09/main" Requires="p159">
+      <p:transition xmlns:p14="http://schemas.microsoft.com/office/powerpoint/2010/main" spd="slow" p14:dur="2000">
+        <p159:morph option="byObject"/>
+      </p:transition>
+    </mc:Choice>
+    <mc:Fallback>
+      <p:transition spd="slow">
+        <p:fade/>
+      </p:transition>
+    </mc:Fallback>
+  </mc:AlternateContent>
+</p:sld>
+</file>
+
+<file path=ppt/slides/slide11.xml><?xml version="1.0" encoding="utf-8"?>
+<p:sld xmlns:a="http://schemas.openxmlformats.org/drawingml/2006/main" xmlns:r="http://schemas.openxmlformats.org/officeDocument/2006/relationships" xmlns:p="http://schemas.openxmlformats.org/presentationml/2006/main">
+  <p:cSld>
+    <p:spTree>
+      <p:nvGrpSpPr>
+        <p:cNvPr id="1" name=""/>
+        <p:cNvGrpSpPr/>
+        <p:nvPr/>
+      </p:nvGrpSpPr>
+      <p:grpSpPr>
+        <a:xfrm>
+          <a:off x="0" y="0"/>
+          <a:ext cx="0" cy="0"/>
+          <a:chOff x="0" y="0"/>
+          <a:chExt cx="0" cy="0"/>
+        </a:xfrm>
+      </p:grpSpPr>
+      <p:sp>
+        <p:nvSpPr>
+          <p:cNvPr id="2" name="Title 1">
+            <a:extLst>
+              <a:ext uri="{FF2B5EF4-FFF2-40B4-BE49-F238E27FC236}">
+                <a16:creationId xmlns:a16="http://schemas.microsoft.com/office/drawing/2014/main" id="{61D0110A-A638-EF29-0913-78B58563F434}"/>
+              </a:ext>
+            </a:extLst>
+          </p:cNvPr>
+          <p:cNvSpPr>
+            <a:spLocks noGrp="1"/>
+          </p:cNvSpPr>
+          <p:nvPr>
+            <p:ph type="title"/>
+          </p:nvPr>
+        </p:nvSpPr>
+        <p:spPr/>
+        <p:txBody>
+          <a:bodyPr/>
+          <a:lstStyle/>
+          <a:p>
+            <a:r>
+              <a:rPr lang="en-US"/>
+              <a:t>Demonstration</a:t>
+            </a:r>
+          </a:p>
+        </p:txBody>
+      </p:sp>
+      <p:sp>
+        <p:nvSpPr>
+          <p:cNvPr id="3" name="Content Placeholder 2">
+            <a:extLst>
+              <a:ext uri="{FF2B5EF4-FFF2-40B4-BE49-F238E27FC236}">
+                <a16:creationId xmlns:a16="http://schemas.microsoft.com/office/drawing/2014/main" id="{248A4871-37B0-C1E8-D1EB-3E357FC9F5E9}"/>
+              </a:ext>
+            </a:extLst>
+          </p:cNvPr>
+          <p:cNvSpPr>
+            <a:spLocks noGrp="1"/>
+          </p:cNvSpPr>
+          <p:nvPr>
+            <p:ph idx="1"/>
+          </p:nvPr>
+        </p:nvSpPr>
+        <p:spPr/>
+        <p:txBody>
+          <a:bodyPr/>
+          <a:lstStyle/>
+          <a:p>
+            <a:endParaRPr lang="en-US"/>
+          </a:p>
+        </p:txBody>
+      </p:sp>
+    </p:spTree>
+    <p:extLst>
+      <p:ext uri="{BB962C8B-B14F-4D97-AF65-F5344CB8AC3E}">
+        <p14:creationId xmlns:p14="http://schemas.microsoft.com/office/powerpoint/2010/main" val="2941710776"/>
+      </p:ext>
+    </p:extLst>
+  </p:cSld>
+  <p:clrMapOvr>
+    <a:masterClrMapping/>
+  </p:clrMapOvr>
+</p:sld>
+</file>
+
+<file path=ppt/slides/slide12.xml><?xml version="1.0" encoding="utf-8"?>
+<p:sld xmlns:a="http://schemas.openxmlformats.org/drawingml/2006/main" xmlns:r="http://schemas.openxmlformats.org/officeDocument/2006/relationships" xmlns:p="http://schemas.openxmlformats.org/presentationml/2006/main">
+  <p:cSld>
+    <p:spTree>
+      <p:nvGrpSpPr>
+        <p:cNvPr id="1" name=""/>
+        <p:cNvGrpSpPr/>
+        <p:nvPr/>
+      </p:nvGrpSpPr>
+      <p:grpSpPr>
+        <a:xfrm>
+          <a:off x="0" y="0"/>
+          <a:ext cx="0" cy="0"/>
+          <a:chOff x="0" y="0"/>
+          <a:chExt cx="0" cy="0"/>
+        </a:xfrm>
+      </p:grpSpPr>
+      <p:sp>
+        <p:nvSpPr>
+          <p:cNvPr id="2" name="Title 1">
+            <a:extLst>
+              <a:ext uri="{FF2B5EF4-FFF2-40B4-BE49-F238E27FC236}">
+                <a16:creationId xmlns:a16="http://schemas.microsoft.com/office/drawing/2014/main" id="{3F469514-D49B-6103-A7BF-3598ACA270CB}"/>
+              </a:ext>
+            </a:extLst>
+          </p:cNvPr>
+          <p:cNvSpPr>
+            <a:spLocks noGrp="1"/>
+          </p:cNvSpPr>
+          <p:nvPr>
+            <p:ph type="title"/>
+          </p:nvPr>
+        </p:nvSpPr>
+        <p:spPr/>
+        <p:txBody>
+          <a:bodyPr/>
+          <a:lstStyle/>
+          <a:p>
+            <a:r>
+              <a:rPr lang="en-US"/>
+              <a:t>Results</a:t>
+            </a:r>
+          </a:p>
+        </p:txBody>
+      </p:sp>
+      <p:sp>
+        <p:nvSpPr>
+          <p:cNvPr id="3" name="Content Placeholder 2">
+            <a:extLst>
+              <a:ext uri="{FF2B5EF4-FFF2-40B4-BE49-F238E27FC236}">
+                <a16:creationId xmlns:a16="http://schemas.microsoft.com/office/drawing/2014/main" id="{A15696CB-F9B7-384F-3483-08C10816F169}"/>
+              </a:ext>
+            </a:extLst>
+          </p:cNvPr>
+          <p:cNvSpPr>
+            <a:spLocks noGrp="1"/>
+          </p:cNvSpPr>
+          <p:nvPr>
+            <p:ph idx="1"/>
+          </p:nvPr>
+        </p:nvSpPr>
+        <p:spPr/>
+        <p:txBody>
+          <a:bodyPr vert="horz" lIns="91440" tIns="45720" rIns="91440" bIns="45720" rtlCol="0" anchor="t">
+            <a:normAutofit/>
+          </a:bodyPr>
+          <a:lstStyle/>
+          <a:p>
+            <a:r>
+              <a:rPr lang="en-US" dirty="0"/>
+              <a:t>[explain performa</a:t>
+            </a:r>
+            <a:r>
+              <a:rPr lang="en-US"/>
+              <a:t>nce, both effectiveness, and complexity]</a:t>
+            </a:r>
+          </a:p>
+          <a:p>
+            <a:r>
+              <a:rPr lang="en-US" dirty="0"/>
+              <a:t>[trade-offs of </a:t>
+            </a:r>
+            <a:r>
+              <a:rPr lang="en-US" dirty="0" err="1"/>
+              <a:t>Arith</a:t>
+            </a:r>
+            <a:r>
+              <a:rPr lang="en-US" dirty="0"/>
+              <a:t> Code]</a:t>
+            </a:r>
+          </a:p>
+          <a:p>
+            <a:r>
+              <a:rPr lang="en-US"/>
+              <a:t>Valuable in image/video compression and scientific data storage.</a:t>
+            </a:r>
+            <a:endParaRPr lang="en-US" dirty="0"/>
+          </a:p>
+          <a:p>
+            <a:endParaRPr lang="en-US" dirty="0"/>
+          </a:p>
+        </p:txBody>
+      </p:sp>
+    </p:spTree>
+    <p:extLst>
+      <p:ext uri="{BB962C8B-B14F-4D97-AF65-F5344CB8AC3E}">
+        <p14:creationId xmlns:p14="http://schemas.microsoft.com/office/powerpoint/2010/main" val="653080710"/>
+      </p:ext>
+    </p:extLst>
+  </p:cSld>
+  <p:clrMapOvr>
+    <a:masterClrMapping/>
+  </p:clrMapOvr>
+</p:sld>
+</file>
+
 <file path=ppt/slides/slide2.xml><?xml version="1.0" encoding="utf-8"?>
 <p:sld xmlns:a="http://schemas.openxmlformats.org/drawingml/2006/main" xmlns:r="http://schemas.openxmlformats.org/officeDocument/2006/relationships" xmlns:p="http://schemas.openxmlformats.org/presentationml/2006/main">
   <p:cSld>
@@ -3748,102 +4281,308 @@
       </p:grpSpPr>
       <p:sp>
         <p:nvSpPr>
-          <p:cNvPr id="2" name="Title 1">
+          <p:cNvPr id="9" name="Rectangle 8">
             <a:extLst>
               <a:ext uri="{FF2B5EF4-FFF2-40B4-BE49-F238E27FC236}">
-                <a16:creationId xmlns:a16="http://schemas.microsoft.com/office/drawing/2014/main" id="{4816AD95-9ADF-4F32-5BC6-23FF0E8FD463}"/>
+                <a16:creationId xmlns:a16="http://schemas.microsoft.com/office/drawing/2014/main" id="{9C4D4E8B-819A-A551-4241-46DA1AF0D801}"/>
               </a:ext>
             </a:extLst>
           </p:cNvPr>
-          <p:cNvSpPr>
-            <a:spLocks noGrp="1"/>
-          </p:cNvSpPr>
-          <p:nvPr>
-            <p:ph type="title"/>
-          </p:nvPr>
-        </p:nvSpPr>
-        <p:spPr/>
-        <p:txBody>
-          <a:bodyPr>
-            <a:normAutofit/>
-          </a:bodyPr>
-          <a:lstStyle/>
-          <a:p>
-            <a:r>
-              <a:rPr lang="en-US">
-                <a:latin typeface="Aptos Display"/>
-              </a:rPr>
-              <a:t>Arithmetic Coding explained</a:t>
-            </a:r>
-            <a:endParaRPr lang="en-US"/>
-          </a:p>
-        </p:txBody>
-      </p:sp>
-      <p:sp>
-        <p:nvSpPr>
-          <p:cNvPr id="3" name="Content Placeholder 2">
+          <p:cNvSpPr/>
+          <p:nvPr/>
+        </p:nvSpPr>
+        <p:spPr>
+          <a:xfrm>
+            <a:off x="979473" y="4073981"/>
+            <a:ext cx="8333" cy="369515"/>
+          </a:xfrm>
+          <a:prstGeom prst="rect">
+            <a:avLst/>
+          </a:prstGeom>
+          <a:solidFill>
+            <a:schemeClr val="bg1"/>
+          </a:solidFill>
+          <a:ln>
+            <a:solidFill>
+              <a:schemeClr val="bg1"/>
+            </a:solidFill>
+          </a:ln>
+        </p:spPr>
+        <p:style>
+          <a:lnRef idx="2">
+            <a:schemeClr val="accent1">
+              <a:shade val="15000"/>
+            </a:schemeClr>
+          </a:lnRef>
+          <a:fillRef idx="1">
+            <a:schemeClr val="accent1"/>
+          </a:fillRef>
+          <a:effectRef idx="0">
+            <a:schemeClr val="accent1"/>
+          </a:effectRef>
+          <a:fontRef idx="minor">
+            <a:schemeClr val="lt1"/>
+          </a:fontRef>
+        </p:style>
+        <p:txBody>
+          <a:bodyPr lIns="91440" tIns="45720" rIns="91440" bIns="45720" rtlCol="0" anchor="ctr"/>
+          <a:lstStyle/>
+          <a:p>
+            <a:pPr algn="ctr"/>
+            <a:endParaRPr lang="en-US" dirty="0"/>
+          </a:p>
+        </p:txBody>
+      </p:sp>
+      <p:sp>
+        <p:nvSpPr>
+          <p:cNvPr id="5" name="TextBox 4">
             <a:extLst>
               <a:ext uri="{FF2B5EF4-FFF2-40B4-BE49-F238E27FC236}">
-                <a16:creationId xmlns:a16="http://schemas.microsoft.com/office/drawing/2014/main" id="{B080A83C-48F2-FA91-53BD-1A090439B53B}"/>
+                <a16:creationId xmlns:a16="http://schemas.microsoft.com/office/drawing/2014/main" id="{C9487162-86C1-6952-227D-76039EB8180A}"/>
               </a:ext>
             </a:extLst>
           </p:cNvPr>
-          <p:cNvSpPr>
-            <a:spLocks noGrp="1"/>
-          </p:cNvSpPr>
-          <p:nvPr>
-            <p:ph idx="1"/>
-          </p:nvPr>
-        </p:nvSpPr>
-        <p:spPr/>
-        <p:txBody>
-          <a:bodyPr vert="horz" lIns="91440" tIns="45720" rIns="91440" bIns="45720" rtlCol="0" anchor="t">
-            <a:normAutofit/>
+          <p:cNvSpPr txBox="1"/>
+          <p:nvPr/>
+        </p:nvSpPr>
+        <p:spPr>
+          <a:xfrm>
+            <a:off x="149604" y="272008"/>
+            <a:ext cx="5770494" cy="1200329"/>
+          </a:xfrm>
+          <a:prstGeom prst="rect">
+            <a:avLst/>
+          </a:prstGeom>
+          <a:noFill/>
+        </p:spPr>
+        <p:txBody>
+          <a:bodyPr rot="0" spcFirstLastPara="0" vertOverflow="overflow" horzOverflow="overflow" vert="horz" wrap="square" lIns="91440" tIns="45720" rIns="91440" bIns="45720" numCol="1" spcCol="0" rtlCol="0" fromWordArt="0" anchor="t" anchorCtr="0" forceAA="0" compatLnSpc="1">
+            <a:prstTxWarp prst="textNoShape">
+              <a:avLst/>
+            </a:prstTxWarp>
+            <a:spAutoFit/>
           </a:bodyPr>
           <a:lstStyle/>
           <a:p>
             <a:r>
-              <a:rPr lang="en-US" dirty="0"/>
-              <a:t>Symbols</a:t>
-            </a:r>
-            <a:r>
-              <a:rPr lang="en-US">
-                <a:solidFill>
-                  <a:srgbClr val="000000"/>
-                </a:solidFill>
-                <a:latin typeface="Aptos"/>
-              </a:rPr>
-              <a:t> are assigned portions of a narrowing interval based on probability, starting as [0, 1).</a:t>
-            </a:r>
-            <a:endParaRPr lang="en-US" dirty="0">
-              <a:solidFill>
-                <a:srgbClr val="000000"/>
-              </a:solidFill>
-              <a:latin typeface="Aptos"/>
-            </a:endParaRPr>
-          </a:p>
-          <a:p>
-            <a:r>
-              <a:rPr lang="en-US"/>
-              <a:t>Messages are encoded using a number inside the final interval.</a:t>
-            </a:r>
+              <a:rPr lang="en-US"/>
+              <a:t>Symbols are assigned portions of a narrowing interval based on probability, starting as [0, 1).</a:t>
+            </a:r>
+          </a:p>
+          <a:p>
             <a:endParaRPr lang="en-US" dirty="0"/>
           </a:p>
           <a:p>
             <a:r>
               <a:rPr lang="en-US"/>
-              <a:t>Messages are decoded using the encoded value and the probability model</a:t>
-            </a:r>
+              <a:t>Here, we encode the word "DAD".</a:t>
+            </a:r>
+          </a:p>
+        </p:txBody>
+      </p:sp>
+      <p:sp>
+        <p:nvSpPr>
+          <p:cNvPr id="6" name="TextBox 5">
+            <a:extLst>
+              <a:ext uri="{FF2B5EF4-FFF2-40B4-BE49-F238E27FC236}">
+                <a16:creationId xmlns:a16="http://schemas.microsoft.com/office/drawing/2014/main" id="{2DD14932-C9CB-DC3F-AB48-886E080D257E}"/>
+              </a:ext>
+            </a:extLst>
+          </p:cNvPr>
+          <p:cNvSpPr txBox="1"/>
+          <p:nvPr/>
+        </p:nvSpPr>
+        <p:spPr>
+          <a:xfrm>
+            <a:off x="775222" y="4066517"/>
+            <a:ext cx="598417" cy="369332"/>
+          </a:xfrm>
+          <a:prstGeom prst="rect">
+            <a:avLst/>
+          </a:prstGeom>
+          <a:noFill/>
+        </p:spPr>
+        <p:txBody>
+          <a:bodyPr rot="0" spcFirstLastPara="0" vertOverflow="overflow" horzOverflow="overflow" vert="horz" wrap="square" lIns="91440" tIns="45720" rIns="91440" bIns="45720" numCol="1" spcCol="0" rtlCol="0" fromWordArt="0" anchor="t" anchorCtr="0" forceAA="0" compatLnSpc="1">
+            <a:prstTxWarp prst="textNoShape">
+              <a:avLst/>
+            </a:prstTxWarp>
+            <a:spAutoFit/>
+          </a:bodyPr>
+          <a:lstStyle/>
+          <a:p>
+            <a:pPr algn="l"/>
+            <a:r>
+              <a:rPr lang="en-US"/>
+              <a:t>0.0</a:t>
+            </a:r>
+          </a:p>
+        </p:txBody>
+      </p:sp>
+      <p:sp>
+        <p:nvSpPr>
+          <p:cNvPr id="7" name="TextBox 6">
+            <a:extLst>
+              <a:ext uri="{FF2B5EF4-FFF2-40B4-BE49-F238E27FC236}">
+                <a16:creationId xmlns:a16="http://schemas.microsoft.com/office/drawing/2014/main" id="{854A41EC-814C-C381-4755-1BF5FA784B74}"/>
+              </a:ext>
+            </a:extLst>
+          </p:cNvPr>
+          <p:cNvSpPr txBox="1"/>
+          <p:nvPr/>
+        </p:nvSpPr>
+        <p:spPr>
+          <a:xfrm>
+            <a:off x="10573526" y="4086085"/>
+            <a:ext cx="594009" cy="369332"/>
+          </a:xfrm>
+          <a:prstGeom prst="rect">
+            <a:avLst/>
+          </a:prstGeom>
+          <a:noFill/>
+        </p:spPr>
+        <p:txBody>
+          <a:bodyPr rot="0" spcFirstLastPara="0" vertOverflow="overflow" horzOverflow="overflow" vert="horz" wrap="square" lIns="91440" tIns="45720" rIns="91440" bIns="45720" numCol="1" spcCol="0" rtlCol="0" fromWordArt="0" anchor="t" anchorCtr="0" forceAA="0" compatLnSpc="1">
+            <a:prstTxWarp prst="textNoShape">
+              <a:avLst/>
+            </a:prstTxWarp>
+            <a:spAutoFit/>
+          </a:bodyPr>
+          <a:lstStyle/>
+          <a:p>
+            <a:pPr algn="l"/>
+            <a:r>
+              <a:rPr lang="en-US"/>
+              <a:t>1.0</a:t>
+            </a:r>
+          </a:p>
+        </p:txBody>
+      </p:sp>
+      <p:sp>
+        <p:nvSpPr>
+          <p:cNvPr id="11" name="Rectangle 10">
+            <a:extLst>
+              <a:ext uri="{FF2B5EF4-FFF2-40B4-BE49-F238E27FC236}">
+                <a16:creationId xmlns:a16="http://schemas.microsoft.com/office/drawing/2014/main" id="{713BA833-3EF8-F76F-330D-CBEE287B70F9}"/>
+              </a:ext>
+            </a:extLst>
+          </p:cNvPr>
+          <p:cNvSpPr/>
+          <p:nvPr/>
+        </p:nvSpPr>
+        <p:spPr>
+          <a:xfrm flipH="1">
+            <a:off x="10852866" y="4073981"/>
+            <a:ext cx="5161" cy="369515"/>
+          </a:xfrm>
+          <a:prstGeom prst="rect">
+            <a:avLst/>
+          </a:prstGeom>
+          <a:solidFill>
+            <a:schemeClr val="bg1"/>
+          </a:solidFill>
+          <a:ln>
+            <a:solidFill>
+              <a:schemeClr val="bg1"/>
+            </a:solidFill>
+          </a:ln>
+        </p:spPr>
+        <p:style>
+          <a:lnRef idx="2">
+            <a:schemeClr val="accent1">
+              <a:shade val="15000"/>
+            </a:schemeClr>
+          </a:lnRef>
+          <a:fillRef idx="1">
+            <a:schemeClr val="accent1"/>
+          </a:fillRef>
+          <a:effectRef idx="0">
+            <a:schemeClr val="accent1"/>
+          </a:effectRef>
+          <a:fontRef idx="minor">
+            <a:schemeClr val="lt1"/>
+          </a:fontRef>
+        </p:style>
+        <p:txBody>
+          <a:bodyPr lIns="91440" tIns="45720" rIns="91440" bIns="45720" rtlCol="0" anchor="ctr"/>
+          <a:lstStyle/>
+          <a:p>
+            <a:pPr algn="ctr"/>
             <a:endParaRPr lang="en-US" dirty="0"/>
           </a:p>
-          <a:p>
-            <a:r>
-              <a:rPr lang="en-US"/>
-              <a:t>Effective example of lossless compression</a:t>
-            </a:r>
-            <a:endParaRPr lang="en-US" dirty="0"/>
-          </a:p>
-          <a:p>
+        </p:txBody>
+      </p:sp>
+      <p:cxnSp>
+        <p:nvCxnSpPr>
+          <p:cNvPr id="4" name="Straight Arrow Connector 3">
+            <a:extLst>
+              <a:ext uri="{FF2B5EF4-FFF2-40B4-BE49-F238E27FC236}">
+                <a16:creationId xmlns:a16="http://schemas.microsoft.com/office/drawing/2014/main" id="{5911C9D5-D263-7FBF-B2C7-6ACD1462F620}"/>
+              </a:ext>
+            </a:extLst>
+          </p:cNvPr>
+          <p:cNvCxnSpPr/>
+          <p:nvPr/>
+        </p:nvCxnSpPr>
+        <p:spPr>
+          <a:xfrm>
+            <a:off x="982250" y="4442794"/>
+            <a:ext cx="9882952" cy="15119"/>
+          </a:xfrm>
+          <a:prstGeom prst="straightConnector1">
+            <a:avLst/>
+          </a:prstGeom>
+        </p:spPr>
+        <p:style>
+          <a:lnRef idx="2">
+            <a:schemeClr val="accent1"/>
+          </a:lnRef>
+          <a:fillRef idx="0">
+            <a:schemeClr val="accent1"/>
+          </a:fillRef>
+          <a:effectRef idx="1">
+            <a:schemeClr val="accent1"/>
+          </a:effectRef>
+          <a:fontRef idx="minor">
+            <a:schemeClr val="tx1"/>
+          </a:fontRef>
+        </p:style>
+      </p:cxnSp>
+      <p:sp>
+        <p:nvSpPr>
+          <p:cNvPr id="13" name="TextBox 12">
+            <a:extLst>
+              <a:ext uri="{FF2B5EF4-FFF2-40B4-BE49-F238E27FC236}">
+                <a16:creationId xmlns:a16="http://schemas.microsoft.com/office/drawing/2014/main" id="{28364E6C-AC4A-C6FF-341C-FE2EC90730D9}"/>
+              </a:ext>
+            </a:extLst>
+          </p:cNvPr>
+          <p:cNvSpPr txBox="1"/>
+          <p:nvPr/>
+        </p:nvSpPr>
+        <p:spPr>
+          <a:xfrm>
+            <a:off x="979988" y="4502084"/>
+            <a:ext cx="5575575" cy="369332"/>
+          </a:xfrm>
+          <a:prstGeom prst="rect">
+            <a:avLst/>
+          </a:prstGeom>
+          <a:noFill/>
+        </p:spPr>
+        <p:txBody>
+          <a:bodyPr rot="0" spcFirstLastPara="0" vertOverflow="overflow" horzOverflow="overflow" vert="horz" wrap="square" lIns="91440" tIns="45720" rIns="91440" bIns="45720" numCol="1" spcCol="0" rtlCol="0" fromWordArt="0" anchor="t" anchorCtr="0" forceAA="0" compatLnSpc="1">
+            <a:prstTxWarp prst="textNoShape">
+              <a:avLst/>
+            </a:prstTxWarp>
+            <a:spAutoFit/>
+          </a:bodyPr>
+          <a:lstStyle/>
+          <a:p>
+            <a:r>
+              <a:rPr lang="en-US"/>
+              <a:t>Interval: [0, 1)</a:t>
+            </a:r>
             <a:endParaRPr lang="en-US" dirty="0"/>
           </a:p>
         </p:txBody>
@@ -3851,7 +4590,7 @@
     </p:spTree>
     <p:extLst>
       <p:ext uri="{BB962C8B-B14F-4D97-AF65-F5344CB8AC3E}">
-        <p14:creationId xmlns:p14="http://schemas.microsoft.com/office/powerpoint/2010/main" val="1095693652"/>
+        <p14:creationId xmlns:p14="http://schemas.microsoft.com/office/powerpoint/2010/main" val="3988346295"/>
       </p:ext>
     </p:extLst>
   </p:cSld>
@@ -3866,7 +4605,13 @@
   <p:cSld>
     <p:spTree>
       <p:nvGrpSpPr>
-        <p:cNvPr id="1" name=""/>
+        <p:cNvPr id="1" name="">
+          <a:extLst>
+            <a:ext uri="{FF2B5EF4-FFF2-40B4-BE49-F238E27FC236}">
+              <a16:creationId xmlns:a16="http://schemas.microsoft.com/office/drawing/2014/main" id="{BE7C9029-330C-4F34-A929-8DED93D6C9B6}"/>
+            </a:ext>
+          </a:extLst>
+        </p:cNvPr>
         <p:cNvGrpSpPr/>
         <p:nvPr/>
       </p:nvGrpSpPr>
@@ -3880,61 +4625,352 @@
       </p:grpSpPr>
       <p:sp>
         <p:nvSpPr>
-          <p:cNvPr id="2" name="Title 1">
+          <p:cNvPr id="2" name="Rectangle 1">
             <a:extLst>
               <a:ext uri="{FF2B5EF4-FFF2-40B4-BE49-F238E27FC236}">
-                <a16:creationId xmlns:a16="http://schemas.microsoft.com/office/drawing/2014/main" id="{61D0110A-A638-EF29-0913-78B58563F434}"/>
+                <a16:creationId xmlns:a16="http://schemas.microsoft.com/office/drawing/2014/main" id="{9F0E6C9C-C0E2-AADE-077A-8EB7FC52F80A}"/>
               </a:ext>
             </a:extLst>
           </p:cNvPr>
-          <p:cNvSpPr>
-            <a:spLocks noGrp="1"/>
-          </p:cNvSpPr>
-          <p:nvPr>
-            <p:ph type="title"/>
-          </p:nvPr>
-        </p:nvSpPr>
-        <p:spPr/>
-        <p:txBody>
-          <a:bodyPr/>
-          <a:lstStyle/>
-          <a:p>
-            <a:r>
-              <a:rPr lang="en-US"/>
-              <a:t>Demonstration</a:t>
-            </a:r>
-          </a:p>
-        </p:txBody>
-      </p:sp>
-      <p:sp>
-        <p:nvSpPr>
-          <p:cNvPr id="3" name="Content Placeholder 2">
+          <p:cNvSpPr/>
+          <p:nvPr/>
+        </p:nvSpPr>
+        <p:spPr>
+          <a:xfrm>
+            <a:off x="991105" y="4073981"/>
+            <a:ext cx="6138755" cy="369515"/>
+          </a:xfrm>
+          <a:prstGeom prst="rect">
+            <a:avLst/>
+          </a:prstGeom>
+          <a:solidFill>
+            <a:srgbClr val="ED7D31"/>
+          </a:solidFill>
+          <a:ln>
+            <a:solidFill>
+              <a:schemeClr val="accent2"/>
+            </a:solidFill>
+          </a:ln>
+        </p:spPr>
+        <p:style>
+          <a:lnRef idx="2">
+            <a:schemeClr val="accent1">
+              <a:shade val="15000"/>
+            </a:schemeClr>
+          </a:lnRef>
+          <a:fillRef idx="1">
+            <a:schemeClr val="accent1"/>
+          </a:fillRef>
+          <a:effectRef idx="0">
+            <a:schemeClr val="accent1"/>
+          </a:effectRef>
+          <a:fontRef idx="minor">
+            <a:schemeClr val="lt1"/>
+          </a:fontRef>
+        </p:style>
+        <p:txBody>
+          <a:bodyPr rtlCol="0" anchor="ctr"/>
+          <a:lstStyle/>
+          <a:p>
+            <a:pPr algn="ctr"/>
+            <a:r>
+              <a:rPr lang="en-US"/>
+              <a:t>D: 60%</a:t>
+            </a:r>
+          </a:p>
+        </p:txBody>
+      </p:sp>
+      <p:sp>
+        <p:nvSpPr>
+          <p:cNvPr id="3" name="Rectangle 2">
             <a:extLst>
               <a:ext uri="{FF2B5EF4-FFF2-40B4-BE49-F238E27FC236}">
-                <a16:creationId xmlns:a16="http://schemas.microsoft.com/office/drawing/2014/main" id="{248A4871-37B0-C1E8-D1EB-3E357FC9F5E9}"/>
+                <a16:creationId xmlns:a16="http://schemas.microsoft.com/office/drawing/2014/main" id="{7BF93901-8745-1394-8A8E-9A73FA39C78A}"/>
               </a:ext>
             </a:extLst>
           </p:cNvPr>
-          <p:cNvSpPr>
-            <a:spLocks noGrp="1"/>
-          </p:cNvSpPr>
-          <p:nvPr>
-            <p:ph idx="1"/>
-          </p:nvPr>
-        </p:nvSpPr>
-        <p:spPr/>
-        <p:txBody>
-          <a:bodyPr/>
-          <a:lstStyle/>
-          <a:p>
-            <a:endParaRPr lang="en-US"/>
+          <p:cNvSpPr/>
+          <p:nvPr/>
+        </p:nvSpPr>
+        <p:spPr>
+          <a:xfrm flipH="1">
+            <a:off x="7139628" y="4073981"/>
+            <a:ext cx="3718399" cy="369515"/>
+          </a:xfrm>
+          <a:prstGeom prst="rect">
+            <a:avLst/>
+          </a:prstGeom>
+          <a:solidFill>
+            <a:srgbClr val="F58C53"/>
+          </a:solidFill>
+          <a:ln>
+            <a:solidFill>
+              <a:srgbClr val="F58C53"/>
+            </a:solidFill>
+          </a:ln>
+        </p:spPr>
+        <p:style>
+          <a:lnRef idx="2">
+            <a:schemeClr val="accent1">
+              <a:shade val="15000"/>
+            </a:schemeClr>
+          </a:lnRef>
+          <a:fillRef idx="1">
+            <a:schemeClr val="accent1"/>
+          </a:fillRef>
+          <a:effectRef idx="0">
+            <a:schemeClr val="accent1"/>
+          </a:effectRef>
+          <a:fontRef idx="minor">
+            <a:schemeClr val="lt1"/>
+          </a:fontRef>
+        </p:style>
+        <p:txBody>
+          <a:bodyPr lIns="91440" tIns="45720" rIns="91440" bIns="45720" rtlCol="0" anchor="ctr"/>
+          <a:lstStyle/>
+          <a:p>
+            <a:pPr algn="ctr"/>
+            <a:r>
+              <a:rPr lang="en-US"/>
+              <a:t>A: 40%</a:t>
+            </a:r>
+          </a:p>
+        </p:txBody>
+      </p:sp>
+      <p:cxnSp>
+        <p:nvCxnSpPr>
+          <p:cNvPr id="4" name="Straight Arrow Connector 3">
+            <a:extLst>
+              <a:ext uri="{FF2B5EF4-FFF2-40B4-BE49-F238E27FC236}">
+                <a16:creationId xmlns:a16="http://schemas.microsoft.com/office/drawing/2014/main" id="{3D9ACC8E-3CDE-48B1-AB10-DCE83F03C3D6}"/>
+              </a:ext>
+            </a:extLst>
+          </p:cNvPr>
+          <p:cNvCxnSpPr/>
+          <p:nvPr/>
+        </p:nvCxnSpPr>
+        <p:spPr>
+          <a:xfrm>
+            <a:off x="982250" y="4442794"/>
+            <a:ext cx="9882952" cy="15119"/>
+          </a:xfrm>
+          <a:prstGeom prst="straightConnector1">
+            <a:avLst/>
+          </a:prstGeom>
+        </p:spPr>
+        <p:style>
+          <a:lnRef idx="2">
+            <a:schemeClr val="accent1"/>
+          </a:lnRef>
+          <a:fillRef idx="0">
+            <a:schemeClr val="accent1"/>
+          </a:fillRef>
+          <a:effectRef idx="1">
+            <a:schemeClr val="accent1"/>
+          </a:effectRef>
+          <a:fontRef idx="minor">
+            <a:schemeClr val="tx1"/>
+          </a:fontRef>
+        </p:style>
+      </p:cxnSp>
+      <p:sp>
+        <p:nvSpPr>
+          <p:cNvPr id="5" name="TextBox 4">
+            <a:extLst>
+              <a:ext uri="{FF2B5EF4-FFF2-40B4-BE49-F238E27FC236}">
+                <a16:creationId xmlns:a16="http://schemas.microsoft.com/office/drawing/2014/main" id="{0958F6D3-D6CA-84AF-B6E8-196C8FDBB642}"/>
+              </a:ext>
+            </a:extLst>
+          </p:cNvPr>
+          <p:cNvSpPr txBox="1"/>
+          <p:nvPr/>
+        </p:nvSpPr>
+        <p:spPr>
+          <a:xfrm>
+            <a:off x="149604" y="272008"/>
+            <a:ext cx="5575575" cy="369332"/>
+          </a:xfrm>
+          <a:prstGeom prst="rect">
+            <a:avLst/>
+          </a:prstGeom>
+          <a:noFill/>
+        </p:spPr>
+        <p:txBody>
+          <a:bodyPr rot="0" spcFirstLastPara="0" vertOverflow="overflow" horzOverflow="overflow" vert="horz" wrap="square" lIns="91440" tIns="45720" rIns="91440" bIns="45720" numCol="1" spcCol="0" rtlCol="0" fromWordArt="0" anchor="t" anchorCtr="0" forceAA="0" compatLnSpc="1">
+            <a:prstTxWarp prst="textNoShape">
+              <a:avLst/>
+            </a:prstTxWarp>
+            <a:spAutoFit/>
+          </a:bodyPr>
+          <a:lstStyle/>
+          <a:p>
+            <a:r>
+              <a:rPr lang="en-US"/>
+              <a:t>Divide by probability of letters appearing in "DAD"</a:t>
+            </a:r>
+          </a:p>
+        </p:txBody>
+      </p:sp>
+      <p:sp>
+        <p:nvSpPr>
+          <p:cNvPr id="6" name="TextBox 5">
+            <a:extLst>
+              <a:ext uri="{FF2B5EF4-FFF2-40B4-BE49-F238E27FC236}">
+                <a16:creationId xmlns:a16="http://schemas.microsoft.com/office/drawing/2014/main" id="{2D559294-0C19-46F2-B714-23F9E03B3540}"/>
+              </a:ext>
+            </a:extLst>
+          </p:cNvPr>
+          <p:cNvSpPr txBox="1"/>
+          <p:nvPr/>
+        </p:nvSpPr>
+        <p:spPr>
+          <a:xfrm>
+            <a:off x="775222" y="4066517"/>
+            <a:ext cx="598417" cy="369332"/>
+          </a:xfrm>
+          <a:prstGeom prst="rect">
+            <a:avLst/>
+          </a:prstGeom>
+          <a:noFill/>
+        </p:spPr>
+        <p:txBody>
+          <a:bodyPr rot="0" spcFirstLastPara="0" vertOverflow="overflow" horzOverflow="overflow" vert="horz" wrap="square" lIns="91440" tIns="45720" rIns="91440" bIns="45720" numCol="1" spcCol="0" rtlCol="0" fromWordArt="0" anchor="t" anchorCtr="0" forceAA="0" compatLnSpc="1">
+            <a:prstTxWarp prst="textNoShape">
+              <a:avLst/>
+            </a:prstTxWarp>
+            <a:spAutoFit/>
+          </a:bodyPr>
+          <a:lstStyle/>
+          <a:p>
+            <a:pPr algn="l"/>
+            <a:r>
+              <a:rPr lang="en-US"/>
+              <a:t>0.0</a:t>
+            </a:r>
+          </a:p>
+        </p:txBody>
+      </p:sp>
+      <p:sp>
+        <p:nvSpPr>
+          <p:cNvPr id="7" name="TextBox 6">
+            <a:extLst>
+              <a:ext uri="{FF2B5EF4-FFF2-40B4-BE49-F238E27FC236}">
+                <a16:creationId xmlns:a16="http://schemas.microsoft.com/office/drawing/2014/main" id="{5AA62789-6735-E9F0-0B9D-C2798BF2F571}"/>
+              </a:ext>
+            </a:extLst>
+          </p:cNvPr>
+          <p:cNvSpPr txBox="1"/>
+          <p:nvPr/>
+        </p:nvSpPr>
+        <p:spPr>
+          <a:xfrm>
+            <a:off x="10573526" y="4086085"/>
+            <a:ext cx="594009" cy="369332"/>
+          </a:xfrm>
+          <a:prstGeom prst="rect">
+            <a:avLst/>
+          </a:prstGeom>
+          <a:noFill/>
+        </p:spPr>
+        <p:txBody>
+          <a:bodyPr rot="0" spcFirstLastPara="0" vertOverflow="overflow" horzOverflow="overflow" vert="horz" wrap="square" lIns="91440" tIns="45720" rIns="91440" bIns="45720" numCol="1" spcCol="0" rtlCol="0" fromWordArt="0" anchor="t" anchorCtr="0" forceAA="0" compatLnSpc="1">
+            <a:prstTxWarp prst="textNoShape">
+              <a:avLst/>
+            </a:prstTxWarp>
+            <a:spAutoFit/>
+          </a:bodyPr>
+          <a:lstStyle/>
+          <a:p>
+            <a:pPr algn="l"/>
+            <a:r>
+              <a:rPr lang="en-US"/>
+              <a:t>1.0</a:t>
+            </a:r>
+          </a:p>
+        </p:txBody>
+      </p:sp>
+      <p:sp>
+        <p:nvSpPr>
+          <p:cNvPr id="9" name="TextBox 8">
+            <a:extLst>
+              <a:ext uri="{FF2B5EF4-FFF2-40B4-BE49-F238E27FC236}">
+                <a16:creationId xmlns:a16="http://schemas.microsoft.com/office/drawing/2014/main" id="{FD9EACB9-E36D-7A98-462E-036F895CDC15}"/>
+              </a:ext>
+            </a:extLst>
+          </p:cNvPr>
+          <p:cNvSpPr txBox="1"/>
+          <p:nvPr/>
+        </p:nvSpPr>
+        <p:spPr>
+          <a:xfrm>
+            <a:off x="979988" y="4502084"/>
+            <a:ext cx="5575575" cy="369332"/>
+          </a:xfrm>
+          <a:prstGeom prst="rect">
+            <a:avLst/>
+          </a:prstGeom>
+          <a:noFill/>
+        </p:spPr>
+        <p:txBody>
+          <a:bodyPr rot="0" spcFirstLastPara="0" vertOverflow="overflow" horzOverflow="overflow" vert="horz" wrap="square" lIns="91440" tIns="45720" rIns="91440" bIns="45720" numCol="1" spcCol="0" rtlCol="0" fromWordArt="0" anchor="t" anchorCtr="0" forceAA="0" compatLnSpc="1">
+            <a:prstTxWarp prst="textNoShape">
+              <a:avLst/>
+            </a:prstTxWarp>
+            <a:spAutoFit/>
+          </a:bodyPr>
+          <a:lstStyle/>
+          <a:p>
+            <a:r>
+              <a:rPr lang="en-US"/>
+              <a:t>Interval: [0, 1)</a:t>
+            </a:r>
+            <a:endParaRPr lang="en-US" dirty="0"/>
+          </a:p>
+        </p:txBody>
+      </p:sp>
+      <p:sp>
+        <p:nvSpPr>
+          <p:cNvPr id="10" name="TextBox 9">
+            <a:extLst>
+              <a:ext uri="{FF2B5EF4-FFF2-40B4-BE49-F238E27FC236}">
+                <a16:creationId xmlns:a16="http://schemas.microsoft.com/office/drawing/2014/main" id="{38512114-A128-654F-252C-55F033A32262}"/>
+              </a:ext>
+            </a:extLst>
+          </p:cNvPr>
+          <p:cNvSpPr txBox="1"/>
+          <p:nvPr/>
+        </p:nvSpPr>
+        <p:spPr>
+          <a:xfrm>
+            <a:off x="6832145" y="4086055"/>
+            <a:ext cx="598417" cy="369332"/>
+          </a:xfrm>
+          <a:prstGeom prst="rect">
+            <a:avLst/>
+          </a:prstGeom>
+          <a:noFill/>
+        </p:spPr>
+        <p:txBody>
+          <a:bodyPr rot="0" spcFirstLastPara="0" vertOverflow="overflow" horzOverflow="overflow" vert="horz" wrap="square" lIns="91440" tIns="45720" rIns="91440" bIns="45720" numCol="1" spcCol="0" rtlCol="0" fromWordArt="0" anchor="t" anchorCtr="0" forceAA="0" compatLnSpc="1">
+            <a:prstTxWarp prst="textNoShape">
+              <a:avLst/>
+            </a:prstTxWarp>
+            <a:spAutoFit/>
+          </a:bodyPr>
+          <a:lstStyle/>
+          <a:p>
+            <a:pPr algn="l"/>
+            <a:r>
+              <a:rPr lang="en-US"/>
+              <a:t>0.6</a:t>
+            </a:r>
           </a:p>
         </p:txBody>
       </p:sp>
     </p:spTree>
     <p:extLst>
       <p:ext uri="{BB962C8B-B14F-4D97-AF65-F5344CB8AC3E}">
-        <p14:creationId xmlns:p14="http://schemas.microsoft.com/office/powerpoint/2010/main" val="2941710776"/>
+        <p14:creationId xmlns:p14="http://schemas.microsoft.com/office/powerpoint/2010/main" val="3512049708"/>
       </p:ext>
     </p:extLst>
   </p:cSld>
@@ -3949,7 +4985,13 @@
   <p:cSld>
     <p:spTree>
       <p:nvGrpSpPr>
-        <p:cNvPr id="1" name=""/>
+        <p:cNvPr id="1" name="">
+          <a:extLst>
+            <a:ext uri="{FF2B5EF4-FFF2-40B4-BE49-F238E27FC236}">
+              <a16:creationId xmlns:a16="http://schemas.microsoft.com/office/drawing/2014/main" id="{FB4EE7B2-7912-CE66-70C1-EAF0513859C7}"/>
+            </a:ext>
+          </a:extLst>
+        </p:cNvPr>
         <p:cNvGrpSpPr/>
         <p:nvPr/>
       </p:nvGrpSpPr>
@@ -3963,100 +5005,1641 @@
       </p:grpSpPr>
       <p:sp>
         <p:nvSpPr>
-          <p:cNvPr id="2" name="Title 1">
+          <p:cNvPr id="5" name="TextBox 4">
             <a:extLst>
               <a:ext uri="{FF2B5EF4-FFF2-40B4-BE49-F238E27FC236}">
-                <a16:creationId xmlns:a16="http://schemas.microsoft.com/office/drawing/2014/main" id="{3F469514-D49B-6103-A7BF-3598ACA270CB}"/>
+                <a16:creationId xmlns:a16="http://schemas.microsoft.com/office/drawing/2014/main" id="{05C5C8F6-E3A9-5739-438A-1D41AEB784F2}"/>
               </a:ext>
             </a:extLst>
           </p:cNvPr>
-          <p:cNvSpPr>
-            <a:spLocks noGrp="1"/>
-          </p:cNvSpPr>
-          <p:nvPr>
-            <p:ph type="title"/>
-          </p:nvPr>
-        </p:nvSpPr>
-        <p:spPr/>
-        <p:txBody>
-          <a:bodyPr/>
-          <a:lstStyle/>
-          <a:p>
-            <a:r>
-              <a:rPr lang="en-US"/>
-              <a:t>Results</a:t>
-            </a:r>
-          </a:p>
-        </p:txBody>
-      </p:sp>
-      <p:sp>
-        <p:nvSpPr>
-          <p:cNvPr id="3" name="Content Placeholder 2">
+          <p:cNvSpPr txBox="1"/>
+          <p:nvPr/>
+        </p:nvSpPr>
+        <p:spPr>
+          <a:xfrm>
+            <a:off x="149604" y="272008"/>
+            <a:ext cx="5575575" cy="646331"/>
+          </a:xfrm>
+          <a:prstGeom prst="rect">
+            <a:avLst/>
+          </a:prstGeom>
+          <a:noFill/>
+        </p:spPr>
+        <p:txBody>
+          <a:bodyPr rot="0" spcFirstLastPara="0" vertOverflow="overflow" horzOverflow="overflow" vert="horz" wrap="square" lIns="91440" tIns="45720" rIns="91440" bIns="45720" numCol="1" spcCol="0" rtlCol="0" fromWordArt="0" anchor="t" anchorCtr="0" forceAA="0" compatLnSpc="1">
+            <a:prstTxWarp prst="textNoShape">
+              <a:avLst/>
+            </a:prstTxWarp>
+            <a:spAutoFit/>
+          </a:bodyPr>
+          <a:lstStyle/>
+          <a:p>
+            <a:r>
+              <a:rPr lang="en-US"/>
+              <a:t>We keep section D and discard the rest, narrowing the interval.</a:t>
+            </a:r>
+          </a:p>
+        </p:txBody>
+      </p:sp>
+      <p:sp>
+        <p:nvSpPr>
+          <p:cNvPr id="8" name="TextBox 7">
             <a:extLst>
               <a:ext uri="{FF2B5EF4-FFF2-40B4-BE49-F238E27FC236}">
-                <a16:creationId xmlns:a16="http://schemas.microsoft.com/office/drawing/2014/main" id="{A15696CB-F9B7-384F-3483-08C10816F169}"/>
+                <a16:creationId xmlns:a16="http://schemas.microsoft.com/office/drawing/2014/main" id="{70BCA920-79D4-4BB1-A691-CBBD45016F9D}"/>
               </a:ext>
             </a:extLst>
           </p:cNvPr>
-          <p:cNvSpPr>
-            <a:spLocks noGrp="1"/>
-          </p:cNvSpPr>
-          <p:nvPr>
-            <p:ph idx="1"/>
-          </p:nvPr>
-        </p:nvSpPr>
-        <p:spPr/>
-        <p:txBody>
-          <a:bodyPr vert="horz" lIns="91440" tIns="45720" rIns="91440" bIns="45720" rtlCol="0" anchor="t">
-            <a:normAutofit/>
+          <p:cNvSpPr txBox="1"/>
+          <p:nvPr/>
+        </p:nvSpPr>
+        <p:spPr>
+          <a:xfrm>
+            <a:off x="989757" y="4531392"/>
+            <a:ext cx="5575575" cy="369332"/>
+          </a:xfrm>
+          <a:prstGeom prst="rect">
+            <a:avLst/>
+          </a:prstGeom>
+          <a:noFill/>
+        </p:spPr>
+        <p:txBody>
+          <a:bodyPr rot="0" spcFirstLastPara="0" vertOverflow="overflow" horzOverflow="overflow" vert="horz" wrap="square" lIns="91440" tIns="45720" rIns="91440" bIns="45720" numCol="1" spcCol="0" rtlCol="0" fromWordArt="0" anchor="t" anchorCtr="0" forceAA="0" compatLnSpc="1">
+            <a:prstTxWarp prst="textNoShape">
+              <a:avLst/>
+            </a:prstTxWarp>
+            <a:spAutoFit/>
           </a:bodyPr>
           <a:lstStyle/>
           <a:p>
             <a:r>
-              <a:rPr lang="en-US" dirty="0"/>
-              <a:t>[explain performa</a:t>
-            </a:r>
-            <a:r>
-              <a:rPr lang="en-US"/>
-              <a:t>nce, both effectiveness, and complexity]</a:t>
-            </a:r>
-          </a:p>
-          <a:p>
-            <a:r>
-              <a:rPr lang="en-US" dirty="0"/>
-              <a:t>[trade-offs of </a:t>
-            </a:r>
-            <a:r>
-              <a:rPr lang="en-US" dirty="0" err="1"/>
-              <a:t>Arith</a:t>
-            </a:r>
-            <a:r>
-              <a:rPr lang="en-US" dirty="0"/>
-              <a:t> Code]</a:t>
-            </a:r>
-          </a:p>
-          <a:p>
-            <a:r>
-              <a:rPr lang="en-US"/>
-              <a:t>Valuable in image/video compression and scientific data storage.</a:t>
+              <a:rPr lang="en-US"/>
+              <a:t>Interval: [0, 0.6)</a:t>
             </a:r>
             <a:endParaRPr lang="en-US" dirty="0"/>
           </a:p>
-          <a:p>
-            <a:endParaRPr lang="en-US" dirty="0"/>
-          </a:p>
-        </p:txBody>
-      </p:sp>
+        </p:txBody>
+      </p:sp>
+      <p:sp>
+        <p:nvSpPr>
+          <p:cNvPr id="12" name="Rectangle 11">
+            <a:extLst>
+              <a:ext uri="{FF2B5EF4-FFF2-40B4-BE49-F238E27FC236}">
+                <a16:creationId xmlns:a16="http://schemas.microsoft.com/office/drawing/2014/main" id="{F17945B3-B3A4-9007-15B5-2A58CA1CCD52}"/>
+              </a:ext>
+            </a:extLst>
+          </p:cNvPr>
+          <p:cNvSpPr/>
+          <p:nvPr/>
+        </p:nvSpPr>
+        <p:spPr>
+          <a:xfrm>
+            <a:off x="991105" y="4064212"/>
+            <a:ext cx="9851061" cy="369515"/>
+          </a:xfrm>
+          <a:prstGeom prst="rect">
+            <a:avLst/>
+          </a:prstGeom>
+          <a:solidFill>
+            <a:schemeClr val="accent2"/>
+          </a:solidFill>
+          <a:ln>
+            <a:solidFill>
+              <a:schemeClr val="accent2"/>
+            </a:solidFill>
+          </a:ln>
+        </p:spPr>
+        <p:style>
+          <a:lnRef idx="2">
+            <a:schemeClr val="accent1">
+              <a:shade val="15000"/>
+            </a:schemeClr>
+          </a:lnRef>
+          <a:fillRef idx="1">
+            <a:schemeClr val="accent1"/>
+          </a:fillRef>
+          <a:effectRef idx="0">
+            <a:schemeClr val="accent1"/>
+          </a:effectRef>
+          <a:fontRef idx="minor">
+            <a:schemeClr val="lt1"/>
+          </a:fontRef>
+        </p:style>
+        <p:txBody>
+          <a:bodyPr rtlCol="0" anchor="ctr"/>
+          <a:lstStyle/>
+          <a:p>
+            <a:pPr algn="ctr"/>
+            <a:r>
+              <a:rPr lang="en-US"/>
+              <a:t>D: 60%</a:t>
+            </a:r>
+          </a:p>
+        </p:txBody>
+      </p:sp>
+      <p:sp>
+        <p:nvSpPr>
+          <p:cNvPr id="14" name="TextBox 13">
+            <a:extLst>
+              <a:ext uri="{FF2B5EF4-FFF2-40B4-BE49-F238E27FC236}">
+                <a16:creationId xmlns:a16="http://schemas.microsoft.com/office/drawing/2014/main" id="{33692C1A-A7A8-B20E-5A0A-CB5C7ED5DABC}"/>
+              </a:ext>
+            </a:extLst>
+          </p:cNvPr>
+          <p:cNvSpPr txBox="1"/>
+          <p:nvPr/>
+        </p:nvSpPr>
+        <p:spPr>
+          <a:xfrm>
+            <a:off x="775222" y="4066517"/>
+            <a:ext cx="598417" cy="369332"/>
+          </a:xfrm>
+          <a:prstGeom prst="rect">
+            <a:avLst/>
+          </a:prstGeom>
+          <a:noFill/>
+        </p:spPr>
+        <p:txBody>
+          <a:bodyPr rot="0" spcFirstLastPara="0" vertOverflow="overflow" horzOverflow="overflow" vert="horz" wrap="square" lIns="91440" tIns="45720" rIns="91440" bIns="45720" numCol="1" spcCol="0" rtlCol="0" fromWordArt="0" anchor="t" anchorCtr="0" forceAA="0" compatLnSpc="1">
+            <a:prstTxWarp prst="textNoShape">
+              <a:avLst/>
+            </a:prstTxWarp>
+            <a:spAutoFit/>
+          </a:bodyPr>
+          <a:lstStyle/>
+          <a:p>
+            <a:pPr algn="l"/>
+            <a:r>
+              <a:rPr lang="en-US"/>
+              <a:t>0.0</a:t>
+            </a:r>
+          </a:p>
+        </p:txBody>
+      </p:sp>
+      <p:sp>
+        <p:nvSpPr>
+          <p:cNvPr id="16" name="TextBox 15">
+            <a:extLst>
+              <a:ext uri="{FF2B5EF4-FFF2-40B4-BE49-F238E27FC236}">
+                <a16:creationId xmlns:a16="http://schemas.microsoft.com/office/drawing/2014/main" id="{5E9A5A61-CA45-8186-4B28-35953283125F}"/>
+              </a:ext>
+            </a:extLst>
+          </p:cNvPr>
+          <p:cNvSpPr txBox="1"/>
+          <p:nvPr/>
+        </p:nvSpPr>
+        <p:spPr>
+          <a:xfrm>
+            <a:off x="10563757" y="4066546"/>
+            <a:ext cx="594009" cy="369332"/>
+          </a:xfrm>
+          <a:prstGeom prst="rect">
+            <a:avLst/>
+          </a:prstGeom>
+          <a:noFill/>
+        </p:spPr>
+        <p:txBody>
+          <a:bodyPr rot="0" spcFirstLastPara="0" vertOverflow="overflow" horzOverflow="overflow" vert="horz" wrap="square" lIns="91440" tIns="45720" rIns="91440" bIns="45720" numCol="1" spcCol="0" rtlCol="0" fromWordArt="0" anchor="t" anchorCtr="0" forceAA="0" compatLnSpc="1">
+            <a:prstTxWarp prst="textNoShape">
+              <a:avLst/>
+            </a:prstTxWarp>
+            <a:spAutoFit/>
+          </a:bodyPr>
+          <a:lstStyle/>
+          <a:p>
+            <a:pPr algn="l"/>
+            <a:r>
+              <a:rPr lang="en-US"/>
+              <a:t>0.6</a:t>
+            </a:r>
+          </a:p>
+        </p:txBody>
+      </p:sp>
+      <p:cxnSp>
+        <p:nvCxnSpPr>
+          <p:cNvPr id="20" name="Straight Arrow Connector 19">
+            <a:extLst>
+              <a:ext uri="{FF2B5EF4-FFF2-40B4-BE49-F238E27FC236}">
+                <a16:creationId xmlns:a16="http://schemas.microsoft.com/office/drawing/2014/main" id="{BB4F535E-5537-643A-39EE-A711589C88E2}"/>
+              </a:ext>
+            </a:extLst>
+          </p:cNvPr>
+          <p:cNvCxnSpPr/>
+          <p:nvPr/>
+        </p:nvCxnSpPr>
+        <p:spPr>
+          <a:xfrm>
+            <a:off x="982250" y="4442794"/>
+            <a:ext cx="9882952" cy="15119"/>
+          </a:xfrm>
+          <a:prstGeom prst="straightConnector1">
+            <a:avLst/>
+          </a:prstGeom>
+        </p:spPr>
+        <p:style>
+          <a:lnRef idx="2">
+            <a:schemeClr val="accent1"/>
+          </a:lnRef>
+          <a:fillRef idx="0">
+            <a:schemeClr val="accent1"/>
+          </a:fillRef>
+          <a:effectRef idx="1">
+            <a:schemeClr val="accent1"/>
+          </a:effectRef>
+          <a:fontRef idx="minor">
+            <a:schemeClr val="tx1"/>
+          </a:fontRef>
+        </p:style>
+      </p:cxnSp>
     </p:spTree>
     <p:extLst>
       <p:ext uri="{BB962C8B-B14F-4D97-AF65-F5344CB8AC3E}">
-        <p14:creationId xmlns:p14="http://schemas.microsoft.com/office/powerpoint/2010/main" val="653080710"/>
+        <p14:creationId xmlns:p14="http://schemas.microsoft.com/office/powerpoint/2010/main" val="2839988328"/>
       </p:ext>
     </p:extLst>
   </p:cSld>
   <p:clrMapOvr>
     <a:masterClrMapping/>
   </p:clrMapOvr>
+  <mc:AlternateContent xmlns:mc="http://schemas.openxmlformats.org/markup-compatibility/2006" xmlns:p159="http://schemas.microsoft.com/office/powerpoint/2015/09/main">
+    <mc:Choice Requires="p159">
+      <p:transition xmlns:p14="http://schemas.microsoft.com/office/powerpoint/2010/main" spd="slow" p14:dur="2000">
+        <p159:morph option="byObject"/>
+      </p:transition>
+    </mc:Choice>
+    <mc:Fallback xmlns="">
+      <p:transition spd="slow">
+        <p:fade/>
+      </p:transition>
+    </mc:Fallback>
+  </mc:AlternateContent>
+</p:sld>
+</file>
+
+<file path=ppt/slides/slide6.xml><?xml version="1.0" encoding="utf-8"?>
+<p:sld xmlns:a="http://schemas.openxmlformats.org/drawingml/2006/main" xmlns:r="http://schemas.openxmlformats.org/officeDocument/2006/relationships" xmlns:p="http://schemas.openxmlformats.org/presentationml/2006/main">
+  <p:cSld>
+    <p:spTree>
+      <p:nvGrpSpPr>
+        <p:cNvPr id="1" name="">
+          <a:extLst>
+            <a:ext uri="{FF2B5EF4-FFF2-40B4-BE49-F238E27FC236}">
+              <a16:creationId xmlns:a16="http://schemas.microsoft.com/office/drawing/2014/main" id="{F08E41B0-02C0-3CD7-2402-EF21FD97EF6E}"/>
+            </a:ext>
+          </a:extLst>
+        </p:cNvPr>
+        <p:cNvGrpSpPr/>
+        <p:nvPr/>
+      </p:nvGrpSpPr>
+      <p:grpSpPr>
+        <a:xfrm>
+          <a:off x="0" y="0"/>
+          <a:ext cx="0" cy="0"/>
+          <a:chOff x="0" y="0"/>
+          <a:chExt cx="0" cy="0"/>
+        </a:xfrm>
+      </p:grpSpPr>
+      <p:sp>
+        <p:nvSpPr>
+          <p:cNvPr id="10" name="Rectangle 9">
+            <a:extLst>
+              <a:ext uri="{FF2B5EF4-FFF2-40B4-BE49-F238E27FC236}">
+                <a16:creationId xmlns:a16="http://schemas.microsoft.com/office/drawing/2014/main" id="{FD47261D-347E-48A0-9553-B3C509C56C1C}"/>
+              </a:ext>
+            </a:extLst>
+          </p:cNvPr>
+          <p:cNvSpPr/>
+          <p:nvPr/>
+        </p:nvSpPr>
+        <p:spPr>
+          <a:xfrm flipH="1">
+            <a:off x="7149397" y="4064212"/>
+            <a:ext cx="3718399" cy="369515"/>
+          </a:xfrm>
+          <a:prstGeom prst="rect">
+            <a:avLst/>
+          </a:prstGeom>
+          <a:solidFill>
+            <a:schemeClr val="accent2">
+              <a:lumMod val="50000"/>
+            </a:schemeClr>
+          </a:solidFill>
+          <a:ln>
+            <a:solidFill>
+              <a:schemeClr val="accent2">
+                <a:lumMod val="50000"/>
+              </a:schemeClr>
+            </a:solidFill>
+          </a:ln>
+        </p:spPr>
+        <p:style>
+          <a:lnRef idx="2">
+            <a:schemeClr val="accent1">
+              <a:shade val="15000"/>
+            </a:schemeClr>
+          </a:lnRef>
+          <a:fillRef idx="1">
+            <a:schemeClr val="accent1"/>
+          </a:fillRef>
+          <a:effectRef idx="0">
+            <a:schemeClr val="accent1"/>
+          </a:effectRef>
+          <a:fontRef idx="minor">
+            <a:schemeClr val="lt1"/>
+          </a:fontRef>
+        </p:style>
+        <p:txBody>
+          <a:bodyPr lIns="91440" tIns="45720" rIns="91440" bIns="45720" rtlCol="0" anchor="ctr"/>
+          <a:lstStyle/>
+          <a:p>
+            <a:pPr algn="ctr"/>
+            <a:r>
+              <a:rPr lang="en-US"/>
+              <a:t>A: 40%</a:t>
+            </a:r>
+          </a:p>
+        </p:txBody>
+      </p:sp>
+      <p:sp>
+        <p:nvSpPr>
+          <p:cNvPr id="2" name="Rectangle 1">
+            <a:extLst>
+              <a:ext uri="{FF2B5EF4-FFF2-40B4-BE49-F238E27FC236}">
+                <a16:creationId xmlns:a16="http://schemas.microsoft.com/office/drawing/2014/main" id="{0A148090-9A05-6263-0422-574192B8F1DF}"/>
+              </a:ext>
+            </a:extLst>
+          </p:cNvPr>
+          <p:cNvSpPr/>
+          <p:nvPr/>
+        </p:nvSpPr>
+        <p:spPr>
+          <a:xfrm>
+            <a:off x="981336" y="4064212"/>
+            <a:ext cx="6148523" cy="369515"/>
+          </a:xfrm>
+          <a:prstGeom prst="rect">
+            <a:avLst/>
+          </a:prstGeom>
+          <a:solidFill>
+            <a:schemeClr val="accent2">
+              <a:lumMod val="75000"/>
+            </a:schemeClr>
+          </a:solidFill>
+          <a:ln>
+            <a:solidFill>
+              <a:schemeClr val="accent2">
+                <a:lumMod val="75000"/>
+              </a:schemeClr>
+            </a:solidFill>
+          </a:ln>
+        </p:spPr>
+        <p:style>
+          <a:lnRef idx="2">
+            <a:schemeClr val="accent1">
+              <a:shade val="15000"/>
+            </a:schemeClr>
+          </a:lnRef>
+          <a:fillRef idx="1">
+            <a:schemeClr val="accent1"/>
+          </a:fillRef>
+          <a:effectRef idx="0">
+            <a:schemeClr val="accent1"/>
+          </a:effectRef>
+          <a:fontRef idx="minor">
+            <a:schemeClr val="lt1"/>
+          </a:fontRef>
+        </p:style>
+        <p:txBody>
+          <a:bodyPr rtlCol="0" anchor="ctr"/>
+          <a:lstStyle/>
+          <a:p>
+            <a:pPr algn="ctr"/>
+            <a:r>
+              <a:rPr lang="en-US"/>
+              <a:t>D: 60%</a:t>
+            </a:r>
+          </a:p>
+        </p:txBody>
+      </p:sp>
+      <p:cxnSp>
+        <p:nvCxnSpPr>
+          <p:cNvPr id="4" name="Straight Arrow Connector 3">
+            <a:extLst>
+              <a:ext uri="{FF2B5EF4-FFF2-40B4-BE49-F238E27FC236}">
+                <a16:creationId xmlns:a16="http://schemas.microsoft.com/office/drawing/2014/main" id="{8EBA6E5D-3687-AF03-463E-5FCFAB9C54C9}"/>
+              </a:ext>
+            </a:extLst>
+          </p:cNvPr>
+          <p:cNvCxnSpPr/>
+          <p:nvPr/>
+        </p:nvCxnSpPr>
+        <p:spPr>
+          <a:xfrm>
+            <a:off x="982250" y="4442794"/>
+            <a:ext cx="9882952" cy="15119"/>
+          </a:xfrm>
+          <a:prstGeom prst="straightConnector1">
+            <a:avLst/>
+          </a:prstGeom>
+        </p:spPr>
+        <p:style>
+          <a:lnRef idx="2">
+            <a:schemeClr val="accent1"/>
+          </a:lnRef>
+          <a:fillRef idx="0">
+            <a:schemeClr val="accent1"/>
+          </a:fillRef>
+          <a:effectRef idx="1">
+            <a:schemeClr val="accent1"/>
+          </a:effectRef>
+          <a:fontRef idx="minor">
+            <a:schemeClr val="tx1"/>
+          </a:fontRef>
+        </p:style>
+      </p:cxnSp>
+      <p:sp>
+        <p:nvSpPr>
+          <p:cNvPr id="5" name="TextBox 4">
+            <a:extLst>
+              <a:ext uri="{FF2B5EF4-FFF2-40B4-BE49-F238E27FC236}">
+                <a16:creationId xmlns:a16="http://schemas.microsoft.com/office/drawing/2014/main" id="{BEA45169-16F7-5992-9DA5-2FC87A9B98D5}"/>
+              </a:ext>
+            </a:extLst>
+          </p:cNvPr>
+          <p:cNvSpPr txBox="1"/>
+          <p:nvPr/>
+        </p:nvSpPr>
+        <p:spPr>
+          <a:xfrm>
+            <a:off x="149604" y="272008"/>
+            <a:ext cx="5575575" cy="369332"/>
+          </a:xfrm>
+          <a:prstGeom prst="rect">
+            <a:avLst/>
+          </a:prstGeom>
+          <a:noFill/>
+        </p:spPr>
+        <p:txBody>
+          <a:bodyPr rot="0" spcFirstLastPara="0" vertOverflow="overflow" horzOverflow="overflow" vert="horz" wrap="square" lIns="91440" tIns="45720" rIns="91440" bIns="45720" numCol="1" spcCol="0" rtlCol="0" fromWordArt="0" anchor="t" anchorCtr="0" forceAA="0" compatLnSpc="1">
+            <a:prstTxWarp prst="textNoShape">
+              <a:avLst/>
+            </a:prstTxWarp>
+            <a:spAutoFit/>
+          </a:bodyPr>
+          <a:lstStyle/>
+          <a:p>
+            <a:r>
+              <a:rPr lang="en-US"/>
+              <a:t>We continue to split until a small interval remains.</a:t>
+            </a:r>
+          </a:p>
+        </p:txBody>
+      </p:sp>
+      <p:sp>
+        <p:nvSpPr>
+          <p:cNvPr id="6" name="TextBox 5">
+            <a:extLst>
+              <a:ext uri="{FF2B5EF4-FFF2-40B4-BE49-F238E27FC236}">
+                <a16:creationId xmlns:a16="http://schemas.microsoft.com/office/drawing/2014/main" id="{7CE5F618-0DED-0A27-E77A-377283FB72CA}"/>
+              </a:ext>
+            </a:extLst>
+          </p:cNvPr>
+          <p:cNvSpPr txBox="1"/>
+          <p:nvPr/>
+        </p:nvSpPr>
+        <p:spPr>
+          <a:xfrm>
+            <a:off x="775222" y="4066517"/>
+            <a:ext cx="598417" cy="369332"/>
+          </a:xfrm>
+          <a:prstGeom prst="rect">
+            <a:avLst/>
+          </a:prstGeom>
+          <a:noFill/>
+        </p:spPr>
+        <p:txBody>
+          <a:bodyPr rot="0" spcFirstLastPara="0" vertOverflow="overflow" horzOverflow="overflow" vert="horz" wrap="square" lIns="91440" tIns="45720" rIns="91440" bIns="45720" numCol="1" spcCol="0" rtlCol="0" fromWordArt="0" anchor="t" anchorCtr="0" forceAA="0" compatLnSpc="1">
+            <a:prstTxWarp prst="textNoShape">
+              <a:avLst/>
+            </a:prstTxWarp>
+            <a:spAutoFit/>
+          </a:bodyPr>
+          <a:lstStyle/>
+          <a:p>
+            <a:pPr algn="l"/>
+            <a:r>
+              <a:rPr lang="en-US"/>
+              <a:t>0.0</a:t>
+            </a:r>
+          </a:p>
+        </p:txBody>
+      </p:sp>
+      <p:sp>
+        <p:nvSpPr>
+          <p:cNvPr id="7" name="TextBox 6">
+            <a:extLst>
+              <a:ext uri="{FF2B5EF4-FFF2-40B4-BE49-F238E27FC236}">
+                <a16:creationId xmlns:a16="http://schemas.microsoft.com/office/drawing/2014/main" id="{D751262D-E083-F6EB-6063-FAD391915FC2}"/>
+              </a:ext>
+            </a:extLst>
+          </p:cNvPr>
+          <p:cNvSpPr txBox="1"/>
+          <p:nvPr/>
+        </p:nvSpPr>
+        <p:spPr>
+          <a:xfrm>
+            <a:off x="10563757" y="4066546"/>
+            <a:ext cx="594009" cy="369332"/>
+          </a:xfrm>
+          <a:prstGeom prst="rect">
+            <a:avLst/>
+          </a:prstGeom>
+          <a:noFill/>
+        </p:spPr>
+        <p:txBody>
+          <a:bodyPr rot="0" spcFirstLastPara="0" vertOverflow="overflow" horzOverflow="overflow" vert="horz" wrap="square" lIns="91440" tIns="45720" rIns="91440" bIns="45720" numCol="1" spcCol="0" rtlCol="0" fromWordArt="0" anchor="t" anchorCtr="0" forceAA="0" compatLnSpc="1">
+            <a:prstTxWarp prst="textNoShape">
+              <a:avLst/>
+            </a:prstTxWarp>
+            <a:spAutoFit/>
+          </a:bodyPr>
+          <a:lstStyle/>
+          <a:p>
+            <a:pPr algn="l"/>
+            <a:r>
+              <a:rPr lang="en-US"/>
+              <a:t>0.6</a:t>
+            </a:r>
+          </a:p>
+        </p:txBody>
+      </p:sp>
+      <p:sp>
+        <p:nvSpPr>
+          <p:cNvPr id="8" name="TextBox 7">
+            <a:extLst>
+              <a:ext uri="{FF2B5EF4-FFF2-40B4-BE49-F238E27FC236}">
+                <a16:creationId xmlns:a16="http://schemas.microsoft.com/office/drawing/2014/main" id="{177A58AA-6876-CB33-1D48-E65FF4EFACE7}"/>
+              </a:ext>
+            </a:extLst>
+          </p:cNvPr>
+          <p:cNvSpPr txBox="1"/>
+          <p:nvPr/>
+        </p:nvSpPr>
+        <p:spPr>
+          <a:xfrm>
+            <a:off x="979988" y="4502084"/>
+            <a:ext cx="5575575" cy="369332"/>
+          </a:xfrm>
+          <a:prstGeom prst="rect">
+            <a:avLst/>
+          </a:prstGeom>
+          <a:noFill/>
+        </p:spPr>
+        <p:txBody>
+          <a:bodyPr rot="0" spcFirstLastPara="0" vertOverflow="overflow" horzOverflow="overflow" vert="horz" wrap="square" lIns="91440" tIns="45720" rIns="91440" bIns="45720" numCol="1" spcCol="0" rtlCol="0" fromWordArt="0" anchor="t" anchorCtr="0" forceAA="0" compatLnSpc="1">
+            <a:prstTxWarp prst="textNoShape">
+              <a:avLst/>
+            </a:prstTxWarp>
+            <a:spAutoFit/>
+          </a:bodyPr>
+          <a:lstStyle/>
+          <a:p>
+            <a:r>
+              <a:rPr lang="en-US"/>
+              <a:t>Interval: [0, 0.6)</a:t>
+            </a:r>
+            <a:endParaRPr lang="en-US" dirty="0"/>
+          </a:p>
+        </p:txBody>
+      </p:sp>
+      <p:sp>
+        <p:nvSpPr>
+          <p:cNvPr id="11" name="TextBox 10">
+            <a:extLst>
+              <a:ext uri="{FF2B5EF4-FFF2-40B4-BE49-F238E27FC236}">
+                <a16:creationId xmlns:a16="http://schemas.microsoft.com/office/drawing/2014/main" id="{FDAEF427-7AAB-7BA3-B114-F3AB19A5C911}"/>
+              </a:ext>
+            </a:extLst>
+          </p:cNvPr>
+          <p:cNvSpPr txBox="1"/>
+          <p:nvPr/>
+        </p:nvSpPr>
+        <p:spPr>
+          <a:xfrm>
+            <a:off x="6793068" y="4066517"/>
+            <a:ext cx="676570" cy="369332"/>
+          </a:xfrm>
+          <a:prstGeom prst="rect">
+            <a:avLst/>
+          </a:prstGeom>
+          <a:noFill/>
+        </p:spPr>
+        <p:txBody>
+          <a:bodyPr rot="0" spcFirstLastPara="0" vertOverflow="overflow" horzOverflow="overflow" vert="horz" wrap="square" lIns="91440" tIns="45720" rIns="91440" bIns="45720" numCol="1" spcCol="0" rtlCol="0" fromWordArt="0" anchor="t" anchorCtr="0" forceAA="0" compatLnSpc="1">
+            <a:prstTxWarp prst="textNoShape">
+              <a:avLst/>
+            </a:prstTxWarp>
+            <a:spAutoFit/>
+          </a:bodyPr>
+          <a:lstStyle/>
+          <a:p>
+            <a:pPr algn="l"/>
+            <a:r>
+              <a:rPr lang="en-US"/>
+              <a:t>0.36</a:t>
+            </a:r>
+          </a:p>
+        </p:txBody>
+      </p:sp>
+    </p:spTree>
+    <p:extLst>
+      <p:ext uri="{BB962C8B-B14F-4D97-AF65-F5344CB8AC3E}">
+        <p14:creationId xmlns:p14="http://schemas.microsoft.com/office/powerpoint/2010/main" val="3397001397"/>
+      </p:ext>
+    </p:extLst>
+  </p:cSld>
+  <p:clrMapOvr>
+    <a:masterClrMapping/>
+  </p:clrMapOvr>
+</p:sld>
+</file>
+
+<file path=ppt/slides/slide7.xml><?xml version="1.0" encoding="utf-8"?>
+<p:sld xmlns:a="http://schemas.openxmlformats.org/drawingml/2006/main" xmlns:r="http://schemas.openxmlformats.org/officeDocument/2006/relationships" xmlns:p="http://schemas.openxmlformats.org/presentationml/2006/main">
+  <p:cSld>
+    <p:spTree>
+      <p:nvGrpSpPr>
+        <p:cNvPr id="1" name="">
+          <a:extLst>
+            <a:ext uri="{FF2B5EF4-FFF2-40B4-BE49-F238E27FC236}">
+              <a16:creationId xmlns:a16="http://schemas.microsoft.com/office/drawing/2014/main" id="{151C13D3-C7A4-6411-DEEA-CBFBC35969F3}"/>
+            </a:ext>
+          </a:extLst>
+        </p:cNvPr>
+        <p:cNvGrpSpPr/>
+        <p:nvPr/>
+      </p:nvGrpSpPr>
+      <p:grpSpPr>
+        <a:xfrm>
+          <a:off x="0" y="0"/>
+          <a:ext cx="0" cy="0"/>
+          <a:chOff x="0" y="0"/>
+          <a:chExt cx="0" cy="0"/>
+        </a:xfrm>
+      </p:grpSpPr>
+      <p:sp>
+        <p:nvSpPr>
+          <p:cNvPr id="10" name="Rectangle 9">
+            <a:extLst>
+              <a:ext uri="{FF2B5EF4-FFF2-40B4-BE49-F238E27FC236}">
+                <a16:creationId xmlns:a16="http://schemas.microsoft.com/office/drawing/2014/main" id="{886D2355-081C-CDAF-FE36-221166013432}"/>
+              </a:ext>
+            </a:extLst>
+          </p:cNvPr>
+          <p:cNvSpPr/>
+          <p:nvPr/>
+        </p:nvSpPr>
+        <p:spPr>
+          <a:xfrm flipH="1">
+            <a:off x="1014321" y="4064212"/>
+            <a:ext cx="9853475" cy="369515"/>
+          </a:xfrm>
+          <a:prstGeom prst="rect">
+            <a:avLst/>
+          </a:prstGeom>
+          <a:solidFill>
+            <a:schemeClr val="accent2">
+              <a:lumMod val="50000"/>
+            </a:schemeClr>
+          </a:solidFill>
+          <a:ln>
+            <a:solidFill>
+              <a:schemeClr val="accent2">
+                <a:lumMod val="50000"/>
+              </a:schemeClr>
+            </a:solidFill>
+          </a:ln>
+        </p:spPr>
+        <p:style>
+          <a:lnRef idx="2">
+            <a:schemeClr val="accent1">
+              <a:shade val="15000"/>
+            </a:schemeClr>
+          </a:lnRef>
+          <a:fillRef idx="1">
+            <a:schemeClr val="accent1"/>
+          </a:fillRef>
+          <a:effectRef idx="0">
+            <a:schemeClr val="accent1"/>
+          </a:effectRef>
+          <a:fontRef idx="minor">
+            <a:schemeClr val="lt1"/>
+          </a:fontRef>
+        </p:style>
+        <p:txBody>
+          <a:bodyPr lIns="91440" tIns="45720" rIns="91440" bIns="45720" rtlCol="0" anchor="ctr"/>
+          <a:lstStyle/>
+          <a:p>
+            <a:pPr algn="ctr"/>
+            <a:r>
+              <a:rPr lang="en-US"/>
+              <a:t>A: 40%</a:t>
+            </a:r>
+          </a:p>
+        </p:txBody>
+      </p:sp>
+      <p:cxnSp>
+        <p:nvCxnSpPr>
+          <p:cNvPr id="4" name="Straight Arrow Connector 3">
+            <a:extLst>
+              <a:ext uri="{FF2B5EF4-FFF2-40B4-BE49-F238E27FC236}">
+                <a16:creationId xmlns:a16="http://schemas.microsoft.com/office/drawing/2014/main" id="{A27C900F-B019-16E3-12E5-553E1989B543}"/>
+              </a:ext>
+            </a:extLst>
+          </p:cNvPr>
+          <p:cNvCxnSpPr/>
+          <p:nvPr/>
+        </p:nvCxnSpPr>
+        <p:spPr>
+          <a:xfrm>
+            <a:off x="982250" y="4442794"/>
+            <a:ext cx="9882952" cy="15119"/>
+          </a:xfrm>
+          <a:prstGeom prst="straightConnector1">
+            <a:avLst/>
+          </a:prstGeom>
+        </p:spPr>
+        <p:style>
+          <a:lnRef idx="2">
+            <a:schemeClr val="accent1"/>
+          </a:lnRef>
+          <a:fillRef idx="0">
+            <a:schemeClr val="accent1"/>
+          </a:fillRef>
+          <a:effectRef idx="1">
+            <a:schemeClr val="accent1"/>
+          </a:effectRef>
+          <a:fontRef idx="minor">
+            <a:schemeClr val="tx1"/>
+          </a:fontRef>
+        </p:style>
+      </p:cxnSp>
+      <p:sp>
+        <p:nvSpPr>
+          <p:cNvPr id="5" name="TextBox 4">
+            <a:extLst>
+              <a:ext uri="{FF2B5EF4-FFF2-40B4-BE49-F238E27FC236}">
+                <a16:creationId xmlns:a16="http://schemas.microsoft.com/office/drawing/2014/main" id="{3B6C2B3F-6CE9-43A6-4C75-891CD617319A}"/>
+              </a:ext>
+            </a:extLst>
+          </p:cNvPr>
+          <p:cNvSpPr txBox="1"/>
+          <p:nvPr/>
+        </p:nvSpPr>
+        <p:spPr>
+          <a:xfrm>
+            <a:off x="149604" y="272008"/>
+            <a:ext cx="5575575" cy="369332"/>
+          </a:xfrm>
+          <a:prstGeom prst="rect">
+            <a:avLst/>
+          </a:prstGeom>
+          <a:noFill/>
+        </p:spPr>
+        <p:txBody>
+          <a:bodyPr rot="0" spcFirstLastPara="0" vertOverflow="overflow" horzOverflow="overflow" vert="horz" wrap="square" lIns="91440" tIns="45720" rIns="91440" bIns="45720" numCol="1" spcCol="0" rtlCol="0" fromWordArt="0" anchor="t" anchorCtr="0" forceAA="0" compatLnSpc="1">
+            <a:prstTxWarp prst="textNoShape">
+              <a:avLst/>
+            </a:prstTxWarp>
+            <a:spAutoFit/>
+          </a:bodyPr>
+          <a:lstStyle/>
+          <a:p>
+            <a:r>
+              <a:rPr lang="en-US"/>
+              <a:t>We continue to split until a small interval remains.</a:t>
+            </a:r>
+          </a:p>
+        </p:txBody>
+      </p:sp>
+      <p:sp>
+        <p:nvSpPr>
+          <p:cNvPr id="7" name="TextBox 6">
+            <a:extLst>
+              <a:ext uri="{FF2B5EF4-FFF2-40B4-BE49-F238E27FC236}">
+                <a16:creationId xmlns:a16="http://schemas.microsoft.com/office/drawing/2014/main" id="{468A1452-7482-2B0F-992C-E6A2CB7C84B3}"/>
+              </a:ext>
+            </a:extLst>
+          </p:cNvPr>
+          <p:cNvSpPr txBox="1"/>
+          <p:nvPr/>
+        </p:nvSpPr>
+        <p:spPr>
+          <a:xfrm>
+            <a:off x="10563757" y="4066546"/>
+            <a:ext cx="594009" cy="369332"/>
+          </a:xfrm>
+          <a:prstGeom prst="rect">
+            <a:avLst/>
+          </a:prstGeom>
+          <a:noFill/>
+        </p:spPr>
+        <p:txBody>
+          <a:bodyPr rot="0" spcFirstLastPara="0" vertOverflow="overflow" horzOverflow="overflow" vert="horz" wrap="square" lIns="91440" tIns="45720" rIns="91440" bIns="45720" numCol="1" spcCol="0" rtlCol="0" fromWordArt="0" anchor="t" anchorCtr="0" forceAA="0" compatLnSpc="1">
+            <a:prstTxWarp prst="textNoShape">
+              <a:avLst/>
+            </a:prstTxWarp>
+            <a:spAutoFit/>
+          </a:bodyPr>
+          <a:lstStyle/>
+          <a:p>
+            <a:pPr algn="l"/>
+            <a:r>
+              <a:rPr lang="en-US"/>
+              <a:t>0.6</a:t>
+            </a:r>
+          </a:p>
+        </p:txBody>
+      </p:sp>
+      <p:sp>
+        <p:nvSpPr>
+          <p:cNvPr id="8" name="TextBox 7">
+            <a:extLst>
+              <a:ext uri="{FF2B5EF4-FFF2-40B4-BE49-F238E27FC236}">
+                <a16:creationId xmlns:a16="http://schemas.microsoft.com/office/drawing/2014/main" id="{7926B3BB-FA4C-ED5F-E4F0-8E2A0ED8F36E}"/>
+              </a:ext>
+            </a:extLst>
+          </p:cNvPr>
+          <p:cNvSpPr txBox="1"/>
+          <p:nvPr/>
+        </p:nvSpPr>
+        <p:spPr>
+          <a:xfrm>
+            <a:off x="979988" y="4502084"/>
+            <a:ext cx="5575575" cy="369332"/>
+          </a:xfrm>
+          <a:prstGeom prst="rect">
+            <a:avLst/>
+          </a:prstGeom>
+          <a:noFill/>
+        </p:spPr>
+        <p:txBody>
+          <a:bodyPr rot="0" spcFirstLastPara="0" vertOverflow="overflow" horzOverflow="overflow" vert="horz" wrap="square" lIns="91440" tIns="45720" rIns="91440" bIns="45720" numCol="1" spcCol="0" rtlCol="0" fromWordArt="0" anchor="t" anchorCtr="0" forceAA="0" compatLnSpc="1">
+            <a:prstTxWarp prst="textNoShape">
+              <a:avLst/>
+            </a:prstTxWarp>
+            <a:spAutoFit/>
+          </a:bodyPr>
+          <a:lstStyle/>
+          <a:p>
+            <a:r>
+              <a:rPr lang="en-US"/>
+              <a:t>Interval: [0.36, 0.6)</a:t>
+            </a:r>
+            <a:endParaRPr lang="en-US" dirty="0"/>
+          </a:p>
+        </p:txBody>
+      </p:sp>
+      <p:sp>
+        <p:nvSpPr>
+          <p:cNvPr id="11" name="TextBox 10">
+            <a:extLst>
+              <a:ext uri="{FF2B5EF4-FFF2-40B4-BE49-F238E27FC236}">
+                <a16:creationId xmlns:a16="http://schemas.microsoft.com/office/drawing/2014/main" id="{37462C22-9AA3-1FBF-7204-36A7944A8DB9}"/>
+              </a:ext>
+            </a:extLst>
+          </p:cNvPr>
+          <p:cNvSpPr txBox="1"/>
+          <p:nvPr/>
+        </p:nvSpPr>
+        <p:spPr>
+          <a:xfrm>
+            <a:off x="638453" y="4076286"/>
+            <a:ext cx="676570" cy="369332"/>
+          </a:xfrm>
+          <a:prstGeom prst="rect">
+            <a:avLst/>
+          </a:prstGeom>
+          <a:noFill/>
+        </p:spPr>
+        <p:txBody>
+          <a:bodyPr rot="0" spcFirstLastPara="0" vertOverflow="overflow" horzOverflow="overflow" vert="horz" wrap="square" lIns="91440" tIns="45720" rIns="91440" bIns="45720" numCol="1" spcCol="0" rtlCol="0" fromWordArt="0" anchor="t" anchorCtr="0" forceAA="0" compatLnSpc="1">
+            <a:prstTxWarp prst="textNoShape">
+              <a:avLst/>
+            </a:prstTxWarp>
+            <a:spAutoFit/>
+          </a:bodyPr>
+          <a:lstStyle/>
+          <a:p>
+            <a:pPr algn="l"/>
+            <a:r>
+              <a:rPr lang="en-US"/>
+              <a:t>0.36</a:t>
+            </a:r>
+          </a:p>
+        </p:txBody>
+      </p:sp>
+    </p:spTree>
+    <p:extLst>
+      <p:ext uri="{BB962C8B-B14F-4D97-AF65-F5344CB8AC3E}">
+        <p14:creationId xmlns:p14="http://schemas.microsoft.com/office/powerpoint/2010/main" val="414150075"/>
+      </p:ext>
+    </p:extLst>
+  </p:cSld>
+  <p:clrMapOvr>
+    <a:masterClrMapping/>
+  </p:clrMapOvr>
+  <mc:AlternateContent xmlns:mc="http://schemas.openxmlformats.org/markup-compatibility/2006" xmlns:p159="http://schemas.microsoft.com/office/powerpoint/2015/09/main">
+    <mc:Choice Requires="p159">
+      <p:transition xmlns:p14="http://schemas.microsoft.com/office/powerpoint/2010/main" spd="slow" p14:dur="2000">
+        <p159:morph option="byObject"/>
+      </p:transition>
+    </mc:Choice>
+    <mc:Fallback xmlns="">
+      <p:transition spd="slow">
+        <p:fade/>
+      </p:transition>
+    </mc:Fallback>
+  </mc:AlternateContent>
+</p:sld>
+</file>
+
+<file path=ppt/slides/slide8.xml><?xml version="1.0" encoding="utf-8"?>
+<p:sld xmlns:a="http://schemas.openxmlformats.org/drawingml/2006/main" xmlns:r="http://schemas.openxmlformats.org/officeDocument/2006/relationships" xmlns:p="http://schemas.openxmlformats.org/presentationml/2006/main">
+  <p:cSld>
+    <p:spTree>
+      <p:nvGrpSpPr>
+        <p:cNvPr id="1" name="">
+          <a:extLst>
+            <a:ext uri="{FF2B5EF4-FFF2-40B4-BE49-F238E27FC236}">
+              <a16:creationId xmlns:a16="http://schemas.microsoft.com/office/drawing/2014/main" id="{19CA9878-49D7-22D3-059E-EB32D6E8B8F2}"/>
+            </a:ext>
+          </a:extLst>
+        </p:cNvPr>
+        <p:cNvGrpSpPr/>
+        <p:nvPr/>
+      </p:nvGrpSpPr>
+      <p:grpSpPr>
+        <a:xfrm>
+          <a:off x="0" y="0"/>
+          <a:ext cx="0" cy="0"/>
+          <a:chOff x="0" y="0"/>
+          <a:chExt cx="0" cy="0"/>
+        </a:xfrm>
+      </p:grpSpPr>
+      <p:sp>
+        <p:nvSpPr>
+          <p:cNvPr id="9" name="Rectangle 8">
+            <a:extLst>
+              <a:ext uri="{FF2B5EF4-FFF2-40B4-BE49-F238E27FC236}">
+                <a16:creationId xmlns:a16="http://schemas.microsoft.com/office/drawing/2014/main" id="{89486DCB-1AC5-2EEA-2356-D8D724F1014B}"/>
+              </a:ext>
+            </a:extLst>
+          </p:cNvPr>
+          <p:cNvSpPr/>
+          <p:nvPr/>
+        </p:nvSpPr>
+        <p:spPr>
+          <a:xfrm flipH="1">
+            <a:off x="7149397" y="4064212"/>
+            <a:ext cx="3718399" cy="369515"/>
+          </a:xfrm>
+          <a:prstGeom prst="rect">
+            <a:avLst/>
+          </a:prstGeom>
+          <a:solidFill>
+            <a:srgbClr val="451D08"/>
+          </a:solidFill>
+          <a:ln>
+            <a:solidFill>
+              <a:srgbClr val="451D08"/>
+            </a:solidFill>
+          </a:ln>
+        </p:spPr>
+        <p:style>
+          <a:lnRef idx="2">
+            <a:schemeClr val="accent1">
+              <a:shade val="15000"/>
+            </a:schemeClr>
+          </a:lnRef>
+          <a:fillRef idx="1">
+            <a:schemeClr val="accent1"/>
+          </a:fillRef>
+          <a:effectRef idx="0">
+            <a:schemeClr val="accent1"/>
+          </a:effectRef>
+          <a:fontRef idx="minor">
+            <a:schemeClr val="lt1"/>
+          </a:fontRef>
+        </p:style>
+        <p:txBody>
+          <a:bodyPr lIns="91440" tIns="45720" rIns="91440" bIns="45720" rtlCol="0" anchor="ctr"/>
+          <a:lstStyle/>
+          <a:p>
+            <a:pPr algn="ctr"/>
+            <a:r>
+              <a:rPr lang="en-US"/>
+              <a:t>A: 40%</a:t>
+            </a:r>
+          </a:p>
+        </p:txBody>
+      </p:sp>
+      <p:cxnSp>
+        <p:nvCxnSpPr>
+          <p:cNvPr id="4" name="Straight Arrow Connector 3">
+            <a:extLst>
+              <a:ext uri="{FF2B5EF4-FFF2-40B4-BE49-F238E27FC236}">
+                <a16:creationId xmlns:a16="http://schemas.microsoft.com/office/drawing/2014/main" id="{E50BB5E8-DF06-48CE-6C3D-9DA1A65481A1}"/>
+              </a:ext>
+            </a:extLst>
+          </p:cNvPr>
+          <p:cNvCxnSpPr/>
+          <p:nvPr/>
+        </p:nvCxnSpPr>
+        <p:spPr>
+          <a:xfrm>
+            <a:off x="982250" y="4442794"/>
+            <a:ext cx="9882952" cy="15119"/>
+          </a:xfrm>
+          <a:prstGeom prst="straightConnector1">
+            <a:avLst/>
+          </a:prstGeom>
+        </p:spPr>
+        <p:style>
+          <a:lnRef idx="2">
+            <a:schemeClr val="accent1"/>
+          </a:lnRef>
+          <a:fillRef idx="0">
+            <a:schemeClr val="accent1"/>
+          </a:fillRef>
+          <a:effectRef idx="1">
+            <a:schemeClr val="accent1"/>
+          </a:effectRef>
+          <a:fontRef idx="minor">
+            <a:schemeClr val="tx1"/>
+          </a:fontRef>
+        </p:style>
+      </p:cxnSp>
+      <p:sp>
+        <p:nvSpPr>
+          <p:cNvPr id="5" name="TextBox 4">
+            <a:extLst>
+              <a:ext uri="{FF2B5EF4-FFF2-40B4-BE49-F238E27FC236}">
+                <a16:creationId xmlns:a16="http://schemas.microsoft.com/office/drawing/2014/main" id="{A25CB3BC-20B5-34BE-BEDC-9A9DED02C646}"/>
+              </a:ext>
+            </a:extLst>
+          </p:cNvPr>
+          <p:cNvSpPr txBox="1"/>
+          <p:nvPr/>
+        </p:nvSpPr>
+        <p:spPr>
+          <a:xfrm>
+            <a:off x="149604" y="272008"/>
+            <a:ext cx="5575575" cy="369332"/>
+          </a:xfrm>
+          <a:prstGeom prst="rect">
+            <a:avLst/>
+          </a:prstGeom>
+          <a:noFill/>
+        </p:spPr>
+        <p:txBody>
+          <a:bodyPr rot="0" spcFirstLastPara="0" vertOverflow="overflow" horzOverflow="overflow" vert="horz" wrap="square" lIns="91440" tIns="45720" rIns="91440" bIns="45720" numCol="1" spcCol="0" rtlCol="0" fromWordArt="0" anchor="t" anchorCtr="0" forceAA="0" compatLnSpc="1">
+            <a:prstTxWarp prst="textNoShape">
+              <a:avLst/>
+            </a:prstTxWarp>
+            <a:spAutoFit/>
+          </a:bodyPr>
+          <a:lstStyle/>
+          <a:p>
+            <a:r>
+              <a:rPr lang="en-US"/>
+              <a:t>We continue to split until a small interval remains.</a:t>
+            </a:r>
+          </a:p>
+        </p:txBody>
+      </p:sp>
+      <p:sp>
+        <p:nvSpPr>
+          <p:cNvPr id="7" name="TextBox 6">
+            <a:extLst>
+              <a:ext uri="{FF2B5EF4-FFF2-40B4-BE49-F238E27FC236}">
+                <a16:creationId xmlns:a16="http://schemas.microsoft.com/office/drawing/2014/main" id="{F71AFB9B-FE1F-15D2-43B2-F09CBB91F914}"/>
+              </a:ext>
+            </a:extLst>
+          </p:cNvPr>
+          <p:cNvSpPr txBox="1"/>
+          <p:nvPr/>
+        </p:nvSpPr>
+        <p:spPr>
+          <a:xfrm>
+            <a:off x="10563757" y="4066546"/>
+            <a:ext cx="594009" cy="369332"/>
+          </a:xfrm>
+          <a:prstGeom prst="rect">
+            <a:avLst/>
+          </a:prstGeom>
+          <a:noFill/>
+        </p:spPr>
+        <p:txBody>
+          <a:bodyPr rot="0" spcFirstLastPara="0" vertOverflow="overflow" horzOverflow="overflow" vert="horz" wrap="square" lIns="91440" tIns="45720" rIns="91440" bIns="45720" numCol="1" spcCol="0" rtlCol="0" fromWordArt="0" anchor="t" anchorCtr="0" forceAA="0" compatLnSpc="1">
+            <a:prstTxWarp prst="textNoShape">
+              <a:avLst/>
+            </a:prstTxWarp>
+            <a:spAutoFit/>
+          </a:bodyPr>
+          <a:lstStyle/>
+          <a:p>
+            <a:pPr algn="l"/>
+            <a:r>
+              <a:rPr lang="en-US"/>
+              <a:t>0.6</a:t>
+            </a:r>
+          </a:p>
+        </p:txBody>
+      </p:sp>
+      <p:sp>
+        <p:nvSpPr>
+          <p:cNvPr id="8" name="TextBox 7">
+            <a:extLst>
+              <a:ext uri="{FF2B5EF4-FFF2-40B4-BE49-F238E27FC236}">
+                <a16:creationId xmlns:a16="http://schemas.microsoft.com/office/drawing/2014/main" id="{CEA66C22-3322-0F66-089C-B160116712AC}"/>
+              </a:ext>
+            </a:extLst>
+          </p:cNvPr>
+          <p:cNvSpPr txBox="1"/>
+          <p:nvPr/>
+        </p:nvSpPr>
+        <p:spPr>
+          <a:xfrm>
+            <a:off x="979988" y="4502084"/>
+            <a:ext cx="5575575" cy="369332"/>
+          </a:xfrm>
+          <a:prstGeom prst="rect">
+            <a:avLst/>
+          </a:prstGeom>
+          <a:noFill/>
+        </p:spPr>
+        <p:txBody>
+          <a:bodyPr rot="0" spcFirstLastPara="0" vertOverflow="overflow" horzOverflow="overflow" vert="horz" wrap="square" lIns="91440" tIns="45720" rIns="91440" bIns="45720" numCol="1" spcCol="0" rtlCol="0" fromWordArt="0" anchor="t" anchorCtr="0" forceAA="0" compatLnSpc="1">
+            <a:prstTxWarp prst="textNoShape">
+              <a:avLst/>
+            </a:prstTxWarp>
+            <a:spAutoFit/>
+          </a:bodyPr>
+          <a:lstStyle/>
+          <a:p>
+            <a:r>
+              <a:rPr lang="en-US"/>
+              <a:t>Interval: [0.36, 0.6)</a:t>
+            </a:r>
+            <a:endParaRPr lang="en-US" dirty="0"/>
+          </a:p>
+        </p:txBody>
+      </p:sp>
+      <p:sp>
+        <p:nvSpPr>
+          <p:cNvPr id="13" name="Rectangle 12">
+            <a:extLst>
+              <a:ext uri="{FF2B5EF4-FFF2-40B4-BE49-F238E27FC236}">
+                <a16:creationId xmlns:a16="http://schemas.microsoft.com/office/drawing/2014/main" id="{AD07E201-1030-B820-3EFF-65971F2986CD}"/>
+              </a:ext>
+            </a:extLst>
+          </p:cNvPr>
+          <p:cNvSpPr/>
+          <p:nvPr/>
+        </p:nvSpPr>
+        <p:spPr>
+          <a:xfrm>
+            <a:off x="981336" y="4064212"/>
+            <a:ext cx="6148523" cy="369515"/>
+          </a:xfrm>
+          <a:prstGeom prst="rect">
+            <a:avLst/>
+          </a:prstGeom>
+          <a:solidFill>
+            <a:srgbClr val="6E2F0D"/>
+          </a:solidFill>
+          <a:ln>
+            <a:solidFill>
+              <a:srgbClr val="6E2F0D"/>
+            </a:solidFill>
+          </a:ln>
+        </p:spPr>
+        <p:style>
+          <a:lnRef idx="2">
+            <a:schemeClr val="accent1">
+              <a:shade val="15000"/>
+            </a:schemeClr>
+          </a:lnRef>
+          <a:fillRef idx="1">
+            <a:schemeClr val="accent1"/>
+          </a:fillRef>
+          <a:effectRef idx="0">
+            <a:schemeClr val="accent1"/>
+          </a:effectRef>
+          <a:fontRef idx="minor">
+            <a:schemeClr val="lt1"/>
+          </a:fontRef>
+        </p:style>
+        <p:txBody>
+          <a:bodyPr rtlCol="0" anchor="ctr"/>
+          <a:lstStyle/>
+          <a:p>
+            <a:pPr algn="ctr"/>
+            <a:r>
+              <a:rPr lang="en-US"/>
+              <a:t>D: 60%</a:t>
+            </a:r>
+          </a:p>
+        </p:txBody>
+      </p:sp>
+      <p:sp>
+        <p:nvSpPr>
+          <p:cNvPr id="11" name="TextBox 10">
+            <a:extLst>
+              <a:ext uri="{FF2B5EF4-FFF2-40B4-BE49-F238E27FC236}">
+                <a16:creationId xmlns:a16="http://schemas.microsoft.com/office/drawing/2014/main" id="{56CA2055-0440-4C87-88A9-44D649D6067D}"/>
+              </a:ext>
+            </a:extLst>
+          </p:cNvPr>
+          <p:cNvSpPr txBox="1"/>
+          <p:nvPr/>
+        </p:nvSpPr>
+        <p:spPr>
+          <a:xfrm>
+            <a:off x="638453" y="4066517"/>
+            <a:ext cx="676570" cy="369332"/>
+          </a:xfrm>
+          <a:prstGeom prst="rect">
+            <a:avLst/>
+          </a:prstGeom>
+          <a:noFill/>
+        </p:spPr>
+        <p:txBody>
+          <a:bodyPr rot="0" spcFirstLastPara="0" vertOverflow="overflow" horzOverflow="overflow" vert="horz" wrap="square" lIns="91440" tIns="45720" rIns="91440" bIns="45720" numCol="1" spcCol="0" rtlCol="0" fromWordArt="0" anchor="t" anchorCtr="0" forceAA="0" compatLnSpc="1">
+            <a:prstTxWarp prst="textNoShape">
+              <a:avLst/>
+            </a:prstTxWarp>
+            <a:spAutoFit/>
+          </a:bodyPr>
+          <a:lstStyle/>
+          <a:p>
+            <a:pPr algn="l"/>
+            <a:r>
+              <a:rPr lang="en-US"/>
+              <a:t>0.36</a:t>
+            </a:r>
+          </a:p>
+        </p:txBody>
+      </p:sp>
+      <p:sp>
+        <p:nvSpPr>
+          <p:cNvPr id="15" name="TextBox 14">
+            <a:extLst>
+              <a:ext uri="{FF2B5EF4-FFF2-40B4-BE49-F238E27FC236}">
+                <a16:creationId xmlns:a16="http://schemas.microsoft.com/office/drawing/2014/main" id="{9F990E57-63C4-A6FD-B0F7-A8D5F3BEF966}"/>
+              </a:ext>
+            </a:extLst>
+          </p:cNvPr>
+          <p:cNvSpPr txBox="1"/>
+          <p:nvPr/>
+        </p:nvSpPr>
+        <p:spPr>
+          <a:xfrm>
+            <a:off x="6724684" y="4066517"/>
+            <a:ext cx="744954" cy="369332"/>
+          </a:xfrm>
+          <a:prstGeom prst="rect">
+            <a:avLst/>
+          </a:prstGeom>
+          <a:noFill/>
+        </p:spPr>
+        <p:txBody>
+          <a:bodyPr rot="0" spcFirstLastPara="0" vertOverflow="overflow" horzOverflow="overflow" vert="horz" wrap="square" lIns="91440" tIns="45720" rIns="91440" bIns="45720" numCol="1" spcCol="0" rtlCol="0" fromWordArt="0" anchor="t" anchorCtr="0" forceAA="0" compatLnSpc="1">
+            <a:prstTxWarp prst="textNoShape">
+              <a:avLst/>
+            </a:prstTxWarp>
+            <a:spAutoFit/>
+          </a:bodyPr>
+          <a:lstStyle/>
+          <a:p>
+            <a:pPr algn="l"/>
+            <a:r>
+              <a:rPr lang="en-US"/>
+              <a:t>0.504</a:t>
+            </a:r>
+          </a:p>
+        </p:txBody>
+      </p:sp>
+    </p:spTree>
+    <p:extLst>
+      <p:ext uri="{BB962C8B-B14F-4D97-AF65-F5344CB8AC3E}">
+        <p14:creationId xmlns:p14="http://schemas.microsoft.com/office/powerpoint/2010/main" val="3267664464"/>
+      </p:ext>
+    </p:extLst>
+  </p:cSld>
+  <p:clrMapOvr>
+    <a:masterClrMapping/>
+  </p:clrMapOvr>
+</p:sld>
+</file>
+
+<file path=ppt/slides/slide9.xml><?xml version="1.0" encoding="utf-8"?>
+<p:sld xmlns:a="http://schemas.openxmlformats.org/drawingml/2006/main" xmlns:r="http://schemas.openxmlformats.org/officeDocument/2006/relationships" xmlns:p="http://schemas.openxmlformats.org/presentationml/2006/main">
+  <p:cSld>
+    <p:spTree>
+      <p:nvGrpSpPr>
+        <p:cNvPr id="1" name="">
+          <a:extLst>
+            <a:ext uri="{FF2B5EF4-FFF2-40B4-BE49-F238E27FC236}">
+              <a16:creationId xmlns:a16="http://schemas.microsoft.com/office/drawing/2014/main" id="{BF5423D9-2F24-8D13-A233-012F5DEEE11F}"/>
+            </a:ext>
+          </a:extLst>
+        </p:cNvPr>
+        <p:cNvGrpSpPr/>
+        <p:nvPr/>
+      </p:nvGrpSpPr>
+      <p:grpSpPr>
+        <a:xfrm>
+          <a:off x="0" y="0"/>
+          <a:ext cx="0" cy="0"/>
+          <a:chOff x="0" y="0"/>
+          <a:chExt cx="0" cy="0"/>
+        </a:xfrm>
+      </p:grpSpPr>
+      <p:cxnSp>
+        <p:nvCxnSpPr>
+          <p:cNvPr id="4" name="Straight Arrow Connector 3">
+            <a:extLst>
+              <a:ext uri="{FF2B5EF4-FFF2-40B4-BE49-F238E27FC236}">
+                <a16:creationId xmlns:a16="http://schemas.microsoft.com/office/drawing/2014/main" id="{9EEF4958-79AF-4322-E907-3CB37335F23E}"/>
+              </a:ext>
+            </a:extLst>
+          </p:cNvPr>
+          <p:cNvCxnSpPr/>
+          <p:nvPr/>
+        </p:nvCxnSpPr>
+        <p:spPr>
+          <a:xfrm>
+            <a:off x="982250" y="4442794"/>
+            <a:ext cx="9882952" cy="15119"/>
+          </a:xfrm>
+          <a:prstGeom prst="straightConnector1">
+            <a:avLst/>
+          </a:prstGeom>
+        </p:spPr>
+        <p:style>
+          <a:lnRef idx="2">
+            <a:schemeClr val="accent1"/>
+          </a:lnRef>
+          <a:fillRef idx="0">
+            <a:schemeClr val="accent1"/>
+          </a:fillRef>
+          <a:effectRef idx="1">
+            <a:schemeClr val="accent1"/>
+          </a:effectRef>
+          <a:fontRef idx="minor">
+            <a:schemeClr val="tx1"/>
+          </a:fontRef>
+        </p:style>
+      </p:cxnSp>
+      <p:sp>
+        <p:nvSpPr>
+          <p:cNvPr id="5" name="TextBox 4">
+            <a:extLst>
+              <a:ext uri="{FF2B5EF4-FFF2-40B4-BE49-F238E27FC236}">
+                <a16:creationId xmlns:a16="http://schemas.microsoft.com/office/drawing/2014/main" id="{87DE329B-CB20-3D6B-4E22-B1719C494604}"/>
+              </a:ext>
+            </a:extLst>
+          </p:cNvPr>
+          <p:cNvSpPr txBox="1"/>
+          <p:nvPr/>
+        </p:nvSpPr>
+        <p:spPr>
+          <a:xfrm>
+            <a:off x="149604" y="272008"/>
+            <a:ext cx="5575575" cy="923330"/>
+          </a:xfrm>
+          <a:prstGeom prst="rect">
+            <a:avLst/>
+          </a:prstGeom>
+          <a:noFill/>
+        </p:spPr>
+        <p:txBody>
+          <a:bodyPr rot="0" spcFirstLastPara="0" vertOverflow="overflow" horzOverflow="overflow" vert="horz" wrap="square" lIns="91440" tIns="45720" rIns="91440" bIns="45720" numCol="1" spcCol="0" rtlCol="0" fromWordArt="0" anchor="t" anchorCtr="0" forceAA="0" compatLnSpc="1">
+            <a:prstTxWarp prst="textNoShape">
+              <a:avLst/>
+            </a:prstTxWarp>
+            <a:spAutoFit/>
+          </a:bodyPr>
+          <a:lstStyle/>
+          <a:p>
+            <a:r>
+              <a:rPr lang="en-US"/>
+              <a:t>Messages are encoded using a number inside the final interval.</a:t>
+            </a:r>
+          </a:p>
+          <a:p>
+            <a:endParaRPr lang="en-US" dirty="0"/>
+          </a:p>
+        </p:txBody>
+      </p:sp>
+      <p:sp>
+        <p:nvSpPr>
+          <p:cNvPr id="8" name="TextBox 7">
+            <a:extLst>
+              <a:ext uri="{FF2B5EF4-FFF2-40B4-BE49-F238E27FC236}">
+                <a16:creationId xmlns:a16="http://schemas.microsoft.com/office/drawing/2014/main" id="{C35770ED-B4FF-B504-8AF4-93C94A75843C}"/>
+              </a:ext>
+            </a:extLst>
+          </p:cNvPr>
+          <p:cNvSpPr txBox="1"/>
+          <p:nvPr/>
+        </p:nvSpPr>
+        <p:spPr>
+          <a:xfrm>
+            <a:off x="979988" y="4502084"/>
+            <a:ext cx="5575575" cy="369332"/>
+          </a:xfrm>
+          <a:prstGeom prst="rect">
+            <a:avLst/>
+          </a:prstGeom>
+          <a:noFill/>
+        </p:spPr>
+        <p:txBody>
+          <a:bodyPr rot="0" spcFirstLastPara="0" vertOverflow="overflow" horzOverflow="overflow" vert="horz" wrap="square" lIns="91440" tIns="45720" rIns="91440" bIns="45720" numCol="1" spcCol="0" rtlCol="0" fromWordArt="0" anchor="t" anchorCtr="0" forceAA="0" compatLnSpc="1">
+            <a:prstTxWarp prst="textNoShape">
+              <a:avLst/>
+            </a:prstTxWarp>
+            <a:spAutoFit/>
+          </a:bodyPr>
+          <a:lstStyle/>
+          <a:p>
+            <a:r>
+              <a:rPr lang="en-US"/>
+              <a:t>Interval: [0.36, 0.504)</a:t>
+            </a:r>
+            <a:endParaRPr lang="en-US" dirty="0"/>
+          </a:p>
+        </p:txBody>
+      </p:sp>
+      <p:sp>
+        <p:nvSpPr>
+          <p:cNvPr id="13" name="Rectangle 12">
+            <a:extLst>
+              <a:ext uri="{FF2B5EF4-FFF2-40B4-BE49-F238E27FC236}">
+                <a16:creationId xmlns:a16="http://schemas.microsoft.com/office/drawing/2014/main" id="{B9B0A275-7B88-DC02-73AD-B6E6BB6FED3B}"/>
+              </a:ext>
+            </a:extLst>
+          </p:cNvPr>
+          <p:cNvSpPr/>
+          <p:nvPr/>
+        </p:nvSpPr>
+        <p:spPr>
+          <a:xfrm>
+            <a:off x="981336" y="4064212"/>
+            <a:ext cx="9860830" cy="379284"/>
+          </a:xfrm>
+          <a:prstGeom prst="rect">
+            <a:avLst/>
+          </a:prstGeom>
+          <a:solidFill>
+            <a:srgbClr val="6E2F0D"/>
+          </a:solidFill>
+          <a:ln>
+            <a:solidFill>
+              <a:srgbClr val="6E2F0D"/>
+            </a:solidFill>
+          </a:ln>
+        </p:spPr>
+        <p:style>
+          <a:lnRef idx="2">
+            <a:schemeClr val="accent1">
+              <a:shade val="15000"/>
+            </a:schemeClr>
+          </a:lnRef>
+          <a:fillRef idx="1">
+            <a:schemeClr val="accent1"/>
+          </a:fillRef>
+          <a:effectRef idx="0">
+            <a:schemeClr val="accent1"/>
+          </a:effectRef>
+          <a:fontRef idx="minor">
+            <a:schemeClr val="lt1"/>
+          </a:fontRef>
+        </p:style>
+        <p:txBody>
+          <a:bodyPr rtlCol="0" anchor="ctr"/>
+          <a:lstStyle/>
+          <a:p>
+            <a:pPr algn="ctr"/>
+            <a:r>
+              <a:rPr lang="en-US"/>
+              <a:t>D: 60%</a:t>
+            </a:r>
+          </a:p>
+        </p:txBody>
+      </p:sp>
+      <p:sp>
+        <p:nvSpPr>
+          <p:cNvPr id="11" name="TextBox 10">
+            <a:extLst>
+              <a:ext uri="{FF2B5EF4-FFF2-40B4-BE49-F238E27FC236}">
+                <a16:creationId xmlns:a16="http://schemas.microsoft.com/office/drawing/2014/main" id="{65A31548-DA0A-F047-E59E-F760DFB05303}"/>
+              </a:ext>
+            </a:extLst>
+          </p:cNvPr>
+          <p:cNvSpPr txBox="1"/>
+          <p:nvPr/>
+        </p:nvSpPr>
+        <p:spPr>
+          <a:xfrm>
+            <a:off x="638453" y="4066517"/>
+            <a:ext cx="676570" cy="369332"/>
+          </a:xfrm>
+          <a:prstGeom prst="rect">
+            <a:avLst/>
+          </a:prstGeom>
+          <a:noFill/>
+        </p:spPr>
+        <p:txBody>
+          <a:bodyPr rot="0" spcFirstLastPara="0" vertOverflow="overflow" horzOverflow="overflow" vert="horz" wrap="square" lIns="91440" tIns="45720" rIns="91440" bIns="45720" numCol="1" spcCol="0" rtlCol="0" fromWordArt="0" anchor="t" anchorCtr="0" forceAA="0" compatLnSpc="1">
+            <a:prstTxWarp prst="textNoShape">
+              <a:avLst/>
+            </a:prstTxWarp>
+            <a:spAutoFit/>
+          </a:bodyPr>
+          <a:lstStyle/>
+          <a:p>
+            <a:pPr algn="l"/>
+            <a:r>
+              <a:rPr lang="en-US"/>
+              <a:t>0.36</a:t>
+            </a:r>
+          </a:p>
+        </p:txBody>
+      </p:sp>
+      <p:sp>
+        <p:nvSpPr>
+          <p:cNvPr id="15" name="TextBox 14">
+            <a:extLst>
+              <a:ext uri="{FF2B5EF4-FFF2-40B4-BE49-F238E27FC236}">
+                <a16:creationId xmlns:a16="http://schemas.microsoft.com/office/drawing/2014/main" id="{31178B82-ADEF-4393-383A-01E71278A68B}"/>
+              </a:ext>
+            </a:extLst>
+          </p:cNvPr>
+          <p:cNvSpPr txBox="1"/>
+          <p:nvPr/>
+        </p:nvSpPr>
+        <p:spPr>
+          <a:xfrm>
+            <a:off x="10456530" y="4066517"/>
+            <a:ext cx="744954" cy="369332"/>
+          </a:xfrm>
+          <a:prstGeom prst="rect">
+            <a:avLst/>
+          </a:prstGeom>
+          <a:noFill/>
+        </p:spPr>
+        <p:txBody>
+          <a:bodyPr rot="0" spcFirstLastPara="0" vertOverflow="overflow" horzOverflow="overflow" vert="horz" wrap="square" lIns="91440" tIns="45720" rIns="91440" bIns="45720" numCol="1" spcCol="0" rtlCol="0" fromWordArt="0" anchor="t" anchorCtr="0" forceAA="0" compatLnSpc="1">
+            <a:prstTxWarp prst="textNoShape">
+              <a:avLst/>
+            </a:prstTxWarp>
+            <a:spAutoFit/>
+          </a:bodyPr>
+          <a:lstStyle/>
+          <a:p>
+            <a:pPr algn="l"/>
+            <a:r>
+              <a:rPr lang="en-US"/>
+              <a:t>0.504</a:t>
+            </a:r>
+          </a:p>
+        </p:txBody>
+      </p:sp>
+    </p:spTree>
+    <p:extLst>
+      <p:ext uri="{BB962C8B-B14F-4D97-AF65-F5344CB8AC3E}">
+        <p14:creationId xmlns:p14="http://schemas.microsoft.com/office/powerpoint/2010/main" val="264313934"/>
+      </p:ext>
+    </p:extLst>
+  </p:cSld>
+  <p:clrMapOvr>
+    <a:masterClrMapping/>
+  </p:clrMapOvr>
+  <mc:AlternateContent xmlns:mc="http://schemas.openxmlformats.org/markup-compatibility/2006" xmlns:p159="http://schemas.microsoft.com/office/powerpoint/2015/09/main">
+    <mc:Choice Requires="p159">
+      <p:transition xmlns:p14="http://schemas.microsoft.com/office/powerpoint/2010/main" spd="slow" p14:dur="2000">
+        <p159:morph option="byObject"/>
+      </p:transition>
+    </mc:Choice>
+    <mc:Fallback xmlns="">
+      <p:transition spd="slow">
+        <p:fade/>
+      </p:transition>
+    </mc:Fallback>
+  </mc:AlternateContent>
 </p:sld>
 </file>
 

</xml_diff>

<commit_message>
Added (candidate) final presentation
</commit_message>
<xml_diff>
--- a/project_presentation.pptx
+++ b/project_presentation.pptx
@@ -2,10 +2,10 @@
 <file path=ppt/presentation.xml><?xml version="1.0" encoding="utf-8"?>
 <p:presentation xmlns:a="http://schemas.openxmlformats.org/drawingml/2006/main" xmlns:r="http://schemas.openxmlformats.org/officeDocument/2006/relationships" xmlns:p="http://schemas.openxmlformats.org/presentationml/2006/main" saveSubsetFonts="1">
   <p:sldMasterIdLst>
-    <p:sldMasterId id="2147483660" r:id="rId1"/>
+    <p:sldMasterId id="2147483672" r:id="rId1"/>
   </p:sldMasterIdLst>
   <p:notesMasterIdLst>
-    <p:notesMasterId r:id="rId14"/>
+    <p:notesMasterId r:id="rId15"/>
   </p:notesMasterIdLst>
   <p:sldIdLst>
     <p:sldId id="256" r:id="rId2"/>
@@ -20,6 +20,7 @@
     <p:sldId id="268" r:id="rId11"/>
     <p:sldId id="259" r:id="rId12"/>
     <p:sldId id="260" r:id="rId13"/>
+    <p:sldId id="269" r:id="rId14"/>
   </p:sldIdLst>
   <p:sldSz cx="12192000" cy="6858000"/>
   <p:notesSz cx="6858000" cy="9144000"/>
@@ -129,7 +130,7 @@
 <file path=ppt/revisionInfo.xml><?xml version="1.0" encoding="utf-8"?>
 <p1510:revInfo xmlns:a="http://schemas.openxmlformats.org/drawingml/2006/main" xmlns:r="http://schemas.openxmlformats.org/officeDocument/2006/relationships" xmlns:p1510="http://schemas.microsoft.com/office/powerpoint/2015/10/main">
   <p1510:revLst>
-    <p1510:client id="{1D93DDD2-C351-F292-A442-9645DC35FA3A}" v="667" dt="2026-10-18T10:11:01.524"/>
+    <p1510:client id="{D9F60371-CDAC-7B58-7E9F-19A3FC117413}" v="439" dt="2026-10-24T11:19:30.215"/>
   </p1510:revLst>
 </p1510:revInfo>
 </file>
@@ -215,7 +216,7 @@
           </a:lstStyle>
           <a:p>
             <a:fld id="{6D8E7CD1-BB82-4A33-80CC-AC765A6873D5}" type="datetimeFigureOut">
-              <a:t>10/18/2026</a:t>
+              <a:t>10/24/2026</a:t>
             </a:fld>
             <a:endParaRPr lang="en-US"/>
           </a:p>
@@ -633,10 +634,9 @@
           </a:lstStyle>
           <a:p>
             <a:r>
-              <a:rPr lang="en-US"/>
+              <a:rPr lang="en-US" dirty="0"/>
               <a:t>Click to edit Master title style</a:t>
             </a:r>
-            <a:endParaRPr lang="en-US" dirty="0"/>
           </a:p>
         </p:txBody>
       </p:sp>
@@ -698,21 +698,43 @@
           </a:lstStyle>
           <a:p>
             <a:r>
-              <a:rPr lang="en-US"/>
+              <a:rPr lang="en-US" dirty="0"/>
               <a:t>Click to edit Master subtitle style</a:t>
             </a:r>
+          </a:p>
+        </p:txBody>
+      </p:sp>
+      <p:sp>
+        <p:nvSpPr>
+          <p:cNvPr id="4" name="Date Placeholder 3"/>
+          <p:cNvSpPr>
+            <a:spLocks noGrp="1"/>
+          </p:cNvSpPr>
+          <p:nvPr>
+            <p:ph type="dt" sz="half" idx="10"/>
+          </p:nvPr>
+        </p:nvSpPr>
+        <p:spPr/>
+        <p:txBody>
+          <a:bodyPr/>
+          <a:lstStyle/>
+          <a:p>
+            <a:fld id="{C764DE79-268F-4C1A-8933-263129D2AF90}" type="datetimeFigureOut">
+              <a:rPr lang="en-US" dirty="0"/>
+              <a:t>10/24/2026</a:t>
+            </a:fld>
             <a:endParaRPr lang="en-US" dirty="0"/>
           </a:p>
         </p:txBody>
       </p:sp>
       <p:sp>
         <p:nvSpPr>
-          <p:cNvPr id="4" name="Date Placeholder 3"/>
-          <p:cNvSpPr>
-            <a:spLocks noGrp="1"/>
-          </p:cNvSpPr>
-          <p:nvPr>
-            <p:ph type="dt" sz="half" idx="10"/>
+          <p:cNvPr id="5" name="Footer Placeholder 4"/>
+          <p:cNvSpPr>
+            <a:spLocks noGrp="1"/>
+          </p:cNvSpPr>
+          <p:nvPr>
+            <p:ph type="ftr" sz="quarter" idx="11"/>
           </p:nvPr>
         </p:nvSpPr>
         <p:spPr/>
@@ -720,22 +742,18 @@
           <a:bodyPr/>
           <a:lstStyle/>
           <a:p>
-            <a:fld id="{846CE7D5-CF57-46EF-B807-FDD0502418D4}" type="datetimeFigureOut">
-              <a:rPr lang="en-US" smtClean="0"/>
-              <a:t>10/18/2026</a:t>
-            </a:fld>
-            <a:endParaRPr lang="en-US"/>
-          </a:p>
-        </p:txBody>
-      </p:sp>
-      <p:sp>
-        <p:nvSpPr>
-          <p:cNvPr id="5" name="Footer Placeholder 4"/>
-          <p:cNvSpPr>
-            <a:spLocks noGrp="1"/>
-          </p:cNvSpPr>
-          <p:nvPr>
-            <p:ph type="ftr" sz="quarter" idx="11"/>
+            <a:endParaRPr lang="en-US" dirty="0"/>
+          </a:p>
+        </p:txBody>
+      </p:sp>
+      <p:sp>
+        <p:nvSpPr>
+          <p:cNvPr id="6" name="Slide Number Placeholder 5"/>
+          <p:cNvSpPr>
+            <a:spLocks noGrp="1"/>
+          </p:cNvSpPr>
+          <p:nvPr>
+            <p:ph type="sldNum" sz="quarter" idx="12"/>
           </p:nvPr>
         </p:nvSpPr>
         <p:spPr/>
@@ -743,37 +761,18 @@
           <a:bodyPr/>
           <a:lstStyle/>
           <a:p>
-            <a:endParaRPr lang="en-US"/>
-          </a:p>
-        </p:txBody>
-      </p:sp>
-      <p:sp>
-        <p:nvSpPr>
-          <p:cNvPr id="6" name="Slide Number Placeholder 5"/>
-          <p:cNvSpPr>
-            <a:spLocks noGrp="1"/>
-          </p:cNvSpPr>
-          <p:nvPr>
-            <p:ph type="sldNum" sz="quarter" idx="12"/>
-          </p:nvPr>
-        </p:nvSpPr>
-        <p:spPr/>
-        <p:txBody>
-          <a:bodyPr/>
-          <a:lstStyle/>
-          <a:p>
-            <a:fld id="{330EA680-D336-4FF7-8B7A-9848BB0A1C32}" type="slidenum">
-              <a:rPr lang="en-US" smtClean="0"/>
+            <a:fld id="{48F63A3B-78C7-47BE-AE5E-E10140E04643}" type="slidenum">
+              <a:rPr lang="en-US" dirty="0"/>
               <a:t>‹#›</a:t>
             </a:fld>
-            <a:endParaRPr lang="en-US"/>
+            <a:endParaRPr lang="en-US" dirty="0"/>
           </a:p>
         </p:txBody>
       </p:sp>
     </p:spTree>
     <p:extLst>
       <p:ext uri="{BB962C8B-B14F-4D97-AF65-F5344CB8AC3E}">
-        <p14:creationId xmlns:p14="http://schemas.microsoft.com/office/powerpoint/2010/main" val="2385387890"/>
+        <p14:creationId xmlns:p14="http://schemas.microsoft.com/office/powerpoint/2010/main" val="1926475373"/>
       </p:ext>
     </p:extLst>
   </p:cSld>
@@ -816,73 +815,113 @@
           <a:lstStyle/>
           <a:p>
             <a:r>
-              <a:rPr lang="en-US"/>
+              <a:rPr lang="en-US" dirty="0"/>
               <a:t>Click to edit Master title style</a:t>
             </a:r>
+          </a:p>
+        </p:txBody>
+      </p:sp>
+      <p:sp>
+        <p:nvSpPr>
+          <p:cNvPr id="3" name="Vertical Text Placeholder 2"/>
+          <p:cNvSpPr>
+            <a:spLocks noGrp="1"/>
+          </p:cNvSpPr>
+          <p:nvPr>
+            <p:ph type="body" orient="vert" idx="1"/>
+          </p:nvPr>
+        </p:nvSpPr>
+        <p:spPr/>
+        <p:txBody>
+          <a:bodyPr vert="eaVert"/>
+          <a:lstStyle/>
+          <a:p>
+            <a:pPr lvl="0"/>
+            <a:r>
+              <a:rPr lang="en-US" dirty="0"/>
+              <a:t>Click to edit Master text styles</a:t>
+            </a:r>
+          </a:p>
+          <a:p>
+            <a:pPr lvl="1"/>
+            <a:r>
+              <a:rPr lang="en-US" dirty="0"/>
+              <a:t>Second level</a:t>
+            </a:r>
+          </a:p>
+          <a:p>
+            <a:pPr lvl="2"/>
+            <a:r>
+              <a:rPr lang="en-US" dirty="0"/>
+              <a:t>Third level</a:t>
+            </a:r>
+          </a:p>
+          <a:p>
+            <a:pPr lvl="3"/>
+            <a:r>
+              <a:rPr lang="en-US" dirty="0"/>
+              <a:t>Fourth level</a:t>
+            </a:r>
+          </a:p>
+          <a:p>
+            <a:pPr lvl="4"/>
+            <a:r>
+              <a:rPr lang="en-US" dirty="0"/>
+              <a:t>Fifth level</a:t>
+            </a:r>
+          </a:p>
+        </p:txBody>
+      </p:sp>
+      <p:sp>
+        <p:nvSpPr>
+          <p:cNvPr id="4" name="Date Placeholder 3"/>
+          <p:cNvSpPr>
+            <a:spLocks noGrp="1"/>
+          </p:cNvSpPr>
+          <p:nvPr>
+            <p:ph type="dt" sz="half" idx="10"/>
+          </p:nvPr>
+        </p:nvSpPr>
+        <p:spPr/>
+        <p:txBody>
+          <a:bodyPr/>
+          <a:lstStyle/>
+          <a:p>
+            <a:fld id="{C764DE79-268F-4C1A-8933-263129D2AF90}" type="datetimeFigureOut">
+              <a:rPr lang="en-US" dirty="0"/>
+              <a:t>10/24/2026</a:t>
+            </a:fld>
             <a:endParaRPr lang="en-US" dirty="0"/>
           </a:p>
         </p:txBody>
       </p:sp>
       <p:sp>
         <p:nvSpPr>
-          <p:cNvPr id="3" name="Vertical Text Placeholder 2"/>
-          <p:cNvSpPr>
-            <a:spLocks noGrp="1"/>
-          </p:cNvSpPr>
-          <p:nvPr>
-            <p:ph type="body" orient="vert" idx="1"/>
+          <p:cNvPr id="5" name="Footer Placeholder 4"/>
+          <p:cNvSpPr>
+            <a:spLocks noGrp="1"/>
+          </p:cNvSpPr>
+          <p:nvPr>
+            <p:ph type="ftr" sz="quarter" idx="11"/>
           </p:nvPr>
         </p:nvSpPr>
         <p:spPr/>
         <p:txBody>
-          <a:bodyPr vert="eaVert"/>
-          <a:lstStyle/>
-          <a:p>
-            <a:pPr lvl="0"/>
-            <a:r>
-              <a:rPr lang="en-US"/>
-              <a:t>Click to edit Master text styles</a:t>
-            </a:r>
-          </a:p>
-          <a:p>
-            <a:pPr lvl="1"/>
-            <a:r>
-              <a:rPr lang="en-US"/>
-              <a:t>Second level</a:t>
-            </a:r>
-          </a:p>
-          <a:p>
-            <a:pPr lvl="2"/>
-            <a:r>
-              <a:rPr lang="en-US"/>
-              <a:t>Third level</a:t>
-            </a:r>
-          </a:p>
-          <a:p>
-            <a:pPr lvl="3"/>
-            <a:r>
-              <a:rPr lang="en-US"/>
-              <a:t>Fourth level</a:t>
-            </a:r>
-          </a:p>
-          <a:p>
-            <a:pPr lvl="4"/>
-            <a:r>
-              <a:rPr lang="en-US"/>
-              <a:t>Fifth level</a:t>
-            </a:r>
+          <a:bodyPr/>
+          <a:lstStyle/>
+          <a:p>
             <a:endParaRPr lang="en-US" dirty="0"/>
           </a:p>
         </p:txBody>
       </p:sp>
       <p:sp>
         <p:nvSpPr>
-          <p:cNvPr id="4" name="Date Placeholder 3"/>
-          <p:cNvSpPr>
-            <a:spLocks noGrp="1"/>
-          </p:cNvSpPr>
-          <p:nvPr>
-            <p:ph type="dt" sz="half" idx="10"/>
+          <p:cNvPr id="6" name="Slide Number Placeholder 5"/>
+          <p:cNvSpPr>
+            <a:spLocks noGrp="1"/>
+          </p:cNvSpPr>
+          <p:nvPr>
+            <p:ph type="sldNum" sz="quarter" idx="12"/>
           </p:nvPr>
         </p:nvSpPr>
         <p:spPr/>
@@ -890,60 +929,18 @@
           <a:bodyPr/>
           <a:lstStyle/>
           <a:p>
-            <a:fld id="{846CE7D5-CF57-46EF-B807-FDD0502418D4}" type="datetimeFigureOut">
-              <a:rPr lang="en-US" smtClean="0"/>
-              <a:t>10/18/2026</a:t>
-            </a:fld>
-            <a:endParaRPr lang="en-US"/>
-          </a:p>
-        </p:txBody>
-      </p:sp>
-      <p:sp>
-        <p:nvSpPr>
-          <p:cNvPr id="5" name="Footer Placeholder 4"/>
-          <p:cNvSpPr>
-            <a:spLocks noGrp="1"/>
-          </p:cNvSpPr>
-          <p:nvPr>
-            <p:ph type="ftr" sz="quarter" idx="11"/>
-          </p:nvPr>
-        </p:nvSpPr>
-        <p:spPr/>
-        <p:txBody>
-          <a:bodyPr/>
-          <a:lstStyle/>
-          <a:p>
-            <a:endParaRPr lang="en-US"/>
-          </a:p>
-        </p:txBody>
-      </p:sp>
-      <p:sp>
-        <p:nvSpPr>
-          <p:cNvPr id="6" name="Slide Number Placeholder 5"/>
-          <p:cNvSpPr>
-            <a:spLocks noGrp="1"/>
-          </p:cNvSpPr>
-          <p:nvPr>
-            <p:ph type="sldNum" sz="quarter" idx="12"/>
-          </p:nvPr>
-        </p:nvSpPr>
-        <p:spPr/>
-        <p:txBody>
-          <a:bodyPr/>
-          <a:lstStyle/>
-          <a:p>
-            <a:fld id="{330EA680-D336-4FF7-8B7A-9848BB0A1C32}" type="slidenum">
-              <a:rPr lang="en-US" smtClean="0"/>
+            <a:fld id="{48F63A3B-78C7-47BE-AE5E-E10140E04643}" type="slidenum">
+              <a:rPr lang="en-US" dirty="0"/>
               <a:t>‹#›</a:t>
             </a:fld>
-            <a:endParaRPr lang="en-US"/>
+            <a:endParaRPr lang="en-US" dirty="0"/>
           </a:p>
         </p:txBody>
       </p:sp>
     </p:spTree>
     <p:extLst>
       <p:ext uri="{BB962C8B-B14F-4D97-AF65-F5344CB8AC3E}">
-        <p14:creationId xmlns:p14="http://schemas.microsoft.com/office/powerpoint/2010/main" val="2202905451"/>
+        <p14:creationId xmlns:p14="http://schemas.microsoft.com/office/powerpoint/2010/main" val="4002371230"/>
       </p:ext>
     </p:extLst>
   </p:cSld>
@@ -991,10 +988,9 @@
           <a:lstStyle/>
           <a:p>
             <a:r>
-              <a:rPr lang="en-US"/>
+              <a:rPr lang="en-US" dirty="0"/>
               <a:t>Click to edit Master title style</a:t>
             </a:r>
-            <a:endParaRPr lang="en-US" dirty="0"/>
           </a:p>
         </p:txBody>
       </p:sp>
@@ -1020,49 +1016,71 @@
           <a:p>
             <a:pPr lvl="0"/>
             <a:r>
-              <a:rPr lang="en-US"/>
+              <a:rPr lang="en-US" dirty="0"/>
               <a:t>Click to edit Master text styles</a:t>
             </a:r>
           </a:p>
           <a:p>
             <a:pPr lvl="1"/>
             <a:r>
-              <a:rPr lang="en-US"/>
+              <a:rPr lang="en-US" dirty="0"/>
               <a:t>Second level</a:t>
             </a:r>
           </a:p>
           <a:p>
             <a:pPr lvl="2"/>
             <a:r>
-              <a:rPr lang="en-US"/>
+              <a:rPr lang="en-US" dirty="0"/>
               <a:t>Third level</a:t>
             </a:r>
           </a:p>
           <a:p>
             <a:pPr lvl="3"/>
             <a:r>
-              <a:rPr lang="en-US"/>
+              <a:rPr lang="en-US" dirty="0"/>
               <a:t>Fourth level</a:t>
             </a:r>
           </a:p>
           <a:p>
             <a:pPr lvl="4"/>
             <a:r>
-              <a:rPr lang="en-US"/>
+              <a:rPr lang="en-US" dirty="0"/>
               <a:t>Fifth level</a:t>
             </a:r>
+          </a:p>
+        </p:txBody>
+      </p:sp>
+      <p:sp>
+        <p:nvSpPr>
+          <p:cNvPr id="4" name="Date Placeholder 3"/>
+          <p:cNvSpPr>
+            <a:spLocks noGrp="1"/>
+          </p:cNvSpPr>
+          <p:nvPr>
+            <p:ph type="dt" sz="half" idx="10"/>
+          </p:nvPr>
+        </p:nvSpPr>
+        <p:spPr/>
+        <p:txBody>
+          <a:bodyPr/>
+          <a:lstStyle/>
+          <a:p>
+            <a:fld id="{C764DE79-268F-4C1A-8933-263129D2AF90}" type="datetimeFigureOut">
+              <a:rPr lang="en-US" dirty="0"/>
+              <a:t>10/24/2026</a:t>
+            </a:fld>
             <a:endParaRPr lang="en-US" dirty="0"/>
           </a:p>
         </p:txBody>
       </p:sp>
       <p:sp>
         <p:nvSpPr>
-          <p:cNvPr id="4" name="Date Placeholder 3"/>
-          <p:cNvSpPr>
-            <a:spLocks noGrp="1"/>
-          </p:cNvSpPr>
-          <p:nvPr>
-            <p:ph type="dt" sz="half" idx="10"/>
+          <p:cNvPr id="5" name="Footer Placeholder 4"/>
+          <p:cNvSpPr>
+            <a:spLocks noGrp="1"/>
+          </p:cNvSpPr>
+          <p:nvPr>
+            <p:ph type="ftr" sz="quarter" idx="11"/>
           </p:nvPr>
         </p:nvSpPr>
         <p:spPr/>
@@ -1070,22 +1088,18 @@
           <a:bodyPr/>
           <a:lstStyle/>
           <a:p>
-            <a:fld id="{846CE7D5-CF57-46EF-B807-FDD0502418D4}" type="datetimeFigureOut">
-              <a:rPr lang="en-US" smtClean="0"/>
-              <a:t>10/18/2026</a:t>
-            </a:fld>
-            <a:endParaRPr lang="en-US"/>
-          </a:p>
-        </p:txBody>
-      </p:sp>
-      <p:sp>
-        <p:nvSpPr>
-          <p:cNvPr id="5" name="Footer Placeholder 4"/>
-          <p:cNvSpPr>
-            <a:spLocks noGrp="1"/>
-          </p:cNvSpPr>
-          <p:nvPr>
-            <p:ph type="ftr" sz="quarter" idx="11"/>
+            <a:endParaRPr lang="en-US" dirty="0"/>
+          </a:p>
+        </p:txBody>
+      </p:sp>
+      <p:sp>
+        <p:nvSpPr>
+          <p:cNvPr id="6" name="Slide Number Placeholder 5"/>
+          <p:cNvSpPr>
+            <a:spLocks noGrp="1"/>
+          </p:cNvSpPr>
+          <p:nvPr>
+            <p:ph type="sldNum" sz="quarter" idx="12"/>
           </p:nvPr>
         </p:nvSpPr>
         <p:spPr/>
@@ -1093,37 +1107,18 @@
           <a:bodyPr/>
           <a:lstStyle/>
           <a:p>
-            <a:endParaRPr lang="en-US"/>
-          </a:p>
-        </p:txBody>
-      </p:sp>
-      <p:sp>
-        <p:nvSpPr>
-          <p:cNvPr id="6" name="Slide Number Placeholder 5"/>
-          <p:cNvSpPr>
-            <a:spLocks noGrp="1"/>
-          </p:cNvSpPr>
-          <p:nvPr>
-            <p:ph type="sldNum" sz="quarter" idx="12"/>
-          </p:nvPr>
-        </p:nvSpPr>
-        <p:spPr/>
-        <p:txBody>
-          <a:bodyPr/>
-          <a:lstStyle/>
-          <a:p>
-            <a:fld id="{330EA680-D336-4FF7-8B7A-9848BB0A1C32}" type="slidenum">
-              <a:rPr lang="en-US" smtClean="0"/>
+            <a:fld id="{48F63A3B-78C7-47BE-AE5E-E10140E04643}" type="slidenum">
+              <a:rPr lang="en-US" dirty="0"/>
               <a:t>‹#›</a:t>
             </a:fld>
-            <a:endParaRPr lang="en-US"/>
+            <a:endParaRPr lang="en-US" dirty="0"/>
           </a:p>
         </p:txBody>
       </p:sp>
     </p:spTree>
     <p:extLst>
       <p:ext uri="{BB962C8B-B14F-4D97-AF65-F5344CB8AC3E}">
-        <p14:creationId xmlns:p14="http://schemas.microsoft.com/office/powerpoint/2010/main" val="3479445657"/>
+        <p14:creationId xmlns:p14="http://schemas.microsoft.com/office/powerpoint/2010/main" val="2954377610"/>
       </p:ext>
     </p:extLst>
   </p:cSld>
@@ -1166,21 +1161,94 @@
           <a:lstStyle/>
           <a:p>
             <a:r>
-              <a:rPr lang="en-US"/>
+              <a:rPr lang="en-US" dirty="0"/>
               <a:t>Click to edit Master title style</a:t>
             </a:r>
+          </a:p>
+        </p:txBody>
+      </p:sp>
+      <p:sp>
+        <p:nvSpPr>
+          <p:cNvPr id="3" name="Content Placeholder 2"/>
+          <p:cNvSpPr>
+            <a:spLocks noGrp="1"/>
+          </p:cNvSpPr>
+          <p:nvPr>
+            <p:ph idx="1"/>
+          </p:nvPr>
+        </p:nvSpPr>
+        <p:spPr/>
+        <p:txBody>
+          <a:bodyPr/>
+          <a:lstStyle/>
+          <a:p>
+            <a:pPr lvl="0"/>
+            <a:r>
+              <a:rPr lang="en-US" dirty="0"/>
+              <a:t>Click to edit Master text styles</a:t>
+            </a:r>
+          </a:p>
+          <a:p>
+            <a:pPr lvl="1"/>
+            <a:r>
+              <a:rPr lang="en-US" dirty="0"/>
+              <a:t>Second level</a:t>
+            </a:r>
+          </a:p>
+          <a:p>
+            <a:pPr lvl="2"/>
+            <a:r>
+              <a:rPr lang="en-US" dirty="0"/>
+              <a:t>Third level</a:t>
+            </a:r>
+          </a:p>
+          <a:p>
+            <a:pPr lvl="3"/>
+            <a:r>
+              <a:rPr lang="en-US" dirty="0"/>
+              <a:t>Fourth level</a:t>
+            </a:r>
+          </a:p>
+          <a:p>
+            <a:pPr lvl="4"/>
+            <a:r>
+              <a:rPr lang="en-US" dirty="0"/>
+              <a:t>Fifth level</a:t>
+            </a:r>
+          </a:p>
+        </p:txBody>
+      </p:sp>
+      <p:sp>
+        <p:nvSpPr>
+          <p:cNvPr id="4" name="Date Placeholder 3"/>
+          <p:cNvSpPr>
+            <a:spLocks noGrp="1"/>
+          </p:cNvSpPr>
+          <p:nvPr>
+            <p:ph type="dt" sz="half" idx="10"/>
+          </p:nvPr>
+        </p:nvSpPr>
+        <p:spPr/>
+        <p:txBody>
+          <a:bodyPr/>
+          <a:lstStyle/>
+          <a:p>
+            <a:fld id="{C764DE79-268F-4C1A-8933-263129D2AF90}" type="datetimeFigureOut">
+              <a:rPr lang="en-US" dirty="0"/>
+              <a:t>10/24/2026</a:t>
+            </a:fld>
             <a:endParaRPr lang="en-US" dirty="0"/>
           </a:p>
         </p:txBody>
       </p:sp>
       <p:sp>
         <p:nvSpPr>
-          <p:cNvPr id="3" name="Content Placeholder 2"/>
-          <p:cNvSpPr>
-            <a:spLocks noGrp="1"/>
-          </p:cNvSpPr>
-          <p:nvPr>
-            <p:ph idx="1"/>
+          <p:cNvPr id="5" name="Footer Placeholder 4"/>
+          <p:cNvSpPr>
+            <a:spLocks noGrp="1"/>
+          </p:cNvSpPr>
+          <p:nvPr>
+            <p:ph type="ftr" sz="quarter" idx="11"/>
           </p:nvPr>
         </p:nvSpPr>
         <p:spPr/>
@@ -1188,51 +1256,18 @@
           <a:bodyPr/>
           <a:lstStyle/>
           <a:p>
-            <a:pPr lvl="0"/>
-            <a:r>
-              <a:rPr lang="en-US"/>
-              <a:t>Click to edit Master text styles</a:t>
-            </a:r>
-          </a:p>
-          <a:p>
-            <a:pPr lvl="1"/>
-            <a:r>
-              <a:rPr lang="en-US"/>
-              <a:t>Second level</a:t>
-            </a:r>
-          </a:p>
-          <a:p>
-            <a:pPr lvl="2"/>
-            <a:r>
-              <a:rPr lang="en-US"/>
-              <a:t>Third level</a:t>
-            </a:r>
-          </a:p>
-          <a:p>
-            <a:pPr lvl="3"/>
-            <a:r>
-              <a:rPr lang="en-US"/>
-              <a:t>Fourth level</a:t>
-            </a:r>
-          </a:p>
-          <a:p>
-            <a:pPr lvl="4"/>
-            <a:r>
-              <a:rPr lang="en-US"/>
-              <a:t>Fifth level</a:t>
-            </a:r>
             <a:endParaRPr lang="en-US" dirty="0"/>
           </a:p>
         </p:txBody>
       </p:sp>
       <p:sp>
         <p:nvSpPr>
-          <p:cNvPr id="4" name="Date Placeholder 3"/>
-          <p:cNvSpPr>
-            <a:spLocks noGrp="1"/>
-          </p:cNvSpPr>
-          <p:nvPr>
-            <p:ph type="dt" sz="half" idx="10"/>
+          <p:cNvPr id="6" name="Slide Number Placeholder 5"/>
+          <p:cNvSpPr>
+            <a:spLocks noGrp="1"/>
+          </p:cNvSpPr>
+          <p:nvPr>
+            <p:ph type="sldNum" sz="quarter" idx="12"/>
           </p:nvPr>
         </p:nvSpPr>
         <p:spPr/>
@@ -1240,60 +1275,18 @@
           <a:bodyPr/>
           <a:lstStyle/>
           <a:p>
-            <a:fld id="{846CE7D5-CF57-46EF-B807-FDD0502418D4}" type="datetimeFigureOut">
-              <a:rPr lang="en-US" smtClean="0"/>
-              <a:t>10/18/2026</a:t>
-            </a:fld>
-            <a:endParaRPr lang="en-US"/>
-          </a:p>
-        </p:txBody>
-      </p:sp>
-      <p:sp>
-        <p:nvSpPr>
-          <p:cNvPr id="5" name="Footer Placeholder 4"/>
-          <p:cNvSpPr>
-            <a:spLocks noGrp="1"/>
-          </p:cNvSpPr>
-          <p:nvPr>
-            <p:ph type="ftr" sz="quarter" idx="11"/>
-          </p:nvPr>
-        </p:nvSpPr>
-        <p:spPr/>
-        <p:txBody>
-          <a:bodyPr/>
-          <a:lstStyle/>
-          <a:p>
-            <a:endParaRPr lang="en-US"/>
-          </a:p>
-        </p:txBody>
-      </p:sp>
-      <p:sp>
-        <p:nvSpPr>
-          <p:cNvPr id="6" name="Slide Number Placeholder 5"/>
-          <p:cNvSpPr>
-            <a:spLocks noGrp="1"/>
-          </p:cNvSpPr>
-          <p:nvPr>
-            <p:ph type="sldNum" sz="quarter" idx="12"/>
-          </p:nvPr>
-        </p:nvSpPr>
-        <p:spPr/>
-        <p:txBody>
-          <a:bodyPr/>
-          <a:lstStyle/>
-          <a:p>
-            <a:fld id="{330EA680-D336-4FF7-8B7A-9848BB0A1C32}" type="slidenum">
-              <a:rPr lang="en-US" smtClean="0"/>
+            <a:fld id="{48F63A3B-78C7-47BE-AE5E-E10140E04643}" type="slidenum">
+              <a:rPr lang="en-US" dirty="0"/>
               <a:t>‹#›</a:t>
             </a:fld>
-            <a:endParaRPr lang="en-US"/>
+            <a:endParaRPr lang="en-US" dirty="0"/>
           </a:p>
         </p:txBody>
       </p:sp>
     </p:spTree>
     <p:extLst>
       <p:ext uri="{BB962C8B-B14F-4D97-AF65-F5344CB8AC3E}">
-        <p14:creationId xmlns:p14="http://schemas.microsoft.com/office/powerpoint/2010/main" val="949138452"/>
+        <p14:creationId xmlns:p14="http://schemas.microsoft.com/office/powerpoint/2010/main" val="1301550886"/>
       </p:ext>
     </p:extLst>
   </p:cSld>
@@ -1345,10 +1338,9 @@
           </a:lstStyle>
           <a:p>
             <a:r>
-              <a:rPr lang="en-US"/>
+              <a:rPr lang="en-US" dirty="0"/>
               <a:t>Click to edit Master title style</a:t>
             </a:r>
-            <a:endParaRPr lang="en-US" dirty="0"/>
           </a:p>
         </p:txBody>
       </p:sp>
@@ -1376,7 +1368,7 @@
               <a:defRPr sz="2400">
                 <a:solidFill>
                   <a:schemeClr val="tx1">
-                    <a:tint val="82000"/>
+                    <a:shade val="82000"/>
                   </a:schemeClr>
                 </a:solidFill>
               </a:defRPr>
@@ -1386,7 +1378,7 @@
               <a:defRPr sz="2000">
                 <a:solidFill>
                   <a:schemeClr val="tx1">
-                    <a:tint val="82000"/>
+                    <a:shade val="82000"/>
                   </a:schemeClr>
                 </a:solidFill>
               </a:defRPr>
@@ -1396,7 +1388,7 @@
               <a:defRPr sz="1800">
                 <a:solidFill>
                   <a:schemeClr val="tx1">
-                    <a:tint val="82000"/>
+                    <a:shade val="82000"/>
                   </a:schemeClr>
                 </a:solidFill>
               </a:defRPr>
@@ -1406,7 +1398,7 @@
               <a:defRPr sz="1600">
                 <a:solidFill>
                   <a:schemeClr val="tx1">
-                    <a:tint val="82000"/>
+                    <a:shade val="82000"/>
                   </a:schemeClr>
                 </a:solidFill>
               </a:defRPr>
@@ -1416,7 +1408,7 @@
               <a:defRPr sz="1600">
                 <a:solidFill>
                   <a:schemeClr val="tx1">
-                    <a:tint val="82000"/>
+                    <a:shade val="82000"/>
                   </a:schemeClr>
                 </a:solidFill>
               </a:defRPr>
@@ -1426,7 +1418,7 @@
               <a:defRPr sz="1600">
                 <a:solidFill>
                   <a:schemeClr val="tx1">
-                    <a:tint val="82000"/>
+                    <a:shade val="82000"/>
                   </a:schemeClr>
                 </a:solidFill>
               </a:defRPr>
@@ -1436,7 +1428,7 @@
               <a:defRPr sz="1600">
                 <a:solidFill>
                   <a:schemeClr val="tx1">
-                    <a:tint val="82000"/>
+                    <a:shade val="82000"/>
                   </a:schemeClr>
                 </a:solidFill>
               </a:defRPr>
@@ -1446,7 +1438,7 @@
               <a:defRPr sz="1600">
                 <a:solidFill>
                   <a:schemeClr val="tx1">
-                    <a:tint val="82000"/>
+                    <a:shade val="82000"/>
                   </a:schemeClr>
                 </a:solidFill>
               </a:defRPr>
@@ -1456,7 +1448,7 @@
               <a:defRPr sz="1600">
                 <a:solidFill>
                   <a:schemeClr val="tx1">
-                    <a:tint val="82000"/>
+                    <a:shade val="82000"/>
                   </a:schemeClr>
                 </a:solidFill>
               </a:defRPr>
@@ -1465,7 +1457,7 @@
           <a:p>
             <a:pPr lvl="0"/>
             <a:r>
-              <a:rPr lang="en-US"/>
+              <a:rPr lang="en-US" dirty="0"/>
               <a:t>Click to edit Master text styles</a:t>
             </a:r>
           </a:p>
@@ -1486,11 +1478,11 @@
           <a:bodyPr/>
           <a:lstStyle/>
           <a:p>
-            <a:fld id="{846CE7D5-CF57-46EF-B807-FDD0502418D4}" type="datetimeFigureOut">
-              <a:rPr lang="en-US" smtClean="0"/>
-              <a:t>10/18/2026</a:t>
+            <a:fld id="{C764DE79-268F-4C1A-8933-263129D2AF90}" type="datetimeFigureOut">
+              <a:rPr lang="en-US" dirty="0"/>
+              <a:t>10/24/2026</a:t>
             </a:fld>
-            <a:endParaRPr lang="en-US"/>
+            <a:endParaRPr lang="en-US" dirty="0"/>
           </a:p>
         </p:txBody>
       </p:sp>
@@ -1509,7 +1501,7 @@
           <a:bodyPr/>
           <a:lstStyle/>
           <a:p>
-            <a:endParaRPr lang="en-US"/>
+            <a:endParaRPr lang="en-US" dirty="0"/>
           </a:p>
         </p:txBody>
       </p:sp>
@@ -1528,18 +1520,18 @@
           <a:bodyPr/>
           <a:lstStyle/>
           <a:p>
-            <a:fld id="{330EA680-D336-4FF7-8B7A-9848BB0A1C32}" type="slidenum">
-              <a:rPr lang="en-US" smtClean="0"/>
+            <a:fld id="{48F63A3B-78C7-47BE-AE5E-E10140E04643}" type="slidenum">
+              <a:rPr lang="en-US" dirty="0"/>
               <a:t>‹#›</a:t>
             </a:fld>
-            <a:endParaRPr lang="en-US"/>
+            <a:endParaRPr lang="en-US" dirty="0"/>
           </a:p>
         </p:txBody>
       </p:sp>
     </p:spTree>
     <p:extLst>
       <p:ext uri="{BB962C8B-B14F-4D97-AF65-F5344CB8AC3E}">
-        <p14:creationId xmlns:p14="http://schemas.microsoft.com/office/powerpoint/2010/main" val="2591524520"/>
+        <p14:creationId xmlns:p14="http://schemas.microsoft.com/office/powerpoint/2010/main" val="23006333"/>
       </p:ext>
     </p:extLst>
   </p:cSld>
@@ -1582,10 +1574,9 @@
           <a:lstStyle/>
           <a:p>
             <a:r>
-              <a:rPr lang="en-US"/>
+              <a:rPr lang="en-US" dirty="0"/>
               <a:t>Click to edit Master title style</a:t>
             </a:r>
-            <a:endParaRPr lang="en-US" dirty="0"/>
           </a:p>
         </p:txBody>
       </p:sp>
@@ -1611,38 +1602,37 @@
           <a:p>
             <a:pPr lvl="0"/>
             <a:r>
-              <a:rPr lang="en-US"/>
+              <a:rPr lang="en-US" dirty="0"/>
               <a:t>Click to edit Master text styles</a:t>
             </a:r>
           </a:p>
           <a:p>
             <a:pPr lvl="1"/>
             <a:r>
-              <a:rPr lang="en-US"/>
+              <a:rPr lang="en-US" dirty="0"/>
               <a:t>Second level</a:t>
             </a:r>
           </a:p>
           <a:p>
             <a:pPr lvl="2"/>
             <a:r>
-              <a:rPr lang="en-US"/>
+              <a:rPr lang="en-US" dirty="0"/>
               <a:t>Third level</a:t>
             </a:r>
           </a:p>
           <a:p>
             <a:pPr lvl="3"/>
             <a:r>
-              <a:rPr lang="en-US"/>
+              <a:rPr lang="en-US" dirty="0"/>
               <a:t>Fourth level</a:t>
             </a:r>
           </a:p>
           <a:p>
             <a:pPr lvl="4"/>
             <a:r>
-              <a:rPr lang="en-US"/>
+              <a:rPr lang="en-US" dirty="0"/>
               <a:t>Fifth level</a:t>
             </a:r>
-            <a:endParaRPr lang="en-US" dirty="0"/>
           </a:p>
         </p:txBody>
       </p:sp>
@@ -1668,49 +1658,71 @@
           <a:p>
             <a:pPr lvl="0"/>
             <a:r>
-              <a:rPr lang="en-US"/>
+              <a:rPr lang="en-US" dirty="0"/>
               <a:t>Click to edit Master text styles</a:t>
             </a:r>
           </a:p>
           <a:p>
             <a:pPr lvl="1"/>
             <a:r>
-              <a:rPr lang="en-US"/>
+              <a:rPr lang="en-US" dirty="0"/>
               <a:t>Second level</a:t>
             </a:r>
           </a:p>
           <a:p>
             <a:pPr lvl="2"/>
             <a:r>
-              <a:rPr lang="en-US"/>
+              <a:rPr lang="en-US" dirty="0"/>
               <a:t>Third level</a:t>
             </a:r>
           </a:p>
           <a:p>
             <a:pPr lvl="3"/>
             <a:r>
-              <a:rPr lang="en-US"/>
+              <a:rPr lang="en-US" dirty="0"/>
               <a:t>Fourth level</a:t>
             </a:r>
           </a:p>
           <a:p>
             <a:pPr lvl="4"/>
             <a:r>
-              <a:rPr lang="en-US"/>
+              <a:rPr lang="en-US" dirty="0"/>
               <a:t>Fifth level</a:t>
             </a:r>
+          </a:p>
+        </p:txBody>
+      </p:sp>
+      <p:sp>
+        <p:nvSpPr>
+          <p:cNvPr id="5" name="Date Placeholder 4"/>
+          <p:cNvSpPr>
+            <a:spLocks noGrp="1"/>
+          </p:cNvSpPr>
+          <p:nvPr>
+            <p:ph type="dt" sz="half" idx="10"/>
+          </p:nvPr>
+        </p:nvSpPr>
+        <p:spPr/>
+        <p:txBody>
+          <a:bodyPr/>
+          <a:lstStyle/>
+          <a:p>
+            <a:fld id="{C764DE79-268F-4C1A-8933-263129D2AF90}" type="datetimeFigureOut">
+              <a:rPr lang="en-US" dirty="0"/>
+              <a:t>10/24/2026</a:t>
+            </a:fld>
             <a:endParaRPr lang="en-US" dirty="0"/>
           </a:p>
         </p:txBody>
       </p:sp>
       <p:sp>
         <p:nvSpPr>
-          <p:cNvPr id="5" name="Date Placeholder 4"/>
-          <p:cNvSpPr>
-            <a:spLocks noGrp="1"/>
-          </p:cNvSpPr>
-          <p:nvPr>
-            <p:ph type="dt" sz="half" idx="10"/>
+          <p:cNvPr id="6" name="Footer Placeholder 5"/>
+          <p:cNvSpPr>
+            <a:spLocks noGrp="1"/>
+          </p:cNvSpPr>
+          <p:nvPr>
+            <p:ph type="ftr" sz="quarter" idx="11"/>
           </p:nvPr>
         </p:nvSpPr>
         <p:spPr/>
@@ -1718,22 +1730,18 @@
           <a:bodyPr/>
           <a:lstStyle/>
           <a:p>
-            <a:fld id="{846CE7D5-CF57-46EF-B807-FDD0502418D4}" type="datetimeFigureOut">
-              <a:rPr lang="en-US" smtClean="0"/>
-              <a:t>10/18/2026</a:t>
-            </a:fld>
-            <a:endParaRPr lang="en-US"/>
-          </a:p>
-        </p:txBody>
-      </p:sp>
-      <p:sp>
-        <p:nvSpPr>
-          <p:cNvPr id="6" name="Footer Placeholder 5"/>
-          <p:cNvSpPr>
-            <a:spLocks noGrp="1"/>
-          </p:cNvSpPr>
-          <p:nvPr>
-            <p:ph type="ftr" sz="quarter" idx="11"/>
+            <a:endParaRPr lang="en-US" dirty="0"/>
+          </a:p>
+        </p:txBody>
+      </p:sp>
+      <p:sp>
+        <p:nvSpPr>
+          <p:cNvPr id="7" name="Slide Number Placeholder 6"/>
+          <p:cNvSpPr>
+            <a:spLocks noGrp="1"/>
+          </p:cNvSpPr>
+          <p:nvPr>
+            <p:ph type="sldNum" sz="quarter" idx="12"/>
           </p:nvPr>
         </p:nvSpPr>
         <p:spPr/>
@@ -1741,37 +1749,18 @@
           <a:bodyPr/>
           <a:lstStyle/>
           <a:p>
-            <a:endParaRPr lang="en-US"/>
-          </a:p>
-        </p:txBody>
-      </p:sp>
-      <p:sp>
-        <p:nvSpPr>
-          <p:cNvPr id="7" name="Slide Number Placeholder 6"/>
-          <p:cNvSpPr>
-            <a:spLocks noGrp="1"/>
-          </p:cNvSpPr>
-          <p:nvPr>
-            <p:ph type="sldNum" sz="quarter" idx="12"/>
-          </p:nvPr>
-        </p:nvSpPr>
-        <p:spPr/>
-        <p:txBody>
-          <a:bodyPr/>
-          <a:lstStyle/>
-          <a:p>
-            <a:fld id="{330EA680-D336-4FF7-8B7A-9848BB0A1C32}" type="slidenum">
-              <a:rPr lang="en-US" smtClean="0"/>
+            <a:fld id="{48F63A3B-78C7-47BE-AE5E-E10140E04643}" type="slidenum">
+              <a:rPr lang="en-US" dirty="0"/>
               <a:t>‹#›</a:t>
             </a:fld>
-            <a:endParaRPr lang="en-US"/>
+            <a:endParaRPr lang="en-US" dirty="0"/>
           </a:p>
         </p:txBody>
       </p:sp>
     </p:spTree>
     <p:extLst>
       <p:ext uri="{BB962C8B-B14F-4D97-AF65-F5344CB8AC3E}">
-        <p14:creationId xmlns:p14="http://schemas.microsoft.com/office/powerpoint/2010/main" val="1203092039"/>
+        <p14:creationId xmlns:p14="http://schemas.microsoft.com/office/powerpoint/2010/main" val="3553420964"/>
       </p:ext>
     </p:extLst>
   </p:cSld>
@@ -1819,10 +1808,9 @@
           <a:lstStyle/>
           <a:p>
             <a:r>
-              <a:rPr lang="en-US"/>
+              <a:rPr lang="en-US" dirty="0"/>
               <a:t>Click to edit Master title style</a:t>
             </a:r>
-            <a:endParaRPr lang="en-US" dirty="0"/>
           </a:p>
         </p:txBody>
       </p:sp>
@@ -1885,7 +1873,7 @@
           <a:p>
             <a:pPr lvl="0"/>
             <a:r>
-              <a:rPr lang="en-US"/>
+              <a:rPr lang="en-US" dirty="0"/>
               <a:t>Click to edit Master text styles</a:t>
             </a:r>
           </a:p>
@@ -1913,38 +1901,37 @@
           <a:p>
             <a:pPr lvl="0"/>
             <a:r>
-              <a:rPr lang="en-US"/>
+              <a:rPr lang="en-US" dirty="0"/>
               <a:t>Click to edit Master text styles</a:t>
             </a:r>
           </a:p>
           <a:p>
             <a:pPr lvl="1"/>
             <a:r>
-              <a:rPr lang="en-US"/>
+              <a:rPr lang="en-US" dirty="0"/>
               <a:t>Second level</a:t>
             </a:r>
           </a:p>
           <a:p>
             <a:pPr lvl="2"/>
             <a:r>
-              <a:rPr lang="en-US"/>
+              <a:rPr lang="en-US" dirty="0"/>
               <a:t>Third level</a:t>
             </a:r>
           </a:p>
           <a:p>
             <a:pPr lvl="3"/>
             <a:r>
-              <a:rPr lang="en-US"/>
+              <a:rPr lang="en-US" dirty="0"/>
               <a:t>Fourth level</a:t>
             </a:r>
           </a:p>
           <a:p>
             <a:pPr lvl="4"/>
             <a:r>
-              <a:rPr lang="en-US"/>
+              <a:rPr lang="en-US" dirty="0"/>
               <a:t>Fifth level</a:t>
             </a:r>
-            <a:endParaRPr lang="en-US" dirty="0"/>
           </a:p>
         </p:txBody>
       </p:sp>
@@ -2007,7 +1994,7 @@
           <a:p>
             <a:pPr lvl="0"/>
             <a:r>
-              <a:rPr lang="en-US"/>
+              <a:rPr lang="en-US" dirty="0"/>
               <a:t>Click to edit Master text styles</a:t>
             </a:r>
           </a:p>
@@ -2035,49 +2022,71 @@
           <a:p>
             <a:pPr lvl="0"/>
             <a:r>
-              <a:rPr lang="en-US"/>
+              <a:rPr lang="en-US" dirty="0"/>
               <a:t>Click to edit Master text styles</a:t>
             </a:r>
           </a:p>
           <a:p>
             <a:pPr lvl="1"/>
             <a:r>
-              <a:rPr lang="en-US"/>
+              <a:rPr lang="en-US" dirty="0"/>
               <a:t>Second level</a:t>
             </a:r>
           </a:p>
           <a:p>
             <a:pPr lvl="2"/>
             <a:r>
-              <a:rPr lang="en-US"/>
+              <a:rPr lang="en-US" dirty="0"/>
               <a:t>Third level</a:t>
             </a:r>
           </a:p>
           <a:p>
             <a:pPr lvl="3"/>
             <a:r>
-              <a:rPr lang="en-US"/>
+              <a:rPr lang="en-US" dirty="0"/>
               <a:t>Fourth level</a:t>
             </a:r>
           </a:p>
           <a:p>
             <a:pPr lvl="4"/>
             <a:r>
-              <a:rPr lang="en-US"/>
+              <a:rPr lang="en-US" dirty="0"/>
               <a:t>Fifth level</a:t>
             </a:r>
+          </a:p>
+        </p:txBody>
+      </p:sp>
+      <p:sp>
+        <p:nvSpPr>
+          <p:cNvPr id="7" name="Date Placeholder 6"/>
+          <p:cNvSpPr>
+            <a:spLocks noGrp="1"/>
+          </p:cNvSpPr>
+          <p:nvPr>
+            <p:ph type="dt" sz="half" idx="10"/>
+          </p:nvPr>
+        </p:nvSpPr>
+        <p:spPr/>
+        <p:txBody>
+          <a:bodyPr/>
+          <a:lstStyle/>
+          <a:p>
+            <a:fld id="{C764DE79-268F-4C1A-8933-263129D2AF90}" type="datetimeFigureOut">
+              <a:rPr lang="en-US" dirty="0"/>
+              <a:t>10/24/2026</a:t>
+            </a:fld>
             <a:endParaRPr lang="en-US" dirty="0"/>
           </a:p>
         </p:txBody>
       </p:sp>
       <p:sp>
         <p:nvSpPr>
-          <p:cNvPr id="7" name="Date Placeholder 6"/>
-          <p:cNvSpPr>
-            <a:spLocks noGrp="1"/>
-          </p:cNvSpPr>
-          <p:nvPr>
-            <p:ph type="dt" sz="half" idx="10"/>
+          <p:cNvPr id="8" name="Footer Placeholder 7"/>
+          <p:cNvSpPr>
+            <a:spLocks noGrp="1"/>
+          </p:cNvSpPr>
+          <p:nvPr>
+            <p:ph type="ftr" sz="quarter" idx="11"/>
           </p:nvPr>
         </p:nvSpPr>
         <p:spPr/>
@@ -2085,22 +2094,18 @@
           <a:bodyPr/>
           <a:lstStyle/>
           <a:p>
-            <a:fld id="{846CE7D5-CF57-46EF-B807-FDD0502418D4}" type="datetimeFigureOut">
-              <a:rPr lang="en-US" smtClean="0"/>
-              <a:t>10/18/2026</a:t>
-            </a:fld>
-            <a:endParaRPr lang="en-US"/>
-          </a:p>
-        </p:txBody>
-      </p:sp>
-      <p:sp>
-        <p:nvSpPr>
-          <p:cNvPr id="8" name="Footer Placeholder 7"/>
-          <p:cNvSpPr>
-            <a:spLocks noGrp="1"/>
-          </p:cNvSpPr>
-          <p:nvPr>
-            <p:ph type="ftr" sz="quarter" idx="11"/>
+            <a:endParaRPr lang="en-US" dirty="0"/>
+          </a:p>
+        </p:txBody>
+      </p:sp>
+      <p:sp>
+        <p:nvSpPr>
+          <p:cNvPr id="9" name="Slide Number Placeholder 8"/>
+          <p:cNvSpPr>
+            <a:spLocks noGrp="1"/>
+          </p:cNvSpPr>
+          <p:nvPr>
+            <p:ph type="sldNum" sz="quarter" idx="12"/>
           </p:nvPr>
         </p:nvSpPr>
         <p:spPr/>
@@ -2108,37 +2113,18 @@
           <a:bodyPr/>
           <a:lstStyle/>
           <a:p>
-            <a:endParaRPr lang="en-US"/>
-          </a:p>
-        </p:txBody>
-      </p:sp>
-      <p:sp>
-        <p:nvSpPr>
-          <p:cNvPr id="9" name="Slide Number Placeholder 8"/>
-          <p:cNvSpPr>
-            <a:spLocks noGrp="1"/>
-          </p:cNvSpPr>
-          <p:nvPr>
-            <p:ph type="sldNum" sz="quarter" idx="12"/>
-          </p:nvPr>
-        </p:nvSpPr>
-        <p:spPr/>
-        <p:txBody>
-          <a:bodyPr/>
-          <a:lstStyle/>
-          <a:p>
-            <a:fld id="{330EA680-D336-4FF7-8B7A-9848BB0A1C32}" type="slidenum">
-              <a:rPr lang="en-US" smtClean="0"/>
+            <a:fld id="{48F63A3B-78C7-47BE-AE5E-E10140E04643}" type="slidenum">
+              <a:rPr lang="en-US" dirty="0"/>
               <a:t>‹#›</a:t>
             </a:fld>
-            <a:endParaRPr lang="en-US"/>
+            <a:endParaRPr lang="en-US" dirty="0"/>
           </a:p>
         </p:txBody>
       </p:sp>
     </p:spTree>
     <p:extLst>
       <p:ext uri="{BB962C8B-B14F-4D97-AF65-F5344CB8AC3E}">
-        <p14:creationId xmlns:p14="http://schemas.microsoft.com/office/powerpoint/2010/main" val="3733172339"/>
+        <p14:creationId xmlns:p14="http://schemas.microsoft.com/office/powerpoint/2010/main" val="277781656"/>
       </p:ext>
     </p:extLst>
   </p:cSld>
@@ -2181,21 +2167,43 @@
           <a:lstStyle/>
           <a:p>
             <a:r>
-              <a:rPr lang="en-US"/>
+              <a:rPr lang="en-US" dirty="0"/>
               <a:t>Click to edit Master title style</a:t>
             </a:r>
+          </a:p>
+        </p:txBody>
+      </p:sp>
+      <p:sp>
+        <p:nvSpPr>
+          <p:cNvPr id="3" name="Date Placeholder 2"/>
+          <p:cNvSpPr>
+            <a:spLocks noGrp="1"/>
+          </p:cNvSpPr>
+          <p:nvPr>
+            <p:ph type="dt" sz="half" idx="10"/>
+          </p:nvPr>
+        </p:nvSpPr>
+        <p:spPr/>
+        <p:txBody>
+          <a:bodyPr/>
+          <a:lstStyle/>
+          <a:p>
+            <a:fld id="{C764DE79-268F-4C1A-8933-263129D2AF90}" type="datetimeFigureOut">
+              <a:rPr lang="en-US" dirty="0"/>
+              <a:t>10/24/2026</a:t>
+            </a:fld>
             <a:endParaRPr lang="en-US" dirty="0"/>
           </a:p>
         </p:txBody>
       </p:sp>
       <p:sp>
         <p:nvSpPr>
-          <p:cNvPr id="3" name="Date Placeholder 2"/>
-          <p:cNvSpPr>
-            <a:spLocks noGrp="1"/>
-          </p:cNvSpPr>
-          <p:nvPr>
-            <p:ph type="dt" sz="half" idx="10"/>
+          <p:cNvPr id="4" name="Footer Placeholder 3"/>
+          <p:cNvSpPr>
+            <a:spLocks noGrp="1"/>
+          </p:cNvSpPr>
+          <p:nvPr>
+            <p:ph type="ftr" sz="quarter" idx="11"/>
           </p:nvPr>
         </p:nvSpPr>
         <p:spPr/>
@@ -2203,22 +2211,18 @@
           <a:bodyPr/>
           <a:lstStyle/>
           <a:p>
-            <a:fld id="{846CE7D5-CF57-46EF-B807-FDD0502418D4}" type="datetimeFigureOut">
-              <a:rPr lang="en-US" smtClean="0"/>
-              <a:t>10/18/2026</a:t>
-            </a:fld>
-            <a:endParaRPr lang="en-US"/>
-          </a:p>
-        </p:txBody>
-      </p:sp>
-      <p:sp>
-        <p:nvSpPr>
-          <p:cNvPr id="4" name="Footer Placeholder 3"/>
-          <p:cNvSpPr>
-            <a:spLocks noGrp="1"/>
-          </p:cNvSpPr>
-          <p:nvPr>
-            <p:ph type="ftr" sz="quarter" idx="11"/>
+            <a:endParaRPr lang="en-US" dirty="0"/>
+          </a:p>
+        </p:txBody>
+      </p:sp>
+      <p:sp>
+        <p:nvSpPr>
+          <p:cNvPr id="5" name="Slide Number Placeholder 4"/>
+          <p:cNvSpPr>
+            <a:spLocks noGrp="1"/>
+          </p:cNvSpPr>
+          <p:nvPr>
+            <p:ph type="sldNum" sz="quarter" idx="12"/>
           </p:nvPr>
         </p:nvSpPr>
         <p:spPr/>
@@ -2226,37 +2230,18 @@
           <a:bodyPr/>
           <a:lstStyle/>
           <a:p>
-            <a:endParaRPr lang="en-US"/>
-          </a:p>
-        </p:txBody>
-      </p:sp>
-      <p:sp>
-        <p:nvSpPr>
-          <p:cNvPr id="5" name="Slide Number Placeholder 4"/>
-          <p:cNvSpPr>
-            <a:spLocks noGrp="1"/>
-          </p:cNvSpPr>
-          <p:nvPr>
-            <p:ph type="sldNum" sz="quarter" idx="12"/>
-          </p:nvPr>
-        </p:nvSpPr>
-        <p:spPr/>
-        <p:txBody>
-          <a:bodyPr/>
-          <a:lstStyle/>
-          <a:p>
-            <a:fld id="{330EA680-D336-4FF7-8B7A-9848BB0A1C32}" type="slidenum">
-              <a:rPr lang="en-US" smtClean="0"/>
+            <a:fld id="{48F63A3B-78C7-47BE-AE5E-E10140E04643}" type="slidenum">
+              <a:rPr lang="en-US" dirty="0"/>
               <a:t>‹#›</a:t>
             </a:fld>
-            <a:endParaRPr lang="en-US"/>
+            <a:endParaRPr lang="en-US" dirty="0"/>
           </a:p>
         </p:txBody>
       </p:sp>
     </p:spTree>
     <p:extLst>
       <p:ext uri="{BB962C8B-B14F-4D97-AF65-F5344CB8AC3E}">
-        <p14:creationId xmlns:p14="http://schemas.microsoft.com/office/powerpoint/2010/main" val="3210312558"/>
+        <p14:creationId xmlns:p14="http://schemas.microsoft.com/office/powerpoint/2010/main" val="1703252943"/>
       </p:ext>
     </p:extLst>
   </p:cSld>
@@ -2298,11 +2283,11 @@
           <a:bodyPr/>
           <a:lstStyle/>
           <a:p>
-            <a:fld id="{846CE7D5-CF57-46EF-B807-FDD0502418D4}" type="datetimeFigureOut">
-              <a:rPr lang="en-US" smtClean="0"/>
-              <a:t>10/18/2026</a:t>
+            <a:fld id="{C764DE79-268F-4C1A-8933-263129D2AF90}" type="datetimeFigureOut">
+              <a:rPr lang="en-US" dirty="0"/>
+              <a:t>10/24/2026</a:t>
             </a:fld>
-            <a:endParaRPr lang="en-US"/>
+            <a:endParaRPr lang="en-US" dirty="0"/>
           </a:p>
         </p:txBody>
       </p:sp>
@@ -2321,7 +2306,7 @@
           <a:bodyPr/>
           <a:lstStyle/>
           <a:p>
-            <a:endParaRPr lang="en-US"/>
+            <a:endParaRPr lang="en-US" dirty="0"/>
           </a:p>
         </p:txBody>
       </p:sp>
@@ -2340,18 +2325,18 @@
           <a:bodyPr/>
           <a:lstStyle/>
           <a:p>
-            <a:fld id="{330EA680-D336-4FF7-8B7A-9848BB0A1C32}" type="slidenum">
-              <a:rPr lang="en-US" smtClean="0"/>
+            <a:fld id="{48F63A3B-78C7-47BE-AE5E-E10140E04643}" type="slidenum">
+              <a:rPr lang="en-US" dirty="0"/>
               <a:t>‹#›</a:t>
             </a:fld>
-            <a:endParaRPr lang="en-US"/>
+            <a:endParaRPr lang="en-US" dirty="0"/>
           </a:p>
         </p:txBody>
       </p:sp>
     </p:spTree>
     <p:extLst>
       <p:ext uri="{BB962C8B-B14F-4D97-AF65-F5344CB8AC3E}">
-        <p14:creationId xmlns:p14="http://schemas.microsoft.com/office/powerpoint/2010/main" val="3146388984"/>
+        <p14:creationId xmlns:p14="http://schemas.microsoft.com/office/powerpoint/2010/main" val="4082481081"/>
       </p:ext>
     </p:extLst>
   </p:cSld>
@@ -2403,10 +2388,9 @@
           </a:lstStyle>
           <a:p>
             <a:r>
-              <a:rPr lang="en-US"/>
+              <a:rPr lang="en-US" dirty="0"/>
               <a:t>Click to edit Master title style</a:t>
             </a:r>
-            <a:endParaRPr lang="en-US" dirty="0"/>
           </a:p>
         </p:txBody>
       </p:sp>
@@ -2460,38 +2444,37 @@
           <a:p>
             <a:pPr lvl="0"/>
             <a:r>
-              <a:rPr lang="en-US"/>
+              <a:rPr lang="en-US" dirty="0"/>
               <a:t>Click to edit Master text styles</a:t>
             </a:r>
           </a:p>
           <a:p>
             <a:pPr lvl="1"/>
             <a:r>
-              <a:rPr lang="en-US"/>
+              <a:rPr lang="en-US" dirty="0"/>
               <a:t>Second level</a:t>
             </a:r>
           </a:p>
           <a:p>
             <a:pPr lvl="2"/>
             <a:r>
-              <a:rPr lang="en-US"/>
+              <a:rPr lang="en-US" dirty="0"/>
               <a:t>Third level</a:t>
             </a:r>
           </a:p>
           <a:p>
             <a:pPr lvl="3"/>
             <a:r>
-              <a:rPr lang="en-US"/>
+              <a:rPr lang="en-US" dirty="0"/>
               <a:t>Fourth level</a:t>
             </a:r>
           </a:p>
           <a:p>
             <a:pPr lvl="4"/>
             <a:r>
-              <a:rPr lang="en-US"/>
+              <a:rPr lang="en-US" dirty="0"/>
               <a:t>Fifth level</a:t>
             </a:r>
-            <a:endParaRPr lang="en-US" dirty="0"/>
           </a:p>
         </p:txBody>
       </p:sp>
@@ -2554,7 +2537,7 @@
           <a:p>
             <a:pPr lvl="0"/>
             <a:r>
-              <a:rPr lang="en-US"/>
+              <a:rPr lang="en-US" dirty="0"/>
               <a:t>Click to edit Master text styles</a:t>
             </a:r>
           </a:p>
@@ -2575,11 +2558,11 @@
           <a:bodyPr/>
           <a:lstStyle/>
           <a:p>
-            <a:fld id="{846CE7D5-CF57-46EF-B807-FDD0502418D4}" type="datetimeFigureOut">
-              <a:rPr lang="en-US" smtClean="0"/>
-              <a:t>10/18/2026</a:t>
+            <a:fld id="{C764DE79-268F-4C1A-8933-263129D2AF90}" type="datetimeFigureOut">
+              <a:rPr lang="en-US" dirty="0"/>
+              <a:t>10/24/2026</a:t>
             </a:fld>
-            <a:endParaRPr lang="en-US"/>
+            <a:endParaRPr lang="en-US" dirty="0"/>
           </a:p>
         </p:txBody>
       </p:sp>
@@ -2598,7 +2581,7 @@
           <a:bodyPr/>
           <a:lstStyle/>
           <a:p>
-            <a:endParaRPr lang="en-US"/>
+            <a:endParaRPr lang="en-US" dirty="0"/>
           </a:p>
         </p:txBody>
       </p:sp>
@@ -2617,18 +2600,18 @@
           <a:bodyPr/>
           <a:lstStyle/>
           <a:p>
-            <a:fld id="{330EA680-D336-4FF7-8B7A-9848BB0A1C32}" type="slidenum">
-              <a:rPr lang="en-US" smtClean="0"/>
+            <a:fld id="{48F63A3B-78C7-47BE-AE5E-E10140E04643}" type="slidenum">
+              <a:rPr lang="en-US" dirty="0"/>
               <a:t>‹#›</a:t>
             </a:fld>
-            <a:endParaRPr lang="en-US"/>
+            <a:endParaRPr lang="en-US" dirty="0"/>
           </a:p>
         </p:txBody>
       </p:sp>
     </p:spTree>
     <p:extLst>
       <p:ext uri="{BB962C8B-B14F-4D97-AF65-F5344CB8AC3E}">
-        <p14:creationId xmlns:p14="http://schemas.microsoft.com/office/powerpoint/2010/main" val="3171841454"/>
+        <p14:creationId xmlns:p14="http://schemas.microsoft.com/office/powerpoint/2010/main" val="927238579"/>
       </p:ext>
     </p:extLst>
   </p:cSld>
@@ -2680,10 +2663,9 @@
           </a:lstStyle>
           <a:p>
             <a:r>
-              <a:rPr lang="en-US"/>
+              <a:rPr lang="en-US" dirty="0"/>
               <a:t>Click to edit Master title style</a:t>
             </a:r>
-            <a:endParaRPr lang="en-US" dirty="0"/>
           </a:p>
         </p:txBody>
       </p:sp>
@@ -2807,7 +2789,7 @@
           <a:p>
             <a:pPr lvl="0"/>
             <a:r>
-              <a:rPr lang="en-US"/>
+              <a:rPr lang="en-US" dirty="0"/>
               <a:t>Click to edit Master text styles</a:t>
             </a:r>
           </a:p>
@@ -2828,11 +2810,11 @@
           <a:bodyPr/>
           <a:lstStyle/>
           <a:p>
-            <a:fld id="{846CE7D5-CF57-46EF-B807-FDD0502418D4}" type="datetimeFigureOut">
-              <a:rPr lang="en-US" smtClean="0"/>
-              <a:t>10/18/2026</a:t>
+            <a:fld id="{C764DE79-268F-4C1A-8933-263129D2AF90}" type="datetimeFigureOut">
+              <a:rPr lang="en-US" dirty="0"/>
+              <a:t>10/24/2026</a:t>
             </a:fld>
-            <a:endParaRPr lang="en-US"/>
+            <a:endParaRPr lang="en-US" dirty="0"/>
           </a:p>
         </p:txBody>
       </p:sp>
@@ -2851,7 +2833,7 @@
           <a:bodyPr/>
           <a:lstStyle/>
           <a:p>
-            <a:endParaRPr lang="en-US"/>
+            <a:endParaRPr lang="en-US" dirty="0"/>
           </a:p>
         </p:txBody>
       </p:sp>
@@ -2870,18 +2852,18 @@
           <a:bodyPr/>
           <a:lstStyle/>
           <a:p>
-            <a:fld id="{330EA680-D336-4FF7-8B7A-9848BB0A1C32}" type="slidenum">
-              <a:rPr lang="en-US" smtClean="0"/>
+            <a:fld id="{48F63A3B-78C7-47BE-AE5E-E10140E04643}" type="slidenum">
+              <a:rPr lang="en-US" dirty="0"/>
               <a:t>‹#›</a:t>
             </a:fld>
-            <a:endParaRPr lang="en-US"/>
+            <a:endParaRPr lang="en-US" dirty="0"/>
           </a:p>
         </p:txBody>
       </p:sp>
     </p:spTree>
     <p:extLst>
       <p:ext uri="{BB962C8B-B14F-4D97-AF65-F5344CB8AC3E}">
-        <p14:creationId xmlns:p14="http://schemas.microsoft.com/office/powerpoint/2010/main" val="1718958274"/>
+        <p14:creationId xmlns:p14="http://schemas.microsoft.com/office/powerpoint/2010/main" val="1189346932"/>
       </p:ext>
     </p:extLst>
   </p:cSld>
@@ -2939,10 +2921,9 @@
           <a:lstStyle/>
           <a:p>
             <a:r>
-              <a:rPr lang="en-US"/>
+              <a:rPr lang="en-US" dirty="0"/>
               <a:t>Click to edit Master title style</a:t>
             </a:r>
-            <a:endParaRPr lang="en-US" dirty="0"/>
           </a:p>
         </p:txBody>
       </p:sp>
@@ -2973,38 +2954,37 @@
           <a:p>
             <a:pPr lvl="0"/>
             <a:r>
-              <a:rPr lang="en-US"/>
+              <a:rPr lang="en-US" dirty="0"/>
               <a:t>Click to edit Master text styles</a:t>
             </a:r>
           </a:p>
           <a:p>
             <a:pPr lvl="1"/>
             <a:r>
-              <a:rPr lang="en-US"/>
+              <a:rPr lang="en-US" dirty="0"/>
               <a:t>Second level</a:t>
             </a:r>
           </a:p>
           <a:p>
             <a:pPr lvl="2"/>
             <a:r>
-              <a:rPr lang="en-US"/>
+              <a:rPr lang="en-US" dirty="0"/>
               <a:t>Third level</a:t>
             </a:r>
           </a:p>
           <a:p>
             <a:pPr lvl="3"/>
             <a:r>
-              <a:rPr lang="en-US"/>
+              <a:rPr lang="en-US" dirty="0"/>
               <a:t>Fourth level</a:t>
             </a:r>
           </a:p>
           <a:p>
             <a:pPr lvl="4"/>
             <a:r>
-              <a:rPr lang="en-US"/>
+              <a:rPr lang="en-US" dirty="0"/>
               <a:t>Fifth level</a:t>
             </a:r>
-            <a:endParaRPr lang="en-US" dirty="0"/>
           </a:p>
         </p:txBody>
       </p:sp>
@@ -3034,18 +3014,18 @@
               <a:defRPr sz="1200">
                 <a:solidFill>
                   <a:schemeClr val="tx1">
-                    <a:tint val="82000"/>
+                    <a:shade val="82000"/>
                   </a:schemeClr>
                 </a:solidFill>
               </a:defRPr>
             </a:lvl1pPr>
           </a:lstStyle>
           <a:p>
-            <a:fld id="{846CE7D5-CF57-46EF-B807-FDD0502418D4}" type="datetimeFigureOut">
-              <a:rPr lang="en-US" smtClean="0"/>
-              <a:t>10/18/2026</a:t>
+            <a:fld id="{C764DE79-268F-4C1A-8933-263129D2AF90}" type="datetimeFigureOut">
+              <a:rPr lang="en-US" dirty="0"/>
+              <a:t>10/24/2026</a:t>
             </a:fld>
-            <a:endParaRPr lang="en-US"/>
+            <a:endParaRPr lang="en-US" dirty="0"/>
           </a:p>
         </p:txBody>
       </p:sp>
@@ -3075,14 +3055,14 @@
               <a:defRPr sz="1200">
                 <a:solidFill>
                   <a:schemeClr val="tx1">
-                    <a:tint val="82000"/>
+                    <a:shade val="82000"/>
                   </a:schemeClr>
                 </a:solidFill>
               </a:defRPr>
             </a:lvl1pPr>
           </a:lstStyle>
           <a:p>
-            <a:endParaRPr lang="en-US"/>
+            <a:endParaRPr lang="en-US" dirty="0"/>
           </a:p>
         </p:txBody>
       </p:sp>
@@ -3112,41 +3092,41 @@
               <a:defRPr sz="1200">
                 <a:solidFill>
                   <a:schemeClr val="tx1">
-                    <a:tint val="82000"/>
+                    <a:shade val="82000"/>
                   </a:schemeClr>
                 </a:solidFill>
               </a:defRPr>
             </a:lvl1pPr>
           </a:lstStyle>
           <a:p>
-            <a:fld id="{330EA680-D336-4FF7-8B7A-9848BB0A1C32}" type="slidenum">
-              <a:rPr lang="en-US" smtClean="0"/>
+            <a:fld id="{48F63A3B-78C7-47BE-AE5E-E10140E04643}" type="slidenum">
+              <a:rPr lang="en-US" dirty="0"/>
               <a:t>‹#›</a:t>
             </a:fld>
-            <a:endParaRPr lang="en-US"/>
+            <a:endParaRPr lang="en-US" dirty="0"/>
           </a:p>
         </p:txBody>
       </p:sp>
     </p:spTree>
     <p:extLst>
       <p:ext uri="{BB962C8B-B14F-4D97-AF65-F5344CB8AC3E}">
-        <p14:creationId xmlns:p14="http://schemas.microsoft.com/office/powerpoint/2010/main" val="2460954070"/>
+        <p14:creationId xmlns:p14="http://schemas.microsoft.com/office/powerpoint/2010/main" val="2078183639"/>
       </p:ext>
     </p:extLst>
   </p:cSld>
-  <p:clrMap bg1="lt1" tx1="dk1" bg2="lt2" tx2="dk2" accent1="accent1" accent2="accent2" accent3="accent3" accent4="accent4" accent5="accent5" accent6="accent6" hlink="hlink" folHlink="folHlink"/>
+  <p:clrMap bg1="dk1" tx1="lt1" bg2="dk2" tx2="lt2" accent1="accent1" accent2="accent2" accent3="accent3" accent4="accent4" accent5="accent5" accent6="accent6" hlink="hlink" folHlink="folHlink"/>
   <p:sldLayoutIdLst>
-    <p:sldLayoutId id="2147483661" r:id="rId1"/>
-    <p:sldLayoutId id="2147483662" r:id="rId2"/>
-    <p:sldLayoutId id="2147483663" r:id="rId3"/>
-    <p:sldLayoutId id="2147483664" r:id="rId4"/>
-    <p:sldLayoutId id="2147483665" r:id="rId5"/>
-    <p:sldLayoutId id="2147483666" r:id="rId6"/>
-    <p:sldLayoutId id="2147483667" r:id="rId7"/>
-    <p:sldLayoutId id="2147483668" r:id="rId8"/>
-    <p:sldLayoutId id="2147483669" r:id="rId9"/>
-    <p:sldLayoutId id="2147483670" r:id="rId10"/>
-    <p:sldLayoutId id="2147483671" r:id="rId11"/>
+    <p:sldLayoutId id="2147483673" r:id="rId1"/>
+    <p:sldLayoutId id="2147483674" r:id="rId2"/>
+    <p:sldLayoutId id="2147483675" r:id="rId3"/>
+    <p:sldLayoutId id="2147483676" r:id="rId4"/>
+    <p:sldLayoutId id="2147483677" r:id="rId5"/>
+    <p:sldLayoutId id="2147483678" r:id="rId6"/>
+    <p:sldLayoutId id="2147483679" r:id="rId7"/>
+    <p:sldLayoutId id="2147483680" r:id="rId8"/>
+    <p:sldLayoutId id="2147483681" r:id="rId9"/>
+    <p:sldLayoutId id="2147483682" r:id="rId10"/>
+    <p:sldLayoutId id="2147483683" r:id="rId11"/>
   </p:sldLayoutIdLst>
   <p:txStyles>
     <p:titleStyle>
@@ -3464,14 +3444,26 @@
           <a:lstStyle/>
           <a:p>
             <a:r>
-              <a:rPr lang="en-US" dirty="0"/>
+              <a:rPr lang="en-US" dirty="0">
+                <a:latin typeface="Arial Nova"/>
+                <a:ea typeface="Calibri"/>
+                <a:cs typeface="Times New Roman"/>
+              </a:rPr>
               <a:t>Encoder/Decoder using </a:t>
             </a:r>
             <a:r>
-              <a:rPr lang="en-US"/>
+              <a:rPr lang="en-US">
+                <a:latin typeface="Arial Nova"/>
+                <a:ea typeface="Calibri"/>
+                <a:cs typeface="Times New Roman"/>
+              </a:rPr>
               <a:t>Arithmetic Coding</a:t>
             </a:r>
-            <a:endParaRPr lang="en-US" dirty="0"/>
+            <a:endParaRPr lang="en-US" dirty="0">
+              <a:latin typeface="Arial Nova"/>
+              <a:ea typeface="Calibri"/>
+              <a:cs typeface="Times New Roman"/>
+            </a:endParaRPr>
           </a:p>
         </p:txBody>
       </p:sp>
@@ -3493,8 +3485,12 @@
           <a:lstStyle/>
           <a:p>
             <a:r>
-              <a:rPr lang="en-US"/>
-              <a:t>T. Croft, W. Finney, B. Jones, D. Kwiecien</a:t>
+              <a:rPr lang="en-US">
+                <a:latin typeface="Arial Nova"/>
+                <a:ea typeface="Calibri"/>
+                <a:cs typeface="Times New Roman"/>
+              </a:rPr>
+              <a:t>T. Croft, W. Finney, B. Jones, D. Kwiecien, M. Reed</a:t>
             </a:r>
           </a:p>
         </p:txBody>
@@ -3603,12 +3599,16 @@
           <a:lstStyle/>
           <a:p>
             <a:r>
-              <a:rPr lang="en-US"/>
+              <a:rPr lang="en-US">
+                <a:latin typeface="Arial Nova"/>
+              </a:rPr>
               <a:t>Messages are encoded using a number inside the final interval.</a:t>
             </a:r>
           </a:p>
           <a:p>
-            <a:endParaRPr lang="en-US" dirty="0"/>
+            <a:endParaRPr lang="en-US" dirty="0">
+              <a:latin typeface="Arial Nova"/>
+            </a:endParaRPr>
           </a:p>
         </p:txBody>
       </p:sp>
@@ -3644,10 +3644,11 @@
           <a:lstStyle/>
           <a:p>
             <a:r>
-              <a:rPr lang="en-US"/>
-              <a:t>Interval: [0.36, 0.504)</a:t>
-            </a:r>
-            <a:endParaRPr lang="en-US" dirty="0"/>
+              <a:rPr lang="en-US">
+                <a:latin typeface="Arial Nova"/>
+              </a:rPr>
+              <a:t>Interval: [0.44, 0.59)</a:t>
+            </a:r>
           </a:p>
         </p:txBody>
       </p:sp>
@@ -3697,13 +3698,15 @@
           </a:fontRef>
         </p:style>
         <p:txBody>
-          <a:bodyPr rtlCol="0" anchor="ctr"/>
+          <a:bodyPr lIns="91440" tIns="45720" rIns="91440" bIns="45720" rtlCol="0" anchor="ctr"/>
           <a:lstStyle/>
           <a:p>
             <a:pPr algn="ctr"/>
             <a:r>
-              <a:rPr lang="en-US"/>
-              <a:t>D: 60%</a:t>
+              <a:rPr lang="en-US">
+                <a:latin typeface="Arial Nova"/>
+              </a:rPr>
+              <a:t>D: 66.67%</a:t>
             </a:r>
           </a:p>
         </p:txBody>
@@ -3741,8 +3744,10 @@
           <a:p>
             <a:pPr algn="l"/>
             <a:r>
-              <a:rPr lang="en-US"/>
-              <a:t>0.36</a:t>
+              <a:rPr lang="en-US">
+                <a:latin typeface="Arial Nova"/>
+              </a:rPr>
+              <a:t>0.44</a:t>
             </a:r>
           </a:p>
         </p:txBody>
@@ -3780,8 +3785,10 @@
           <a:p>
             <a:pPr algn="l"/>
             <a:r>
-              <a:rPr lang="en-US"/>
-              <a:t>0.504</a:t>
+              <a:rPr lang="en-US">
+                <a:latin typeface="Arial Nova"/>
+              </a:rPr>
+              <a:t>0.59</a:t>
             </a:r>
           </a:p>
         </p:txBody>
@@ -3800,8 +3807,8 @@
         </p:nvSpPr>
         <p:spPr>
           <a:xfrm>
-            <a:off x="4747846" y="2901462"/>
-            <a:ext cx="2354385" cy="523220"/>
+            <a:off x="5090194" y="2857288"/>
+            <a:ext cx="1647603" cy="954107"/>
           </a:xfrm>
           <a:prstGeom prst="rect">
             <a:avLst/>
@@ -3818,17 +3825,23 @@
           <a:lstStyle/>
           <a:p>
             <a:r>
-              <a:rPr lang="en-US" sz="2800">
+              <a:rPr lang="en-US" sz="2800" dirty="0">
+                <a:latin typeface="Arial Nova"/>
                 <a:cs typeface="Arial"/>
               </a:rPr>
-              <a:t>0.375  =</a:t>
-            </a:r>
-            <a:r>
-              <a:rPr lang="en-US" sz="2800" dirty="0">
+              <a:t>0.5  =</a:t>
+            </a:r>
+            <a:r>
+              <a:rPr lang="en-US" sz="2800">
+                <a:latin typeface="Arial Nova"/>
                 <a:cs typeface="Arial"/>
               </a:rPr>
-              <a:t> 0.011</a:t>
-            </a:r>
+              <a:t> 0.1</a:t>
+            </a:r>
+            <a:endParaRPr lang="en-US" sz="2800" dirty="0">
+              <a:latin typeface="Arial Nova"/>
+              <a:cs typeface="Arial"/>
+            </a:endParaRPr>
           </a:p>
         </p:txBody>
       </p:sp>
@@ -3846,7 +3859,7 @@
         </p:nvSpPr>
         <p:spPr>
           <a:xfrm>
-            <a:off x="5587999" y="3116384"/>
+            <a:off x="5532782" y="3116384"/>
             <a:ext cx="3350846" cy="307777"/>
           </a:xfrm>
           <a:prstGeom prst="rect">
@@ -3865,11 +3878,14 @@
           <a:p>
             <a:r>
               <a:rPr lang="en-US" sz="1400">
+                <a:latin typeface="Arial Nova"/>
                 <a:cs typeface="Arial"/>
               </a:rPr>
-              <a:t>10                             2</a:t>
-            </a:r>
-            <a:endParaRPr lang="en-US" sz="1400"/>
+              <a:t>10                    2</a:t>
+            </a:r>
+            <a:endParaRPr lang="en-US" sz="1400">
+              <a:latin typeface="Arial Nova"/>
+            </a:endParaRPr>
           </a:p>
         </p:txBody>
       </p:sp>
@@ -3887,8 +3903,8 @@
         </p:nvSpPr>
         <p:spPr>
           <a:xfrm>
-            <a:off x="4442790" y="4873996"/>
-            <a:ext cx="2960574" cy="369332"/>
+            <a:off x="4542181" y="4862953"/>
+            <a:ext cx="2772835" cy="646331"/>
           </a:xfrm>
           <a:prstGeom prst="rect">
             <a:avLst/>
@@ -3905,8 +3921,10 @@
           <a:lstStyle/>
           <a:p>
             <a:r>
-              <a:rPr lang="en-US"/>
-              <a:t>DAD can be encoded as 011</a:t>
+              <a:rPr lang="en-US">
+                <a:latin typeface="Arial Nova"/>
+              </a:rPr>
+              <a:t>DAD can be encoded as 1</a:t>
             </a:r>
           </a:p>
         </p:txBody>
@@ -3921,13 +3939,13 @@
   <p:clrMapOvr>
     <a:masterClrMapping/>
   </p:clrMapOvr>
-  <mc:AlternateContent xmlns:mc="http://schemas.openxmlformats.org/markup-compatibility/2006">
-    <mc:Choice xmlns:p159="http://schemas.microsoft.com/office/powerpoint/2015/09/main" Requires="p159">
+  <mc:AlternateContent xmlns:mc="http://schemas.openxmlformats.org/markup-compatibility/2006" xmlns:p159="http://schemas.microsoft.com/office/powerpoint/2015/09/main">
+    <mc:Choice Requires="p159">
       <p:transition xmlns:p14="http://schemas.microsoft.com/office/powerpoint/2010/main" spd="slow" p14:dur="2000">
         <p159:morph option="byObject"/>
       </p:transition>
     </mc:Choice>
-    <mc:Fallback>
+    <mc:Fallback xmlns="">
       <p:transition spd="slow">
         <p:fade/>
       </p:transition>
@@ -3975,7 +3993,9 @@
           <a:lstStyle/>
           <a:p>
             <a:r>
-              <a:rPr lang="en-US"/>
+              <a:rPr lang="en-US">
+                <a:latin typeface="Arial Nova"/>
+              </a:rPr>
               <a:t>Demonstration</a:t>
             </a:r>
           </a:p>
@@ -4002,7 +4022,9 @@
           <a:bodyPr/>
           <a:lstStyle/>
           <a:p>
-            <a:endParaRPr lang="en-US"/>
+            <a:endParaRPr lang="en-US">
+              <a:latin typeface="Arial Nova"/>
+            </a:endParaRPr>
           </a:p>
         </p:txBody>
       </p:sp>
@@ -4058,7 +4080,9 @@
           <a:lstStyle/>
           <a:p>
             <a:r>
-              <a:rPr lang="en-US"/>
+              <a:rPr lang="en-US">
+                <a:latin typeface="Arial Nova"/>
+              </a:rPr>
               <a:t>Results</a:t>
             </a:r>
           </a:p>
@@ -4088,37 +4112,70 @@
           <a:lstStyle/>
           <a:p>
             <a:r>
-              <a:rPr lang="en-US" dirty="0"/>
-              <a:t>[explain performa</a:t>
-            </a:r>
-            <a:r>
-              <a:rPr lang="en-US"/>
-              <a:t>nce, both effectiveness, and complexity]</a:t>
-            </a:r>
-          </a:p>
-          <a:p>
-            <a:r>
-              <a:rPr lang="en-US" dirty="0"/>
-              <a:t>[trade-offs of </a:t>
-            </a:r>
-            <a:r>
-              <a:rPr lang="en-US" dirty="0" err="1"/>
-              <a:t>Arith</a:t>
-            </a:r>
-            <a:r>
-              <a:rPr lang="en-US" dirty="0"/>
-              <a:t> Code]</a:t>
-            </a:r>
-          </a:p>
-          <a:p>
-            <a:r>
-              <a:rPr lang="en-US"/>
+              <a:rPr lang="en-US" dirty="0">
+                <a:latin typeface="Arial Nova"/>
+              </a:rPr>
+              <a:t>O(n) time comple</a:t>
+            </a:r>
+            <a:r>
+              <a:rPr lang="en-US">
+                <a:latin typeface="Arial Nova"/>
+              </a:rPr>
+              <a:t>xity.</a:t>
+            </a:r>
+            <a:endParaRPr lang="en-US" dirty="0">
+              <a:latin typeface="Arial Nova"/>
+            </a:endParaRPr>
+          </a:p>
+          <a:p>
+            <a:r>
+              <a:rPr lang="en-US">
+                <a:latin typeface="Arial Nova"/>
+              </a:rPr>
+              <a:t>Highly effective at encoding files with repeated pattens.</a:t>
+            </a:r>
+            <a:endParaRPr lang="en-US" dirty="0">
+              <a:latin typeface="Arial Nova"/>
+            </a:endParaRPr>
+          </a:p>
+          <a:p>
+            <a:r>
+              <a:rPr lang="en-US" dirty="0">
+                <a:latin typeface="Arial Nova"/>
+              </a:rPr>
+              <a:t>More </a:t>
+            </a:r>
+            <a:r>
+              <a:rPr lang="en-US" err="1">
+                <a:latin typeface="Arial Nova"/>
+              </a:rPr>
+              <a:t>computationall</a:t>
+            </a:r>
+            <a:r>
+              <a:rPr lang="en-US">
+                <a:latin typeface="Arial Nova"/>
+              </a:rPr>
+              <a:t>y complex than alternative compression algorithms.</a:t>
+            </a:r>
+            <a:endParaRPr lang="en-US" dirty="0">
+              <a:latin typeface="Arial Nova"/>
+            </a:endParaRPr>
+          </a:p>
+          <a:p>
+            <a:r>
+              <a:rPr lang="en-US">
+                <a:latin typeface="Arial Nova"/>
+              </a:rPr>
               <a:t>Valuable in image/video compression and scientific data storage.</a:t>
             </a:r>
-            <a:endParaRPr lang="en-US" dirty="0"/>
-          </a:p>
-          <a:p>
-            <a:endParaRPr lang="en-US" dirty="0"/>
+            <a:endParaRPr lang="en-US" dirty="0">
+              <a:latin typeface="Arial Nova"/>
+            </a:endParaRPr>
+          </a:p>
+          <a:p>
+            <a:endParaRPr lang="en-US" dirty="0">
+              <a:latin typeface="Arial Nova"/>
+            </a:endParaRPr>
           </a:p>
         </p:txBody>
       </p:sp>
@@ -4126,6 +4183,66 @@
     <p:extLst>
       <p:ext uri="{BB962C8B-B14F-4D97-AF65-F5344CB8AC3E}">
         <p14:creationId xmlns:p14="http://schemas.microsoft.com/office/powerpoint/2010/main" val="653080710"/>
+      </p:ext>
+    </p:extLst>
+  </p:cSld>
+  <p:clrMapOvr>
+    <a:masterClrMapping/>
+  </p:clrMapOvr>
+</p:sld>
+</file>
+
+<file path=ppt/slides/slide13.xml><?xml version="1.0" encoding="utf-8"?>
+<p:sld xmlns:a="http://schemas.openxmlformats.org/drawingml/2006/main" xmlns:r="http://schemas.openxmlformats.org/officeDocument/2006/relationships" xmlns:p="http://schemas.openxmlformats.org/presentationml/2006/main">
+  <p:cSld>
+    <p:spTree>
+      <p:nvGrpSpPr>
+        <p:cNvPr id="1" name=""/>
+        <p:cNvGrpSpPr/>
+        <p:nvPr/>
+      </p:nvGrpSpPr>
+      <p:grpSpPr>
+        <a:xfrm>
+          <a:off x="0" y="0"/>
+          <a:ext cx="0" cy="0"/>
+          <a:chOff x="0" y="0"/>
+          <a:chExt cx="0" cy="0"/>
+        </a:xfrm>
+      </p:grpSpPr>
+      <p:sp>
+        <p:nvSpPr>
+          <p:cNvPr id="2" name="Title 1">
+            <a:extLst>
+              <a:ext uri="{FF2B5EF4-FFF2-40B4-BE49-F238E27FC236}">
+                <a16:creationId xmlns:a16="http://schemas.microsoft.com/office/drawing/2014/main" id="{673C0368-51D2-B46F-0D42-D42E451B0C96}"/>
+              </a:ext>
+            </a:extLst>
+          </p:cNvPr>
+          <p:cNvSpPr>
+            <a:spLocks noGrp="1"/>
+          </p:cNvSpPr>
+          <p:nvPr>
+            <p:ph type="title"/>
+          </p:nvPr>
+        </p:nvSpPr>
+        <p:spPr/>
+        <p:txBody>
+          <a:bodyPr/>
+          <a:lstStyle/>
+          <a:p>
+            <a:r>
+              <a:rPr lang="en-US">
+                <a:latin typeface="Arial Nova"/>
+              </a:rPr>
+              <a:t>Discussion</a:t>
+            </a:r>
+          </a:p>
+        </p:txBody>
+      </p:sp>
+    </p:spTree>
+    <p:extLst>
+      <p:ext uri="{BB962C8B-B14F-4D97-AF65-F5344CB8AC3E}">
+        <p14:creationId xmlns:p14="http://schemas.microsoft.com/office/powerpoint/2010/main" val="2677593763"/>
       </p:ext>
     </p:extLst>
   </p:cSld>
@@ -4174,7 +4291,9 @@
           <a:lstStyle/>
           <a:p>
             <a:r>
-              <a:rPr lang="en-US"/>
+              <a:rPr lang="en-US">
+                <a:latin typeface="Arial Nova"/>
+              </a:rPr>
               <a:t>The problem: File Compression</a:t>
             </a:r>
           </a:p>
@@ -4204,48 +4323,56 @@
           <a:lstStyle/>
           <a:p>
             <a:r>
-              <a:rPr lang="en-US" dirty="0"/>
+              <a:rPr lang="en-US" dirty="0">
+                <a:latin typeface="Arial Nova"/>
+              </a:rPr>
               <a:t>Files can take up too much storage and </a:t>
             </a:r>
             <a:r>
-              <a:rPr lang="en-US"/>
+              <a:rPr lang="en-US">
+                <a:latin typeface="Arial Nova"/>
+              </a:rPr>
               <a:t>bandwidth.</a:t>
             </a:r>
           </a:p>
           <a:p>
             <a:r>
-              <a:rPr lang="en-US" dirty="0"/>
+              <a:rPr lang="en-US" dirty="0">
+                <a:latin typeface="Arial Nova"/>
+              </a:rPr>
               <a:t>Traditional approaches cannot </a:t>
             </a:r>
             <a:r>
-              <a:rPr lang="en-US"/>
+              <a:rPr lang="en-US">
+                <a:latin typeface="Arial Nova"/>
+              </a:rPr>
               <a:t>achieve</a:t>
             </a:r>
             <a:r>
-              <a:rPr lang="en-US" dirty="0"/>
+              <a:rPr lang="en-US" dirty="0">
+                <a:latin typeface="Arial Nova"/>
+              </a:rPr>
               <a:t> compression close to the </a:t>
             </a:r>
             <a:r>
-              <a:rPr lang="en-US"/>
+              <a:rPr lang="en-US">
+                <a:latin typeface="Arial Nova"/>
+              </a:rPr>
               <a:t>source's entropy.</a:t>
             </a:r>
           </a:p>
           <a:p>
             <a:r>
-              <a:rPr lang="en-US" dirty="0"/>
-              <a:t>The </a:t>
-            </a:r>
-            <a:r>
-              <a:rPr lang="en-US"/>
-              <a:t>Arithmetic</a:t>
-            </a:r>
-            <a:r>
-              <a:rPr lang="en-US" dirty="0"/>
-              <a:t> Coding algorithm addresses this.</a:t>
-            </a:r>
-          </a:p>
-          <a:p>
-            <a:endParaRPr lang="en-US" dirty="0"/>
+              <a:rPr lang="en-US">
+                <a:latin typeface="Arial Nova"/>
+              </a:rPr>
+              <a:t>Our Encoder/Decoder algorithm addresses this using Arithmetic Coding.</a:t>
+            </a:r>
+          </a:p>
+          <a:p>
+            <a:endParaRPr lang="en-US" dirty="0">
+              <a:latin typeface="Arial Nova"/>
+            </a:endParaRPr>
           </a:p>
         </p:txBody>
       </p:sp>
@@ -4329,7 +4456,9 @@
           <a:lstStyle/>
           <a:p>
             <a:pPr algn="ctr"/>
-            <a:endParaRPr lang="en-US" dirty="0"/>
+            <a:endParaRPr lang="en-US" dirty="0">
+              <a:latin typeface="Arial Nova"/>
+            </a:endParaRPr>
           </a:p>
         </p:txBody>
       </p:sp>
@@ -4365,16 +4494,22 @@
           <a:lstStyle/>
           <a:p>
             <a:r>
-              <a:rPr lang="en-US"/>
+              <a:rPr lang="en-US">
+                <a:latin typeface="Arial Nova"/>
+              </a:rPr>
               <a:t>Symbols are assigned portions of a narrowing interval based on probability, starting as [0, 1).</a:t>
             </a:r>
           </a:p>
           <a:p>
-            <a:endParaRPr lang="en-US" dirty="0"/>
-          </a:p>
-          <a:p>
-            <a:r>
-              <a:rPr lang="en-US"/>
+            <a:endParaRPr lang="en-US" dirty="0">
+              <a:latin typeface="Arial Nova"/>
+            </a:endParaRPr>
+          </a:p>
+          <a:p>
+            <a:r>
+              <a:rPr lang="en-US">
+                <a:latin typeface="Arial Nova"/>
+              </a:rPr>
               <a:t>Here, we encode the word "DAD".</a:t>
             </a:r>
           </a:p>
@@ -4413,7 +4548,9 @@
           <a:p>
             <a:pPr algn="l"/>
             <a:r>
-              <a:rPr lang="en-US"/>
+              <a:rPr lang="en-US">
+                <a:latin typeface="Arial Nova"/>
+              </a:rPr>
               <a:t>0.0</a:t>
             </a:r>
           </a:p>
@@ -4452,7 +4589,9 @@
           <a:p>
             <a:pPr algn="l"/>
             <a:r>
-              <a:rPr lang="en-US"/>
+              <a:rPr lang="en-US">
+                <a:latin typeface="Arial Nova"/>
+              </a:rPr>
               <a:t>1.0</a:t>
             </a:r>
           </a:p>
@@ -4508,7 +4647,9 @@
           <a:lstStyle/>
           <a:p>
             <a:pPr algn="ctr"/>
-            <a:endParaRPr lang="en-US" dirty="0"/>
+            <a:endParaRPr lang="en-US" dirty="0">
+              <a:latin typeface="Arial Nova"/>
+            </a:endParaRPr>
           </a:p>
         </p:txBody>
       </p:sp>
@@ -4580,10 +4721,14 @@
           <a:lstStyle/>
           <a:p>
             <a:r>
-              <a:rPr lang="en-US"/>
+              <a:rPr lang="en-US">
+                <a:latin typeface="Arial Nova"/>
+              </a:rPr>
               <a:t>Interval: [0, 1)</a:t>
             </a:r>
-            <a:endParaRPr lang="en-US" dirty="0"/>
+            <a:endParaRPr lang="en-US" dirty="0">
+              <a:latin typeface="Arial Nova"/>
+            </a:endParaRPr>
           </a:p>
         </p:txBody>
       </p:sp>
@@ -4669,13 +4814,15 @@
           </a:fontRef>
         </p:style>
         <p:txBody>
-          <a:bodyPr rtlCol="0" anchor="ctr"/>
+          <a:bodyPr lIns="91440" tIns="45720" rIns="91440" bIns="45720" rtlCol="0" anchor="ctr"/>
           <a:lstStyle/>
           <a:p>
             <a:pPr algn="ctr"/>
             <a:r>
-              <a:rPr lang="en-US"/>
-              <a:t>D: 60%</a:t>
+              <a:rPr lang="en-US">
+                <a:latin typeface="Arial Nova"/>
+              </a:rPr>
+              <a:t>D: 66.67%</a:t>
             </a:r>
           </a:p>
         </p:txBody>
@@ -4731,8 +4878,10 @@
           <a:p>
             <a:pPr algn="ctr"/>
             <a:r>
-              <a:rPr lang="en-US"/>
-              <a:t>A: 40%</a:t>
+              <a:rPr lang="en-US">
+                <a:latin typeface="Arial Nova"/>
+              </a:rPr>
+              <a:t>A: 33.33%</a:t>
             </a:r>
           </a:p>
         </p:txBody>
@@ -4805,7 +4954,9 @@
           <a:lstStyle/>
           <a:p>
             <a:r>
-              <a:rPr lang="en-US"/>
+              <a:rPr lang="en-US">
+                <a:latin typeface="Arial Nova"/>
+              </a:rPr>
               <a:t>Divide by probability of letters appearing in "DAD"</a:t>
             </a:r>
           </a:p>
@@ -4844,7 +4995,9 @@
           <a:p>
             <a:pPr algn="l"/>
             <a:r>
-              <a:rPr lang="en-US"/>
+              <a:rPr lang="en-US">
+                <a:latin typeface="Arial Nova"/>
+              </a:rPr>
               <a:t>0.0</a:t>
             </a:r>
           </a:p>
@@ -4883,7 +5036,9 @@
           <a:p>
             <a:pPr algn="l"/>
             <a:r>
-              <a:rPr lang="en-US"/>
+              <a:rPr lang="en-US">
+                <a:latin typeface="Arial Nova"/>
+              </a:rPr>
               <a:t>1.0</a:t>
             </a:r>
           </a:p>
@@ -4921,10 +5076,14 @@
           <a:lstStyle/>
           <a:p>
             <a:r>
-              <a:rPr lang="en-US"/>
+              <a:rPr lang="en-US">
+                <a:latin typeface="Arial Nova"/>
+              </a:rPr>
               <a:t>Interval: [0, 1)</a:t>
             </a:r>
-            <a:endParaRPr lang="en-US" dirty="0"/>
+            <a:endParaRPr lang="en-US" dirty="0">
+              <a:latin typeface="Arial Nova"/>
+            </a:endParaRPr>
           </a:p>
         </p:txBody>
       </p:sp>
@@ -4942,8 +5101,8 @@
         </p:nvSpPr>
         <p:spPr>
           <a:xfrm>
-            <a:off x="6832145" y="4086055"/>
-            <a:ext cx="598417" cy="369332"/>
+            <a:off x="6699624" y="4075012"/>
+            <a:ext cx="874503" cy="369332"/>
           </a:xfrm>
           <a:prstGeom prst="rect">
             <a:avLst/>
@@ -4961,8 +5120,10 @@
           <a:p>
             <a:pPr algn="l"/>
             <a:r>
-              <a:rPr lang="en-US"/>
-              <a:t>0.6</a:t>
+              <a:rPr lang="en-US">
+                <a:latin typeface="Arial Nova"/>
+              </a:rPr>
+              <a:t>0.67</a:t>
             </a:r>
           </a:p>
         </p:txBody>
@@ -5035,7 +5196,9 @@
           <a:lstStyle/>
           <a:p>
             <a:r>
-              <a:rPr lang="en-US"/>
+              <a:rPr lang="en-US">
+                <a:latin typeface="Arial Nova"/>
+              </a:rPr>
               <a:t>We keep section D and discard the rest, narrowing the interval.</a:t>
             </a:r>
           </a:p>
@@ -5073,10 +5236,14 @@
           <a:lstStyle/>
           <a:p>
             <a:r>
-              <a:rPr lang="en-US"/>
-              <a:t>Interval: [0, 0.6)</a:t>
-            </a:r>
-            <a:endParaRPr lang="en-US" dirty="0"/>
+              <a:rPr lang="en-US">
+                <a:latin typeface="Arial Nova"/>
+              </a:rPr>
+              <a:t>Interval: [0, 0.67)</a:t>
+            </a:r>
+            <a:endParaRPr lang="en-US" dirty="0">
+              <a:latin typeface="Arial Nova"/>
+            </a:endParaRPr>
           </a:p>
         </p:txBody>
       </p:sp>
@@ -5126,13 +5293,15 @@
           </a:fontRef>
         </p:style>
         <p:txBody>
-          <a:bodyPr rtlCol="0" anchor="ctr"/>
+          <a:bodyPr lIns="91440" tIns="45720" rIns="91440" bIns="45720" rtlCol="0" anchor="ctr"/>
           <a:lstStyle/>
           <a:p>
             <a:pPr algn="ctr"/>
             <a:r>
-              <a:rPr lang="en-US"/>
-              <a:t>D: 60%</a:t>
+              <a:rPr lang="en-US">
+                <a:latin typeface="Arial Nova"/>
+              </a:rPr>
+              <a:t>D: 66.67%</a:t>
             </a:r>
           </a:p>
         </p:txBody>
@@ -5170,7 +5339,9 @@
           <a:p>
             <a:pPr algn="l"/>
             <a:r>
-              <a:rPr lang="en-US"/>
+              <a:rPr lang="en-US">
+                <a:latin typeface="Arial Nova"/>
+              </a:rPr>
               <a:t>0.0</a:t>
             </a:r>
           </a:p>
@@ -5190,8 +5361,8 @@
         </p:nvSpPr>
         <p:spPr>
           <a:xfrm>
-            <a:off x="10563757" y="4066546"/>
-            <a:ext cx="594009" cy="369332"/>
+            <a:off x="10497497" y="4066546"/>
+            <a:ext cx="814876" cy="369332"/>
           </a:xfrm>
           <a:prstGeom prst="rect">
             <a:avLst/>
@@ -5209,8 +5380,10 @@
           <a:p>
             <a:pPr algn="l"/>
             <a:r>
-              <a:rPr lang="en-US"/>
-              <a:t>0.6</a:t>
+              <a:rPr lang="en-US">
+                <a:latin typeface="Arial Nova"/>
+              </a:rPr>
+              <a:t>0.67</a:t>
             </a:r>
           </a:p>
         </p:txBody>
@@ -5354,8 +5527,10 @@
           <a:p>
             <a:pPr algn="ctr"/>
             <a:r>
-              <a:rPr lang="en-US"/>
-              <a:t>A: 40%</a:t>
+              <a:rPr lang="en-US">
+                <a:latin typeface="Arial Nova"/>
+              </a:rPr>
+              <a:t>A: 33.33%</a:t>
             </a:r>
           </a:p>
         </p:txBody>
@@ -5410,13 +5585,15 @@
           </a:fontRef>
         </p:style>
         <p:txBody>
-          <a:bodyPr rtlCol="0" anchor="ctr"/>
+          <a:bodyPr lIns="91440" tIns="45720" rIns="91440" bIns="45720" rtlCol="0" anchor="ctr"/>
           <a:lstStyle/>
           <a:p>
             <a:pPr algn="ctr"/>
             <a:r>
-              <a:rPr lang="en-US"/>
-              <a:t>D: 60%</a:t>
+              <a:rPr lang="en-US">
+                <a:latin typeface="Arial Nova"/>
+              </a:rPr>
+              <a:t>D: 66.67%</a:t>
             </a:r>
           </a:p>
         </p:txBody>
@@ -5489,7 +5666,9 @@
           <a:lstStyle/>
           <a:p>
             <a:r>
-              <a:rPr lang="en-US"/>
+              <a:rPr lang="en-US">
+                <a:latin typeface="Arial Nova"/>
+              </a:rPr>
               <a:t>We continue to split until a small interval remains.</a:t>
             </a:r>
           </a:p>
@@ -5528,7 +5707,9 @@
           <a:p>
             <a:pPr algn="l"/>
             <a:r>
-              <a:rPr lang="en-US"/>
+              <a:rPr lang="en-US">
+                <a:latin typeface="Arial Nova"/>
+              </a:rPr>
               <a:t>0.0</a:t>
             </a:r>
           </a:p>
@@ -5549,7 +5730,7 @@
         <p:spPr>
           <a:xfrm>
             <a:off x="10563757" y="4066546"/>
-            <a:ext cx="594009" cy="369332"/>
+            <a:ext cx="660269" cy="369332"/>
           </a:xfrm>
           <a:prstGeom prst="rect">
             <a:avLst/>
@@ -5567,8 +5748,10 @@
           <a:p>
             <a:pPr algn="l"/>
             <a:r>
-              <a:rPr lang="en-US"/>
-              <a:t>0.6</a:t>
+              <a:rPr lang="en-US">
+                <a:latin typeface="Arial Nova"/>
+              </a:rPr>
+              <a:t>0.67</a:t>
             </a:r>
           </a:p>
         </p:txBody>
@@ -5605,10 +5788,14 @@
           <a:lstStyle/>
           <a:p>
             <a:r>
-              <a:rPr lang="en-US"/>
-              <a:t>Interval: [0, 0.6)</a:t>
-            </a:r>
-            <a:endParaRPr lang="en-US" dirty="0"/>
+              <a:rPr lang="en-US">
+                <a:latin typeface="Arial Nova"/>
+              </a:rPr>
+              <a:t>Interval: [0, 0.67)</a:t>
+            </a:r>
+            <a:endParaRPr lang="en-US" dirty="0">
+              <a:latin typeface="Arial Nova"/>
+            </a:endParaRPr>
           </a:p>
         </p:txBody>
       </p:sp>
@@ -5645,8 +5832,10 @@
           <a:p>
             <a:pPr algn="l"/>
             <a:r>
-              <a:rPr lang="en-US"/>
-              <a:t>0.36</a:t>
+              <a:rPr lang="en-US">
+                <a:latin typeface="Arial Nova"/>
+              </a:rPr>
+              <a:t>0.44</a:t>
             </a:r>
           </a:p>
         </p:txBody>
@@ -5742,8 +5931,10 @@
           <a:p>
             <a:pPr algn="ctr"/>
             <a:r>
-              <a:rPr lang="en-US"/>
-              <a:t>A: 40%</a:t>
+              <a:rPr lang="en-US">
+                <a:latin typeface="Arial Nova"/>
+              </a:rPr>
+              <a:t>A: 33.33%</a:t>
             </a:r>
           </a:p>
         </p:txBody>
@@ -5816,7 +6007,9 @@
           <a:lstStyle/>
           <a:p>
             <a:r>
-              <a:rPr lang="en-US"/>
+              <a:rPr lang="en-US">
+                <a:latin typeface="Arial Nova"/>
+              </a:rPr>
               <a:t>We continue to split until a small interval remains.</a:t>
             </a:r>
           </a:p>
@@ -5836,8 +6029,8 @@
         </p:nvSpPr>
         <p:spPr>
           <a:xfrm>
-            <a:off x="10563757" y="4066546"/>
-            <a:ext cx="594009" cy="369332"/>
+            <a:off x="10497497" y="4077589"/>
+            <a:ext cx="660269" cy="369332"/>
           </a:xfrm>
           <a:prstGeom prst="rect">
             <a:avLst/>
@@ -5855,8 +6048,10 @@
           <a:p>
             <a:pPr algn="l"/>
             <a:r>
-              <a:rPr lang="en-US"/>
-              <a:t>0.6</a:t>
+              <a:rPr lang="en-US">
+                <a:latin typeface="Arial Nova"/>
+              </a:rPr>
+              <a:t>0.67</a:t>
             </a:r>
           </a:p>
         </p:txBody>
@@ -5893,10 +6088,14 @@
           <a:lstStyle/>
           <a:p>
             <a:r>
-              <a:rPr lang="en-US"/>
-              <a:t>Interval: [0.36, 0.6)</a:t>
-            </a:r>
-            <a:endParaRPr lang="en-US" dirty="0"/>
+              <a:rPr lang="en-US">
+                <a:latin typeface="Arial Nova"/>
+              </a:rPr>
+              <a:t>Interval: [0.44, 0.67)</a:t>
+            </a:r>
+            <a:endParaRPr lang="en-US" dirty="0">
+              <a:latin typeface="Arial Nova"/>
+            </a:endParaRPr>
           </a:p>
         </p:txBody>
       </p:sp>
@@ -5933,8 +6132,10 @@
           <a:p>
             <a:pPr algn="l"/>
             <a:r>
-              <a:rPr lang="en-US"/>
-              <a:t>0.36</a:t>
+              <a:rPr lang="en-US">
+                <a:latin typeface="Arial Nova"/>
+              </a:rPr>
+              <a:t>0.44</a:t>
             </a:r>
           </a:p>
         </p:txBody>
@@ -6038,8 +6239,10 @@
           <a:p>
             <a:pPr algn="ctr"/>
             <a:r>
-              <a:rPr lang="en-US"/>
-              <a:t>A: 40%</a:t>
+              <a:rPr lang="en-US">
+                <a:latin typeface="Arial Nova"/>
+              </a:rPr>
+              <a:t>A: 33.3%</a:t>
             </a:r>
           </a:p>
         </p:txBody>
@@ -6112,7 +6315,9 @@
           <a:lstStyle/>
           <a:p>
             <a:r>
-              <a:rPr lang="en-US"/>
+              <a:rPr lang="en-US">
+                <a:latin typeface="Arial Nova"/>
+              </a:rPr>
               <a:t>We continue to split until a small interval remains.</a:t>
             </a:r>
           </a:p>
@@ -6132,8 +6337,8 @@
         </p:nvSpPr>
         <p:spPr>
           <a:xfrm>
-            <a:off x="10563757" y="4066546"/>
-            <a:ext cx="594009" cy="369332"/>
+            <a:off x="10541671" y="4066546"/>
+            <a:ext cx="660269" cy="369332"/>
           </a:xfrm>
           <a:prstGeom prst="rect">
             <a:avLst/>
@@ -6151,8 +6356,10 @@
           <a:p>
             <a:pPr algn="l"/>
             <a:r>
-              <a:rPr lang="en-US"/>
-              <a:t>0.6</a:t>
+              <a:rPr lang="en-US">
+                <a:latin typeface="Arial Nova"/>
+              </a:rPr>
+              <a:t>0.67</a:t>
             </a:r>
           </a:p>
         </p:txBody>
@@ -6189,10 +6396,14 @@
           <a:lstStyle/>
           <a:p>
             <a:r>
-              <a:rPr lang="en-US"/>
-              <a:t>Interval: [0.36, 0.6)</a:t>
-            </a:r>
-            <a:endParaRPr lang="en-US" dirty="0"/>
+              <a:rPr lang="en-US">
+                <a:latin typeface="Arial Nova"/>
+              </a:rPr>
+              <a:t>Interval: [0.44, 0.67)</a:t>
+            </a:r>
+            <a:endParaRPr lang="en-US" dirty="0">
+              <a:latin typeface="Arial Nova"/>
+            </a:endParaRPr>
           </a:p>
         </p:txBody>
       </p:sp>
@@ -6242,13 +6453,15 @@
           </a:fontRef>
         </p:style>
         <p:txBody>
-          <a:bodyPr rtlCol="0" anchor="ctr"/>
+          <a:bodyPr lIns="91440" tIns="45720" rIns="91440" bIns="45720" rtlCol="0" anchor="ctr"/>
           <a:lstStyle/>
           <a:p>
             <a:pPr algn="ctr"/>
             <a:r>
-              <a:rPr lang="en-US"/>
-              <a:t>D: 60%</a:t>
+              <a:rPr lang="en-US">
+                <a:latin typeface="Arial Nova"/>
+              </a:rPr>
+              <a:t>D: 66.67%</a:t>
             </a:r>
           </a:p>
         </p:txBody>
@@ -6286,8 +6499,10 @@
           <a:p>
             <a:pPr algn="l"/>
             <a:r>
-              <a:rPr lang="en-US"/>
-              <a:t>0.36</a:t>
+              <a:rPr lang="en-US">
+                <a:latin typeface="Arial Nova"/>
+              </a:rPr>
+              <a:t>0.44</a:t>
             </a:r>
           </a:p>
         </p:txBody>
@@ -6325,8 +6540,10 @@
           <a:p>
             <a:pPr algn="l"/>
             <a:r>
-              <a:rPr lang="en-US"/>
-              <a:t>0.504</a:t>
+              <a:rPr lang="en-US">
+                <a:latin typeface="Arial Nova"/>
+              </a:rPr>
+              <a:t>0.59</a:t>
             </a:r>
           </a:p>
         </p:txBody>
@@ -6435,12 +6652,16 @@
           <a:lstStyle/>
           <a:p>
             <a:r>
-              <a:rPr lang="en-US"/>
+              <a:rPr lang="en-US">
+                <a:latin typeface="Arial Nova"/>
+              </a:rPr>
               <a:t>Messages are encoded using a number inside the final interval.</a:t>
             </a:r>
           </a:p>
           <a:p>
-            <a:endParaRPr lang="en-US" dirty="0"/>
+            <a:endParaRPr lang="en-US" dirty="0">
+              <a:latin typeface="Arial Nova"/>
+            </a:endParaRPr>
           </a:p>
         </p:txBody>
       </p:sp>
@@ -6476,10 +6697,14 @@
           <a:lstStyle/>
           <a:p>
             <a:r>
-              <a:rPr lang="en-US"/>
-              <a:t>Interval: [0.36, 0.504)</a:t>
-            </a:r>
-            <a:endParaRPr lang="en-US" dirty="0"/>
+              <a:rPr lang="en-US">
+                <a:latin typeface="Arial Nova"/>
+              </a:rPr>
+              <a:t>Interval: [0.44, 0.59)</a:t>
+            </a:r>
+            <a:endParaRPr lang="en-US" dirty="0">
+              <a:latin typeface="Arial Nova"/>
+            </a:endParaRPr>
           </a:p>
         </p:txBody>
       </p:sp>
@@ -6529,13 +6754,15 @@
           </a:fontRef>
         </p:style>
         <p:txBody>
-          <a:bodyPr rtlCol="0" anchor="ctr"/>
+          <a:bodyPr lIns="91440" tIns="45720" rIns="91440" bIns="45720" rtlCol="0" anchor="ctr"/>
           <a:lstStyle/>
           <a:p>
             <a:pPr algn="ctr"/>
             <a:r>
-              <a:rPr lang="en-US"/>
-              <a:t>D: 60%</a:t>
+              <a:rPr lang="en-US">
+                <a:latin typeface="Arial Nova"/>
+              </a:rPr>
+              <a:t>D: 66.67%</a:t>
             </a:r>
           </a:p>
         </p:txBody>
@@ -6573,8 +6800,10 @@
           <a:p>
             <a:pPr algn="l"/>
             <a:r>
-              <a:rPr lang="en-US"/>
-              <a:t>0.36</a:t>
+              <a:rPr lang="en-US">
+                <a:latin typeface="Arial Nova"/>
+              </a:rPr>
+              <a:t>0.44</a:t>
             </a:r>
           </a:p>
         </p:txBody>
@@ -6593,7 +6822,7 @@
         </p:nvSpPr>
         <p:spPr>
           <a:xfrm>
-            <a:off x="10456530" y="4066517"/>
+            <a:off x="10500704" y="4066517"/>
             <a:ext cx="744954" cy="369332"/>
           </a:xfrm>
           <a:prstGeom prst="rect">
@@ -6612,8 +6841,10 @@
           <a:p>
             <a:pPr algn="l"/>
             <a:r>
-              <a:rPr lang="en-US"/>
-              <a:t>0.504</a:t>
+              <a:rPr lang="en-US">
+                <a:latin typeface="Arial Nova"/>
+              </a:rPr>
+              <a:t>0.59</a:t>
             </a:r>
           </a:p>
         </p:txBody>
@@ -6678,10 +6909,10 @@
         <a:srgbClr val="4EA72E"/>
       </a:accent6>
       <a:hlink>
-        <a:srgbClr val="467886"/>
+        <a:srgbClr val="538D9D"/>
       </a:hlink>
       <a:folHlink>
-        <a:srgbClr val="96607D"/>
+        <a:srgbClr val="A5738E"/>
       </a:folHlink>
     </a:clrScheme>
     <a:fontScheme name="Office Theme">
@@ -6952,7 +7183,7 @@
   <a:extraClrSchemeLst/>
   <a:extLst>
     <a:ext uri="{05A4C25C-085E-4340-85A3-A5531E510DB2}">
-      <thm15:themeFamily xmlns:thm15="http://schemas.microsoft.com/office/thememl/2012/main" name="Office Theme" id="{2E142A2C-CD16-42D6-873A-C26D2A0506FA}" vid="{1BDDFF52-6CD6-40A5-AB3C-68EB2F1E4D0A}"/>
+      <thm15:themeFamily xmlns:thm15="http://schemas.microsoft.com/office/thememl/2012/main" name="Office Theme" id="{2E142A2C-CD16-42D6-873A-C26D2A0506FA}" vid="{3A418E6B-C5F0-4B95-8D77-61E3EF3B5DF5}"/>
     </a:ext>
   </a:extLst>
 </a:theme>

</xml_diff>